<commit_message>
Restructure 8-min deck: pitch -> architecture/concepts -> demo -> code walkthrough -> close
</commit_message>
<xml_diff>
--- a/presentation/Omnichannel_8min.pptx
+++ b/presentation/Omnichannel_8min.pptx
@@ -10,8 +10,6 @@
     <p:sldId id="258" r:id="rId10"/>
     <p:sldId id="259" r:id="rId11"/>
     <p:sldId id="260" r:id="rId12"/>
-    <p:sldId id="261" r:id="rId13"/>
-    <p:sldId id="262" r:id="rId14"/>
   </p:sldIdLst>
   <p:sldSz cx="12191695" cy="6858000" type="screen4x3"/>
   <p:notesSz cx="6858000" cy="9144000"/>
@@ -508,7 +506,7 @@
           <a:lstStyle/>
           <a:p>
             <a:r>
-              <a:t>0:00–0:25. Lead with the 9-second pitch verbatim, then: 'In the next 8 minutes I'll show the problem, how it works, and a live demo.' Keep energy high; the demo is the star.</a:t>
+              <a:t>0:00–0:35. Say the 9-second pitch verbatim, then read the 4-part agenda in one line so they know the shape: pitch, architecture + concepts, demo, code walkthrough. Move fast.</a:t>
             </a:r>
           </a:p>
         </p:txBody>
@@ -578,7 +576,7 @@
           <a:lstStyle/>
           <a:p>
             <a:r>
-              <a:t>0:25–2:15. Frame the tension: fast AND trustworthy. Hit the two pains (speed + ungoverned AI) and land 'a confident wrong answer is a liability.' Then the one-line solution and the key idea: the answer is never just a number — it's a governed package with an owner action.</a:t>
+              <a:t>0:35–2:35 (~2 min). This is the 'architecture + concepts' segment. Walk the loop left-to-right ONCE, then point at the bracketed concept tags — that's you naming the program vocabulary out loud: governance/semantic layer, RAG, knowledge graph, multi-agent, Tree-of-Thoughts/beam, LLM grounding, responsible AI. The ONE principle to land: facts come from governed SQL over certified metrics; the LLM only phrases them. You'll prove each of these in the code walkthrough next.</a:t>
             </a:r>
           </a:p>
         </p:txBody>
@@ -648,7 +646,7 @@
           <a:lstStyle/>
           <a:p>
             <a:r>
-              <a:t>2:15–3:45. One architecture slide. Read the loop quickly, then stress the design principle: the LLM never invents facts — it only phrases proven ones. Name the concepts as you go (RAG, knowledge graph, multi-agent, beam search) so the committee hears the program vocabulary. Mention the free/local fallback so they know the demo is robust.</a:t>
+              <a:t>2:35–5:00 (~2.5 min). App already running and WARMED UP. (1) Run the conversion investigation; narrate the governed steps as the trace streams; land on Business answer → Evidence chart → owner actions + 🔴 human-review banner. (2) Type a write request → it refuses (fast, always lands). (3) Run one briefing. If time is tight, do #1 and #2 only. Keep a backup screenshot.</a:t>
             </a:r>
           </a:p>
         </p:txBody>
@@ -718,7 +716,7 @@
           <a:lstStyle/>
           <a:p>
             <a:r>
-              <a:t>3:45–4:45. This is what makes it a capstone, not a toy. Each line is an ENFORCED control, not a prompt. Emphasize causal humility (observational data → label likelihood) and human-in-the-loop + read-only = safe to deploy in a governed enterprise. Tease the guardrail demo.</a:t>
+              <a:t>5:00–7:30 (~2.5 min). Switch to your editor (VS Code). Open these SIX files in THIS order and say ONE sentence each (see the 'Code walkthrough — fast script' in CAPSTONE_SUBMISSION.md). Goal: show you understand the concepts, not read code line-by-line. The closer: in tot_skill.py point at ungoverned_branch() being pruned automatically — 'governance isn't a prompt, it's enforced.' If short on time, do metrics.yaml → sql_skill → graph.py → tot_skill (the 4 that best show understanding). Keep the files pre-opened as tabs so you don't fumble.</a:t>
             </a:r>
           </a:p>
         </p:txBody>
@@ -788,147 +786,7 @@
           <a:lstStyle/>
           <a:p>
             <a:r>
-              <a:t>4:45–7:45 (your centerpiece — keep it tight). App already running &amp; warmed up. (1) Run the conversion investigation; narrate the governed steps while the trace streams; land on Business answer → Evidence chart → owner actions + human-review banner. (2) Show the write refusal — fast, always lands. (3) Run ONE briefing to show cross-functional ranking. Have a backup screenshot. If short on time, do #1 and #2 only.</a:t>
-            </a:r>
-          </a:p>
-        </p:txBody>
-      </p:sp>
-      <p:sp>
-        <p:nvSpPr>
-          <p:cNvPr id="4" name="Slide Number Placeholder 3"/>
-          <p:cNvSpPr>
-            <a:spLocks noGrp="1"/>
-          </p:cNvSpPr>
-          <p:nvPr>
-            <p:ph type="sldNum" idx="5" sz="quarter"/>
-          </p:nvPr>
-        </p:nvSpPr>
-        <p:spPr/>
-      </p:sp>
-    </p:spTree>
-  </p:cSld>
-  <p:clrMapOvr>
-    <a:masterClrMapping/>
-  </p:clrMapOvr>
-</p:notes>
-</file>
-
-<file path=ppt/notesSlides/notesSlide6.xml><?xml version="1.0" encoding="utf-8"?>
-<p:notes xmlns:a="http://schemas.openxmlformats.org/drawingml/2006/main" xmlns:p="http://schemas.openxmlformats.org/presentationml/2006/main" xmlns:r="http://schemas.openxmlformats.org/officeDocument/2006/relationships">
-  <p:cSld>
-    <p:spTree>
-      <p:nvGrpSpPr>
-        <p:cNvPr id="1" name=""/>
-        <p:cNvGrpSpPr/>
-        <p:nvPr/>
-      </p:nvGrpSpPr>
-      <p:grpSpPr>
-        <a:xfrm>
-          <a:off x="0" y="0"/>
-          <a:ext cx="0" cy="0"/>
-          <a:chOff x="0" y="0"/>
-          <a:chExt cx="0" cy="0"/>
-        </a:xfrm>
-      </p:grpSpPr>
-      <p:sp>
-        <p:nvSpPr>
-          <p:cNvPr id="2" name="Slide Image Placeholder 1"/>
-          <p:cNvSpPr>
-            <a:spLocks noGrp="1"/>
-          </p:cNvSpPr>
-          <p:nvPr>
-            <p:ph type="sldImg" idx="2"/>
-          </p:nvPr>
-        </p:nvSpPr>
-        <p:spPr/>
-      </p:sp>
-      <p:sp>
-        <p:nvSpPr>
-          <p:cNvPr id="3" name="Notes Placeholder 2"/>
-          <p:cNvSpPr>
-            <a:spLocks noGrp="1"/>
-          </p:cNvSpPr>
-          <p:nvPr>
-            <p:ph type="body" idx="3" sz="quarter"/>
-          </p:nvPr>
-        </p:nvSpPr>
-        <p:spPr/>
-        <p:txBody>
-          <a:bodyPr/>
-          <a:lstStyle/>
-          <a:p>
-            <a:r>
-              <a:t>7:45–8:15 (overrun budget). Two evaluation layers: known ground truth + automated gates (data, guardrails, routing). Reproducibility from a fixed seed is itself a governance property. Keep this to ~20 seconds if the demo ran long.</a:t>
-            </a:r>
-          </a:p>
-        </p:txBody>
-      </p:sp>
-      <p:sp>
-        <p:nvSpPr>
-          <p:cNvPr id="4" name="Slide Number Placeholder 3"/>
-          <p:cNvSpPr>
-            <a:spLocks noGrp="1"/>
-          </p:cNvSpPr>
-          <p:nvPr>
-            <p:ph type="sldNum" idx="5" sz="quarter"/>
-          </p:nvPr>
-        </p:nvSpPr>
-        <p:spPr/>
-      </p:sp>
-    </p:spTree>
-  </p:cSld>
-  <p:clrMapOvr>
-    <a:masterClrMapping/>
-  </p:clrMapOvr>
-</p:notes>
-</file>
-
-<file path=ppt/notesSlides/notesSlide7.xml><?xml version="1.0" encoding="utf-8"?>
-<p:notes xmlns:a="http://schemas.openxmlformats.org/drawingml/2006/main" xmlns:p="http://schemas.openxmlformats.org/presentationml/2006/main" xmlns:r="http://schemas.openxmlformats.org/officeDocument/2006/relationships">
-  <p:cSld>
-    <p:spTree>
-      <p:nvGrpSpPr>
-        <p:cNvPr id="1" name=""/>
-        <p:cNvGrpSpPr/>
-        <p:nvPr/>
-      </p:nvGrpSpPr>
-      <p:grpSpPr>
-        <a:xfrm>
-          <a:off x="0" y="0"/>
-          <a:ext cx="0" cy="0"/>
-          <a:chOff x="0" y="0"/>
-          <a:chExt cx="0" cy="0"/>
-        </a:xfrm>
-      </p:grpSpPr>
-      <p:sp>
-        <p:nvSpPr>
-          <p:cNvPr id="2" name="Slide Image Placeholder 1"/>
-          <p:cNvSpPr>
-            <a:spLocks noGrp="1"/>
-          </p:cNvSpPr>
-          <p:nvPr>
-            <p:ph type="sldImg" idx="2"/>
-          </p:nvPr>
-        </p:nvSpPr>
-        <p:spPr/>
-      </p:sp>
-      <p:sp>
-        <p:nvSpPr>
-          <p:cNvPr id="3" name="Notes Placeholder 2"/>
-          <p:cNvSpPr>
-            <a:spLocks noGrp="1"/>
-          </p:cNvSpPr>
-          <p:nvPr>
-            <p:ph type="body" idx="3" sz="quarter"/>
-          </p:nvPr>
-        </p:nvSpPr>
-        <p:spPr/>
-        <p:txBody>
-          <a:bodyPr/>
-          <a:lstStyle/>
-          <a:p>
-            <a:r>
-              <a:t>8:15–8:30. Close on the opening promise (fast AND trustworthy) and the one-sentence lesson. Give the production path in one line to show it scales. Thank them and open Q&amp;A.</a:t>
+              <a:t>7:30–8:00. Tie back to the opening promise (fast AND trustworthy) and deliver the one-sentence lesson. Drop the evaluation numbers as proof in one breath. One line on the production path, then thank them and open Q&amp;A.</a:t>
             </a:r>
           </a:p>
         </p:txBody>
@@ -3986,7 +3844,7 @@
         </p:nvSpPr>
         <p:spPr>
           <a:xfrm>
-            <a:off x="0" y="2286000"/>
+            <a:off x="0" y="2148840"/>
             <a:ext cx="12191695" cy="91440"/>
           </a:xfrm>
           <a:prstGeom prst="rect">
@@ -4030,8 +3888,8 @@
         </p:nvSpPr>
         <p:spPr>
           <a:xfrm>
-            <a:off x="822960" y="1143000"/>
-            <a:ext cx="10515600" cy="1097280"/>
+            <a:off x="822960" y="1051560"/>
+            <a:ext cx="10515600" cy="1005840"/>
           </a:xfrm>
           <a:prstGeom prst="rect">
             <a:avLst/>
@@ -4050,7 +3908,7 @@
               </a:spcAft>
             </a:pPr>
             <a:r>
-              <a:rPr sz="4200" b="1" i="0">
+              <a:rPr sz="4000" b="1" i="0">
                 <a:solidFill>
                   <a:srgbClr val="FFFFFF"/>
                 </a:solidFill>
@@ -4069,8 +3927,8 @@
         </p:nvSpPr>
         <p:spPr>
           <a:xfrm>
-            <a:off x="822960" y="2514600"/>
-            <a:ext cx="10515600" cy="1463040"/>
+            <a:off x="822960" y="2377440"/>
+            <a:ext cx="10515600" cy="1371600"/>
           </a:xfrm>
           <a:prstGeom prst="rect">
             <a:avLst/>
@@ -4089,7 +3947,7 @@
               </a:spcAft>
             </a:pPr>
             <a:r>
-              <a:rPr sz="2200" b="0" i="0">
+              <a:rPr sz="2100" b="0" i="0">
                 <a:solidFill>
                   <a:srgbClr val="F1F5F9"/>
                 </a:solidFill>
@@ -4105,7 +3963,7 @@
               </a:spcAft>
             </a:pPr>
             <a:r>
-              <a:rPr sz="2200" b="0" i="0">
+              <a:rPr sz="2100" b="0" i="0">
                 <a:solidFill>
                   <a:srgbClr val="F1F5F9"/>
                 </a:solidFill>
@@ -4124,8 +3982,8 @@
         </p:nvSpPr>
         <p:spPr>
           <a:xfrm>
-            <a:off x="822960" y="5212080"/>
-            <a:ext cx="10515600" cy="1097280"/>
+            <a:off x="822960" y="4114800"/>
+            <a:ext cx="10515600" cy="1371600"/>
           </a:xfrm>
           <a:prstGeom prst="rect">
             <a:avLst/>
@@ -4144,9 +4002,48 @@
               </a:spcAft>
             </a:pPr>
             <a:r>
-              <a:rPr sz="1500" b="1" i="0">
+              <a:rPr sz="1600" b="1" i="0">
                 <a:solidFill>
                   <a:srgbClr val="FFFFFF"/>
+                </a:solidFill>
+                <a:latin typeface="Segoe UI"/>
+              </a:rPr>
+              <a:t>Today (8 min):  1) the pitch   2) architecture &amp; concepts   3) live demo   4) a quick code walkthrough</a:t>
+            </a:r>
+          </a:p>
+        </p:txBody>
+      </p:sp>
+      <p:sp>
+        <p:nvSpPr>
+          <p:cNvPr id="7" name="TextBox 6"/>
+          <p:cNvSpPr txBox="1"/>
+          <p:nvPr/>
+        </p:nvSpPr>
+        <p:spPr>
+          <a:xfrm>
+            <a:off x="822960" y="5943600"/>
+            <a:ext cx="10515600" cy="548640"/>
+          </a:xfrm>
+          <a:prstGeom prst="rect">
+            <a:avLst/>
+          </a:prstGeom>
+          <a:noFill/>
+        </p:spPr>
+        <p:txBody>
+          <a:bodyPr wrap="square">
+            <a:spAutoFit/>
+          </a:bodyPr>
+          <a:lstStyle/>
+          <a:p>
+            <a:pPr>
+              <a:spcAft>
+                <a:spcPts val="800"/>
+              </a:spcAft>
+            </a:pPr>
+            <a:r>
+              <a:rPr sz="1300" b="0" i="0">
+                <a:solidFill>
+                  <a:srgbClr val="94A3B8"/>
                 </a:solidFill>
                 <a:latin typeface="Segoe UI"/>
               </a:rPr>
@@ -4251,7 +4148,7 @@
                 </a:solidFill>
                 <a:latin typeface="Segoe UI"/>
               </a:rPr>
-              <a:t>PROBLEM → SOLUTION</a:t>
+              <a:t>PART 2 · ARCHITECTURE &amp; THE CONCEPTS I USED</a:t>
             </a:r>
           </a:p>
         </p:txBody>
@@ -4284,13 +4181,13 @@
               </a:spcAft>
             </a:pPr>
             <a:r>
-              <a:rPr sz="3000" b="1" i="0">
+              <a:rPr sz="2900" b="1" i="0">
                 <a:solidFill>
                   <a:srgbClr val="1E293B"/>
                 </a:solidFill>
                 <a:latin typeface="Segoe UI"/>
               </a:rPr>
-              <a:t>Fast answers and trustworthy answers — usually you pick one</a:t>
+              <a:t>Governed knowledge + a multi-agent reasoning loop</a:t>
             </a:r>
           </a:p>
         </p:txBody>
@@ -4303,7 +4200,7 @@
         </p:nvSpPr>
         <p:spPr>
           <a:xfrm>
-            <a:off x="640080" y="1783080"/>
+            <a:off x="640080" y="1737360"/>
             <a:ext cx="10881360" cy="4480560"/>
           </a:xfrm>
           <a:prstGeom prst="rect">
@@ -4319,81 +4216,97 @@
           <a:p>
             <a:pPr>
               <a:spcAft>
-                <a:spcPts val="1000"/>
+                <a:spcPts val="900"/>
               </a:spcAft>
             </a:pPr>
             <a:r>
-              <a:rPr sz="1900" b="0" i="0">
+              <a:rPr sz="1800" b="0" i="0">
                 <a:solidFill>
                   <a:srgbClr val="1E293B"/>
                 </a:solidFill>
                 <a:latin typeface="Segoe UI"/>
               </a:rPr>
-              <a:t>•  When a KPI moves, the 'why' spans many teams — marketing, merchandising, fulfillment, service, finance. Today that's a multi-day, multi-team fire drill.</a:t>
+              <a:t>•  Source of truth — a versioned, hashed YAML catalog of certified metrics, approved tables, drivers, and guardrails.   [data governance / semantic layer]</a:t>
             </a:r>
           </a:p>
           <a:p>
             <a:pPr>
               <a:spcAft>
-                <a:spcPts val="1000"/>
+                <a:spcPts val="900"/>
               </a:spcAft>
             </a:pPr>
             <a:r>
-              <a:rPr sz="1900" b="0" i="0">
+              <a:rPr sz="1800" b="0" i="0">
                 <a:solidFill>
                   <a:srgbClr val="1E293B"/>
                 </a:solidFill>
                 <a:latin typeface="Segoe UI"/>
               </a:rPr>
-              <a:t>•  Generic 'chat-with-your-data' AI is fast but ungoverned: it invents metric definitions, runs arbitrary queries, and asserts causation. A confident wrong answer is a liability.</a:t>
+              <a:t>•  The loop (LangGraph state machine):   classify → retrieve → validate → relate → baseline → dispatch team → critic + beam → human review → answer.   [agent orchestration / ReAct]</a:t>
             </a:r>
           </a:p>
           <a:p>
             <a:pPr>
               <a:spcAft>
-                <a:spcPts val="1000"/>
+                <a:spcPts val="900"/>
               </a:spcAft>
             </a:pPr>
             <a:r>
-              <a:rPr sz="1900" b="1" i="0">
+              <a:rPr sz="1800" b="0" i="0">
                 <a:solidFill>
                   <a:srgbClr val="1E293B"/>
                 </a:solidFill>
                 <a:latin typeface="Segoe UI"/>
               </a:rPr>
-              <a:t>•  My solution: a governed multi-agent analyst. Ask in plain English → it retrieves CERTIFIED definitions, runs read-only queries, reasons across domains, and returns:</a:t>
-            </a:r>
-          </a:p>
-          <a:p>
-            <a:pPr lvl="1">
+              <a:t>•  retrieve = RAG over a ChromaDB vector index;  relate = a NetworkX knowledge graph (metric → driver → table → owner).   [RAG + embeddings · knowledge graph]</a:t>
+            </a:r>
+          </a:p>
+          <a:p>
+            <a:pPr>
               <a:spcAft>
-                <a:spcPts val="500"/>
+                <a:spcPts val="900"/>
               </a:spcAft>
             </a:pPr>
             <a:r>
-              <a:rPr sz="1600" b="0" i="0">
-                <a:solidFill>
-                  <a:srgbClr val="475569"/>
-                </a:solidFill>
-                <a:latin typeface="Segoe UI"/>
-              </a:rPr>
-              <a:t>–  answer + evidence + the definition used + confidence + caveats + an owner-routed action.</a:t>
-            </a:r>
-          </a:p>
-          <a:p>
-            <a:pPr>
-              <a:spcAft>
-                <a:spcPts val="1000"/>
-              </a:spcAft>
-            </a:pPr>
-            <a:r>
-              <a:rPr sz="1900" b="0" i="0">
+              <a:rPr sz="1800" b="0" i="0">
                 <a:solidFill>
                   <a:srgbClr val="1E293B"/>
                 </a:solidFill>
                 <a:latin typeface="Segoe UI"/>
               </a:rPr>
-              <a:t>•  100% free and local — synthetic data, local models, nothing leaves the laptop.</a:t>
+              <a:t>•  dispatch = 7 specialized analysts run in parallel;  the Critic scores each on a 0–14 rubric and beam search keeps the strongest.   [multi-agent systems · Tree-of-Thoughts + beam]</a:t>
+            </a:r>
+          </a:p>
+          <a:p>
+            <a:pPr>
+              <a:spcAft>
+                <a:spcPts val="900"/>
+              </a:spcAft>
+            </a:pPr>
+            <a:r>
+              <a:rPr sz="1800" b="1" i="0">
+                <a:solidFill>
+                  <a:srgbClr val="1E293B"/>
+                </a:solidFill>
+                <a:latin typeface="Segoe UI"/>
+              </a:rPr>
+              <a:t>•  The LLM only DRAFTS the prose — every number comes from governed SQL.   [LLM grounding]</a:t>
+            </a:r>
+          </a:p>
+          <a:p>
+            <a:pPr>
+              <a:spcAft>
+                <a:spcPts val="900"/>
+              </a:spcAft>
+            </a:pPr>
+            <a:r>
+              <a:rPr sz="1800" b="0" i="0">
+                <a:solidFill>
+                  <a:srgbClr val="1E293B"/>
+                </a:solidFill>
+                <a:latin typeface="Segoe UI"/>
+              </a:rPr>
+              <a:t>•  Read-only · causality labeled (not asserted) · human-in-the-loop · full audit trail.   [responsible AI / governance]</a:t>
             </a:r>
           </a:p>
         </p:txBody>
@@ -4485,6 +4398,300 @@
 </file>
 
 <file path=ppt/slides/slide3.xml><?xml version="1.0" encoding="utf-8"?>
+<p:sld xmlns:a="http://schemas.openxmlformats.org/drawingml/2006/main" xmlns:p="http://schemas.openxmlformats.org/presentationml/2006/main" xmlns:r="http://schemas.openxmlformats.org/officeDocument/2006/relationships">
+  <p:cSld>
+    <p:spTree>
+      <p:nvGrpSpPr>
+        <p:cNvPr id="1" name=""/>
+        <p:cNvGrpSpPr/>
+        <p:nvPr/>
+      </p:nvGrpSpPr>
+      <p:grpSpPr/>
+      <p:sp>
+        <p:nvSpPr>
+          <p:cNvPr id="2" name="Rectangle 1"/>
+          <p:cNvSpPr/>
+          <p:nvPr/>
+        </p:nvSpPr>
+        <p:spPr>
+          <a:xfrm>
+            <a:off x="0" y="0"/>
+            <a:ext cx="12191695" cy="6858000"/>
+          </a:xfrm>
+          <a:prstGeom prst="rect">
+            <a:avLst/>
+          </a:prstGeom>
+          <a:solidFill>
+            <a:srgbClr val="1E293B"/>
+          </a:solidFill>
+          <a:ln>
+            <a:noFill/>
+          </a:ln>
+          <a:effectLst/>
+        </p:spPr>
+        <p:style>
+          <a:lnRef idx="1">
+            <a:schemeClr val="accent1"/>
+          </a:lnRef>
+          <a:fillRef idx="3">
+            <a:schemeClr val="accent1"/>
+          </a:fillRef>
+          <a:effectRef idx="2">
+            <a:schemeClr val="accent1"/>
+          </a:effectRef>
+          <a:fontRef idx="minor">
+            <a:schemeClr val="lt1"/>
+          </a:fontRef>
+        </p:style>
+        <p:txBody>
+          <a:bodyPr rtlCol="0" anchor="ctr"/>
+          <a:lstStyle/>
+          <a:p>
+            <a:pPr algn="ctr"/>
+          </a:p>
+        </p:txBody>
+      </p:sp>
+      <p:sp>
+        <p:nvSpPr>
+          <p:cNvPr id="3" name="Rectangle 2"/>
+          <p:cNvSpPr/>
+          <p:nvPr/>
+        </p:nvSpPr>
+        <p:spPr>
+          <a:xfrm>
+            <a:off x="0" y="2331720"/>
+            <a:ext cx="12191695" cy="91440"/>
+          </a:xfrm>
+          <a:prstGeom prst="rect">
+            <a:avLst/>
+          </a:prstGeom>
+          <a:solidFill>
+            <a:srgbClr val="C41230"/>
+          </a:solidFill>
+          <a:ln>
+            <a:noFill/>
+          </a:ln>
+          <a:effectLst/>
+        </p:spPr>
+        <p:style>
+          <a:lnRef idx="1">
+            <a:schemeClr val="accent1"/>
+          </a:lnRef>
+          <a:fillRef idx="3">
+            <a:schemeClr val="accent1"/>
+          </a:fillRef>
+          <a:effectRef idx="2">
+            <a:schemeClr val="accent1"/>
+          </a:effectRef>
+          <a:fontRef idx="minor">
+            <a:schemeClr val="lt1"/>
+          </a:fontRef>
+        </p:style>
+        <p:txBody>
+          <a:bodyPr rtlCol="0" anchor="ctr"/>
+          <a:lstStyle/>
+          <a:p>
+            <a:pPr algn="ctr"/>
+          </a:p>
+        </p:txBody>
+      </p:sp>
+      <p:sp>
+        <p:nvSpPr>
+          <p:cNvPr id="4" name="TextBox 3"/>
+          <p:cNvSpPr txBox="1"/>
+          <p:nvPr/>
+        </p:nvSpPr>
+        <p:spPr>
+          <a:xfrm>
+            <a:off x="822960" y="1463040"/>
+            <a:ext cx="10515600" cy="457200"/>
+          </a:xfrm>
+          <a:prstGeom prst="rect">
+            <a:avLst/>
+          </a:prstGeom>
+          <a:noFill/>
+        </p:spPr>
+        <p:txBody>
+          <a:bodyPr wrap="square">
+            <a:spAutoFit/>
+          </a:bodyPr>
+          <a:lstStyle/>
+          <a:p>
+            <a:pPr>
+              <a:spcAft>
+                <a:spcPts val="800"/>
+              </a:spcAft>
+            </a:pPr>
+            <a:r>
+              <a:rPr sz="1700" b="1" i="0">
+                <a:solidFill>
+                  <a:srgbClr val="F87171"/>
+                </a:solidFill>
+                <a:latin typeface="Segoe UI"/>
+              </a:rPr>
+              <a:t>PART 3 · LIVE DEMO (~2.5 MIN)</a:t>
+            </a:r>
+          </a:p>
+        </p:txBody>
+      </p:sp>
+      <p:sp>
+        <p:nvSpPr>
+          <p:cNvPr id="5" name="TextBox 4"/>
+          <p:cNvSpPr txBox="1"/>
+          <p:nvPr/>
+        </p:nvSpPr>
+        <p:spPr>
+          <a:xfrm>
+            <a:off x="822960" y="2423160"/>
+            <a:ext cx="10515600" cy="914400"/>
+          </a:xfrm>
+          <a:prstGeom prst="rect">
+            <a:avLst/>
+          </a:prstGeom>
+          <a:noFill/>
+        </p:spPr>
+        <p:txBody>
+          <a:bodyPr wrap="square">
+            <a:spAutoFit/>
+          </a:bodyPr>
+          <a:lstStyle/>
+          <a:p>
+            <a:pPr>
+              <a:spcAft>
+                <a:spcPts val="800"/>
+              </a:spcAft>
+            </a:pPr>
+            <a:r>
+              <a:rPr sz="3200" b="1" i="0">
+                <a:solidFill>
+                  <a:srgbClr val="FFFFFF"/>
+                </a:solidFill>
+                <a:latin typeface="Segoe UI"/>
+              </a:rPr>
+              <a:t>Seeing it run on a seeded 'bad day'</a:t>
+            </a:r>
+          </a:p>
+        </p:txBody>
+      </p:sp>
+      <p:sp>
+        <p:nvSpPr>
+          <p:cNvPr id="6" name="TextBox 5"/>
+          <p:cNvSpPr txBox="1"/>
+          <p:nvPr/>
+        </p:nvSpPr>
+        <p:spPr>
+          <a:xfrm>
+            <a:off x="822960" y="3566160"/>
+            <a:ext cx="10515600" cy="2560320"/>
+          </a:xfrm>
+          <a:prstGeom prst="rect">
+            <a:avLst/>
+          </a:prstGeom>
+          <a:noFill/>
+        </p:spPr>
+        <p:txBody>
+          <a:bodyPr wrap="square">
+            <a:spAutoFit/>
+          </a:bodyPr>
+          <a:lstStyle/>
+          <a:p>
+            <a:pPr>
+              <a:spcAft>
+                <a:spcPts val="800"/>
+              </a:spcAft>
+            </a:pPr>
+            <a:r>
+              <a:rPr sz="1600" b="0" i="0">
+                <a:solidFill>
+                  <a:srgbClr val="F1F5F9"/>
+                </a:solidFill>
+                <a:latin typeface="Segoe UI"/>
+              </a:rPr>
+              <a:t>1.  'Why did conversion drop yesterday?' → team dispatch + live trace → drivers &amp; evidence chart → owner actions + the human-review banner.</a:t>
+            </a:r>
+          </a:p>
+          <a:p>
+            <a:pPr>
+              <a:spcAft>
+                <a:spcPts val="800"/>
+              </a:spcAft>
+            </a:pPr>
+            <a:r>
+              <a:rPr sz="1600" b="0" i="0">
+                <a:solidFill>
+                  <a:srgbClr val="F1F5F9"/>
+                </a:solidFill>
+                <a:latin typeface="Segoe UI"/>
+              </a:rPr>
+              <a:t>2.  'Update the paid-social budget' → the read-only guardrail refuses.</a:t>
+            </a:r>
+          </a:p>
+          <a:p>
+            <a:pPr>
+              <a:spcAft>
+                <a:spcPts val="800"/>
+              </a:spcAft>
+            </a:pPr>
+            <a:r>
+              <a:rPr sz="1600" b="0" i="0">
+                <a:solidFill>
+                  <a:srgbClr val="F1F5F9"/>
+                </a:solidFill>
+                <a:latin typeface="Segoe UI"/>
+              </a:rPr>
+              <a:t>3.  An executive briefing → the multi-agent path ranks the biggest cross-functional issues.</a:t>
+            </a:r>
+          </a:p>
+        </p:txBody>
+      </p:sp>
+      <p:sp>
+        <p:nvSpPr>
+          <p:cNvPr id="7" name="TextBox 6"/>
+          <p:cNvSpPr txBox="1"/>
+          <p:nvPr/>
+        </p:nvSpPr>
+        <p:spPr>
+          <a:xfrm>
+            <a:off x="11430000" y="6400800"/>
+            <a:ext cx="548640" cy="365760"/>
+          </a:xfrm>
+          <a:prstGeom prst="rect">
+            <a:avLst/>
+          </a:prstGeom>
+          <a:noFill/>
+        </p:spPr>
+        <p:txBody>
+          <a:bodyPr wrap="square">
+            <a:spAutoFit/>
+          </a:bodyPr>
+          <a:lstStyle/>
+          <a:p>
+            <a:pPr>
+              <a:spcAft>
+                <a:spcPts val="800"/>
+              </a:spcAft>
+            </a:pPr>
+            <a:r>
+              <a:rPr sz="1100" b="1" i="0">
+                <a:solidFill>
+                  <a:srgbClr val="94A3B8"/>
+                </a:solidFill>
+                <a:latin typeface="Segoe UI"/>
+              </a:rPr>
+              <a:t>3</a:t>
+            </a:r>
+          </a:p>
+        </p:txBody>
+      </p:sp>
+    </p:spTree>
+  </p:cSld>
+  <p:clrMapOvr>
+    <a:masterClrMapping/>
+  </p:clrMapOvr>
+</p:sld>
+</file>
+
+<file path=ppt/slides/slide4.xml><?xml version="1.0" encoding="utf-8"?>
 <p:sld xmlns:a="http://schemas.openxmlformats.org/drawingml/2006/main" xmlns:p="http://schemas.openxmlformats.org/presentationml/2006/main" xmlns:r="http://schemas.openxmlformats.org/officeDocument/2006/relationships">
   <p:cSld>
     <p:spTree>
@@ -4572,7 +4779,7 @@
                 </a:solidFill>
                 <a:latin typeface="Segoe UI"/>
               </a:rPr>
-              <a:t>HOW IT WORKS</a:t>
+              <a:t>PART 4 · QUICK CODE WALKTHROUGH</a:t>
             </a:r>
           </a:p>
         </p:txBody>
@@ -4605,13 +4812,13 @@
               </a:spcAft>
             </a:pPr>
             <a:r>
-              <a:rPr sz="3000" b="1" i="0">
+              <a:rPr sz="2900" b="1" i="0">
                 <a:solidFill>
                   <a:srgbClr val="1E293B"/>
                 </a:solidFill>
                 <a:latin typeface="Segoe UI"/>
               </a:rPr>
-              <a:t>Governed knowledge + a multi-agent reasoning loop</a:t>
+              <a:t>Six files — each is one concept, end to end</a:t>
             </a:r>
           </a:p>
         </p:txBody>
@@ -4624,7 +4831,7 @@
         </p:nvSpPr>
         <p:spPr>
           <a:xfrm>
-            <a:off x="640080" y="1783080"/>
+            <a:off x="640080" y="1737360"/>
             <a:ext cx="10881360" cy="4480560"/>
           </a:xfrm>
           <a:prstGeom prst="rect">
@@ -4640,49 +4847,97 @@
           <a:p>
             <a:pPr>
               <a:spcAft>
-                <a:spcPts val="1000"/>
+                <a:spcPts val="900"/>
               </a:spcAft>
             </a:pPr>
             <a:r>
-              <a:rPr sz="1900" b="0" i="0">
+              <a:rPr sz="1800" b="0" i="0">
                 <a:solidFill>
                   <a:srgbClr val="1E293B"/>
                 </a:solidFill>
                 <a:latin typeface="Segoe UI"/>
               </a:rPr>
-              <a:t>•  Source of truth: a versioned YAML catalog of certified metrics, approved tables, drivers, and guardrails — queried read-only over 18 tables in DuckDB.</a:t>
+              <a:t>•  catalog/metrics.yaml — the certified definitions everything resolves to.   [governance / source of truth]</a:t>
             </a:r>
           </a:p>
           <a:p>
             <a:pPr>
               <a:spcAft>
-                <a:spcPts val="1000"/>
+                <a:spcPts val="900"/>
               </a:spcAft>
             </a:pPr>
             <a:r>
-              <a:rPr sz="1900" b="0" i="0">
+              <a:rPr sz="1800" b="0" i="0">
                 <a:solidFill>
                   <a:srgbClr val="1E293B"/>
                 </a:solidFill>
                 <a:latin typeface="Segoe UI"/>
               </a:rPr>
-              <a:t>•  A LangGraph workflow runs the loop: classify → retrieve (RAG/ChromaDB) → validate (YAML) → relate (NetworkX graph) → dispatch a 7-analyst team in parallel → Critic scores each on a 0–14 rubric → beam search keeps the strongest → human review → answer.</a:t>
+              <a:t>•  skills/sql_skill.py · check_sql() — only read-only SELECTs over approved tables run.   [guardrails]</a:t>
             </a:r>
           </a:p>
           <a:p>
             <a:pPr>
               <a:spcAft>
-                <a:spcPts val="1000"/>
+                <a:spcPts val="900"/>
               </a:spcAft>
             </a:pPr>
             <a:r>
-              <a:rPr sz="1900" b="1" i="0">
+              <a:rPr sz="1800" b="0" i="0">
                 <a:solidFill>
                   <a:srgbClr val="1E293B"/>
                 </a:solidFill>
                 <a:latin typeface="Segoe UI"/>
               </a:rPr>
-              <a:t>•  The LLM is on a short leash — it only DRAFTS the prose; every number comes from governed SQL. No model running? A deterministic fallback writes it, so the demo can't break.</a:t>
+              <a:t>•  skills/retrieval_skill.py · retrieve() — top-k vector lookup + a staleness/sync gate.   [RAG]</a:t>
+            </a:r>
+          </a:p>
+          <a:p>
+            <a:pPr>
+              <a:spcAft>
+                <a:spcPts val="900"/>
+              </a:spcAft>
+            </a:pPr>
+            <a:r>
+              <a:rPr sz="1800" b="0" i="0">
+                <a:solidFill>
+                  <a:srgbClr val="1E293B"/>
+                </a:solidFill>
+                <a:latin typeface="Segoe UI"/>
+              </a:rPr>
+              <a:t>•  workflows/graph.py · build_workflow() + classify_intent() — the LangGraph loop &amp; routing.   [orchestration]</a:t>
+            </a:r>
+          </a:p>
+          <a:p>
+            <a:pPr>
+              <a:spcAft>
+                <a:spcPts val="900"/>
+              </a:spcAft>
+            </a:pPr>
+            <a:r>
+              <a:rPr sz="1800" b="0" i="0">
+                <a:solidFill>
+                  <a:srgbClr val="1E293B"/>
+                </a:solidFill>
+                <a:latin typeface="Segoe UI"/>
+              </a:rPr>
+              <a:t>•  agents/team.py · dispatch() — 7 analysts in parallel; a failure is isolated.   [multi-agent]</a:t>
+            </a:r>
+          </a:p>
+          <a:p>
+            <a:pPr>
+              <a:spcAft>
+                <a:spcPts val="900"/>
+              </a:spcAft>
+            </a:pPr>
+            <a:r>
+              <a:rPr sz="1800" b="0" i="0">
+                <a:solidFill>
+                  <a:srgbClr val="1E293B"/>
+                </a:solidFill>
+                <a:latin typeface="Segoe UI"/>
+              </a:rPr>
+              <a:t>•  skills/tot_skill.py · score_branch() + ungoverned_branch() — the 0–14 rubric prunes the ungoverned 'maybe prices rose' idea automatically.   [ToT/beam + responsible AI]</a:t>
             </a:r>
           </a:p>
         </p:txBody>
@@ -4760,7 +5015,7 @@
                 </a:solidFill>
                 <a:latin typeface="Segoe UI"/>
               </a:rPr>
-              <a:t>3</a:t>
+              <a:t>4</a:t>
             </a:r>
           </a:p>
         </p:txBody>
@@ -4773,7 +5028,7 @@
 </p:sld>
 </file>
 
-<file path=ppt/slides/slide4.xml><?xml version="1.0" encoding="utf-8"?>
+<file path=ppt/slides/slide5.xml><?xml version="1.0" encoding="utf-8"?>
 <p:sld xmlns:a="http://schemas.openxmlformats.org/drawingml/2006/main" xmlns:p="http://schemas.openxmlformats.org/presentationml/2006/main" xmlns:r="http://schemas.openxmlformats.org/officeDocument/2006/relationships">
   <p:cSld>
     <p:spTree>
@@ -4861,7 +5116,7 @@
                 </a:solidFill>
                 <a:latin typeface="Segoe UI"/>
               </a:rPr>
-              <a:t>WHY IT'S TRUSTWORTHY</a:t>
+              <a:t>CLOSE</a:t>
             </a:r>
           </a:p>
         </p:txBody>
@@ -4894,13 +5149,13 @@
               </a:spcAft>
             </a:pPr>
             <a:r>
-              <a:rPr sz="3000" b="1" i="0">
+              <a:rPr sz="2900" b="1" i="0">
                 <a:solidFill>
                   <a:srgbClr val="1E293B"/>
                 </a:solidFill>
                 <a:latin typeface="Segoe UI"/>
               </a:rPr>
-              <a:t>Governance enforced in code — the differentiator</a:t>
+              <a:t>From a 2-day fire drill to a governed answer in seconds</a:t>
             </a:r>
           </a:p>
         </p:txBody>
@@ -4913,7 +5168,7 @@
         </p:nvSpPr>
         <p:spPr>
           <a:xfrm>
-            <a:off x="640080" y="1783080"/>
+            <a:off x="640080" y="1737360"/>
             <a:ext cx="10881360" cy="4480560"/>
           </a:xfrm>
           <a:prstGeom prst="rect">
@@ -4929,81 +5184,65 @@
           <a:p>
             <a:pPr>
               <a:spcAft>
-                <a:spcPts val="1000"/>
+                <a:spcPts val="900"/>
               </a:spcAft>
             </a:pPr>
             <a:r>
-              <a:rPr sz="1900" b="0" i="0">
+              <a:rPr sz="1800" b="0" i="0">
                 <a:solidFill>
                   <a:srgbClr val="1E293B"/>
                 </a:solidFill>
                 <a:latin typeface="Segoe UI"/>
               </a:rPr>
-              <a:t>•  Read-only guardrail: a SQL validator allows only SELECT over APPROVED tables; any write is blocked before it runs. (I'll show it refuse a write.)</a:t>
+              <a:t>•  Fast AND trustworthy — the tension I opened with, resolved.</a:t>
             </a:r>
           </a:p>
           <a:p>
             <a:pPr>
               <a:spcAft>
-                <a:spcPts val="1000"/>
+                <a:spcPts val="900"/>
               </a:spcAft>
             </a:pPr>
             <a:r>
-              <a:rPr sz="1900" b="0" i="0">
+              <a:rPr sz="1800" b="1" i="0">
                 <a:solidFill>
                   <a:srgbClr val="1E293B"/>
                 </a:solidFill>
                 <a:latin typeface="Segoe UI"/>
               </a:rPr>
-              <a:t>•  Certified definitions only — metrics resolve from the versioned, hashed catalog, never invented.</a:t>
+              <a:t>•  The lesson: the hard part of agentic AI isn't generating answers — it's governing, evaluating, and observing them.</a:t>
             </a:r>
           </a:p>
           <a:p>
             <a:pPr>
               <a:spcAft>
-                <a:spcPts val="1000"/>
+                <a:spcPts val="900"/>
               </a:spcAft>
             </a:pPr>
             <a:r>
-              <a:rPr sz="1900" b="1" i="0">
+              <a:rPr sz="1800" b="0" i="0">
                 <a:solidFill>
                   <a:srgbClr val="1E293B"/>
                 </a:solidFill>
                 <a:latin typeface="Segoe UI"/>
               </a:rPr>
-              <a:t>•  Causality is LABELED, not asserted — 'likely driver' / 'possible contributor', never 'caused'.</a:t>
+              <a:t>•  Proven &amp; reproducible: seeded ground truth, 15 validation checks, 25 tests, 0 UI exceptions — and 100% free/local.</a:t>
             </a:r>
           </a:p>
           <a:p>
             <a:pPr>
               <a:spcAft>
-                <a:spcPts val="1000"/>
+                <a:spcPts val="900"/>
               </a:spcAft>
             </a:pPr>
             <a:r>
-              <a:rPr sz="1900" b="0" i="0">
+              <a:rPr sz="1800" b="0" i="0">
                 <a:solidFill>
                   <a:srgbClr val="1E293B"/>
                 </a:solidFill>
                 <a:latin typeface="Segoe UI"/>
               </a:rPr>
-              <a:t>•  Human-in-the-loop — every recommendation routes to an owner; no system is changed automatically.</a:t>
-            </a:r>
-          </a:p>
-          <a:p>
-            <a:pPr>
-              <a:spcAft>
-                <a:spcPts val="1000"/>
-              </a:spcAft>
-            </a:pPr>
-            <a:r>
-              <a:rPr sz="1900" b="0" i="0">
-                <a:solidFill>
-                  <a:srgbClr val="1E293B"/>
-                </a:solidFill>
-                <a:latin typeface="Segoe UI"/>
-              </a:rPr>
-              <a:t>•  Full audit trail + version/hash on every answer — reproducible and inspectable.</a:t>
+              <a:t>•  Extends to production: swap synthetic data for real tables behind the same catalog. Thank you — questions?</a:t>
             </a:r>
           </a:p>
         </p:txBody>
@@ -5081,856 +5320,7 @@
                 </a:solidFill>
                 <a:latin typeface="Segoe UI"/>
               </a:rPr>
-              <a:t>4</a:t>
-            </a:r>
-          </a:p>
-        </p:txBody>
-      </p:sp>
-    </p:spTree>
-  </p:cSld>
-  <p:clrMapOvr>
-    <a:masterClrMapping/>
-  </p:clrMapOvr>
-</p:sld>
-</file>
-
-<file path=ppt/slides/slide5.xml><?xml version="1.0" encoding="utf-8"?>
-<p:sld xmlns:a="http://schemas.openxmlformats.org/drawingml/2006/main" xmlns:p="http://schemas.openxmlformats.org/presentationml/2006/main" xmlns:r="http://schemas.openxmlformats.org/officeDocument/2006/relationships">
-  <p:cSld>
-    <p:spTree>
-      <p:nvGrpSpPr>
-        <p:cNvPr id="1" name=""/>
-        <p:cNvGrpSpPr/>
-        <p:nvPr/>
-      </p:nvGrpSpPr>
-      <p:grpSpPr/>
-      <p:sp>
-        <p:nvSpPr>
-          <p:cNvPr id="2" name="Rectangle 1"/>
-          <p:cNvSpPr/>
-          <p:nvPr/>
-        </p:nvSpPr>
-        <p:spPr>
-          <a:xfrm>
-            <a:off x="0" y="0"/>
-            <a:ext cx="12191695" cy="6858000"/>
-          </a:xfrm>
-          <a:prstGeom prst="rect">
-            <a:avLst/>
-          </a:prstGeom>
-          <a:solidFill>
-            <a:srgbClr val="1E293B"/>
-          </a:solidFill>
-          <a:ln>
-            <a:noFill/>
-          </a:ln>
-          <a:effectLst/>
-        </p:spPr>
-        <p:style>
-          <a:lnRef idx="1">
-            <a:schemeClr val="accent1"/>
-          </a:lnRef>
-          <a:fillRef idx="3">
-            <a:schemeClr val="accent1"/>
-          </a:fillRef>
-          <a:effectRef idx="2">
-            <a:schemeClr val="accent1"/>
-          </a:effectRef>
-          <a:fontRef idx="minor">
-            <a:schemeClr val="lt1"/>
-          </a:fontRef>
-        </p:style>
-        <p:txBody>
-          <a:bodyPr rtlCol="0" anchor="ctr"/>
-          <a:lstStyle/>
-          <a:p>
-            <a:pPr algn="ctr"/>
-          </a:p>
-        </p:txBody>
-      </p:sp>
-      <p:sp>
-        <p:nvSpPr>
-          <p:cNvPr id="3" name="Rectangle 2"/>
-          <p:cNvSpPr/>
-          <p:nvPr/>
-        </p:nvSpPr>
-        <p:spPr>
-          <a:xfrm>
-            <a:off x="0" y="2468880"/>
-            <a:ext cx="12191695" cy="91440"/>
-          </a:xfrm>
-          <a:prstGeom prst="rect">
-            <a:avLst/>
-          </a:prstGeom>
-          <a:solidFill>
-            <a:srgbClr val="C41230"/>
-          </a:solidFill>
-          <a:ln>
-            <a:noFill/>
-          </a:ln>
-          <a:effectLst/>
-        </p:spPr>
-        <p:style>
-          <a:lnRef idx="1">
-            <a:schemeClr val="accent1"/>
-          </a:lnRef>
-          <a:fillRef idx="3">
-            <a:schemeClr val="accent1"/>
-          </a:fillRef>
-          <a:effectRef idx="2">
-            <a:schemeClr val="accent1"/>
-          </a:effectRef>
-          <a:fontRef idx="minor">
-            <a:schemeClr val="lt1"/>
-          </a:fontRef>
-        </p:style>
-        <p:txBody>
-          <a:bodyPr rtlCol="0" anchor="ctr"/>
-          <a:lstStyle/>
-          <a:p>
-            <a:pPr algn="ctr"/>
-          </a:p>
-        </p:txBody>
-      </p:sp>
-      <p:sp>
-        <p:nvSpPr>
-          <p:cNvPr id="4" name="TextBox 3"/>
-          <p:cNvSpPr txBox="1"/>
-          <p:nvPr/>
-        </p:nvSpPr>
-        <p:spPr>
-          <a:xfrm>
-            <a:off x="822960" y="1828800"/>
-            <a:ext cx="10515600" cy="457200"/>
-          </a:xfrm>
-          <a:prstGeom prst="rect">
-            <a:avLst/>
-          </a:prstGeom>
-          <a:noFill/>
-        </p:spPr>
-        <p:txBody>
-          <a:bodyPr wrap="square">
-            <a:spAutoFit/>
-          </a:bodyPr>
-          <a:lstStyle/>
-          <a:p>
-            <a:pPr>
-              <a:spcAft>
-                <a:spcPts val="800"/>
-              </a:spcAft>
-            </a:pPr>
-            <a:r>
-              <a:rPr sz="1800" b="1" i="0">
-                <a:solidFill>
-                  <a:srgbClr val="C41230"/>
-                </a:solidFill>
-                <a:latin typeface="Segoe UI"/>
-              </a:rPr>
-              <a:t>LIVE DEMO  ·  ~3 minutes</a:t>
-            </a:r>
-          </a:p>
-        </p:txBody>
-      </p:sp>
-      <p:sp>
-        <p:nvSpPr>
-          <p:cNvPr id="5" name="TextBox 4"/>
-          <p:cNvSpPr txBox="1"/>
-          <p:nvPr/>
-        </p:nvSpPr>
-        <p:spPr>
-          <a:xfrm>
-            <a:off x="822960" y="2651760"/>
-            <a:ext cx="10515600" cy="914400"/>
-          </a:xfrm>
-          <a:prstGeom prst="rect">
-            <a:avLst/>
-          </a:prstGeom>
-          <a:noFill/>
-        </p:spPr>
-        <p:txBody>
-          <a:bodyPr wrap="square">
-            <a:spAutoFit/>
-          </a:bodyPr>
-          <a:lstStyle/>
-          <a:p>
-            <a:pPr>
-              <a:spcAft>
-                <a:spcPts val="800"/>
-              </a:spcAft>
-            </a:pPr>
-            <a:r>
-              <a:rPr sz="3400" b="1" i="0">
-                <a:solidFill>
-                  <a:srgbClr val="FFFFFF"/>
-                </a:solidFill>
-                <a:latin typeface="Segoe UI"/>
-              </a:rPr>
-              <a:t>On a seeded 'bad day'</a:t>
-            </a:r>
-          </a:p>
-        </p:txBody>
-      </p:sp>
-      <p:sp>
-        <p:nvSpPr>
-          <p:cNvPr id="6" name="TextBox 5"/>
-          <p:cNvSpPr txBox="1"/>
-          <p:nvPr/>
-        </p:nvSpPr>
-        <p:spPr>
-          <a:xfrm>
-            <a:off x="822960" y="3749039"/>
-            <a:ext cx="10515600" cy="2011680"/>
-          </a:xfrm>
-          <a:prstGeom prst="rect">
-            <a:avLst/>
-          </a:prstGeom>
-          <a:noFill/>
-        </p:spPr>
-        <p:txBody>
-          <a:bodyPr wrap="square">
-            <a:spAutoFit/>
-          </a:bodyPr>
-          <a:lstStyle/>
-          <a:p>
-            <a:pPr>
-              <a:spcAft>
-                <a:spcPts val="900"/>
-              </a:spcAft>
-            </a:pPr>
-            <a:r>
-              <a:rPr sz="1700" b="0" i="0">
-                <a:solidFill>
-                  <a:srgbClr val="F1F5F9"/>
-                </a:solidFill>
-                <a:latin typeface="Segoe UI"/>
-              </a:rPr>
-              <a:t>1.  'Why did conversion drop yesterday?' — team dispatch, live trace, drivers + evidence chart, owner actions, human-review banner.</a:t>
-            </a:r>
-          </a:p>
-          <a:p>
-            <a:pPr>
-              <a:spcAft>
-                <a:spcPts val="900"/>
-              </a:spcAft>
-            </a:pPr>
-            <a:r>
-              <a:rPr sz="1700" b="0" i="0">
-                <a:solidFill>
-                  <a:srgbClr val="F1F5F9"/>
-                </a:solidFill>
-                <a:latin typeface="Segoe UI"/>
-              </a:rPr>
-              <a:t>2.  'Update the paid-social budget' — the read-only guardrail refuses.</a:t>
-            </a:r>
-          </a:p>
-          <a:p>
-            <a:pPr>
-              <a:spcAft>
-                <a:spcPts val="800"/>
-              </a:spcAft>
-            </a:pPr>
-            <a:r>
-              <a:rPr sz="1700" b="0" i="0">
-                <a:solidFill>
-                  <a:srgbClr val="F1F5F9"/>
-                </a:solidFill>
-                <a:latin typeface="Segoe UI"/>
-              </a:rPr>
-              <a:t>3.  An executive briefing — the multi-agent path ranks the biggest cross-functional issues.</a:t>
-            </a:r>
-          </a:p>
-        </p:txBody>
-      </p:sp>
-    </p:spTree>
-  </p:cSld>
-  <p:clrMapOvr>
-    <a:masterClrMapping/>
-  </p:clrMapOvr>
-</p:sld>
-</file>
-
-<file path=ppt/slides/slide6.xml><?xml version="1.0" encoding="utf-8"?>
-<p:sld xmlns:a="http://schemas.openxmlformats.org/drawingml/2006/main" xmlns:p="http://schemas.openxmlformats.org/presentationml/2006/main" xmlns:r="http://schemas.openxmlformats.org/officeDocument/2006/relationships">
-  <p:cSld>
-    <p:spTree>
-      <p:nvGrpSpPr>
-        <p:cNvPr id="1" name=""/>
-        <p:cNvGrpSpPr/>
-        <p:nvPr/>
-      </p:nvGrpSpPr>
-      <p:grpSpPr/>
-      <p:sp>
-        <p:nvSpPr>
-          <p:cNvPr id="2" name="Rectangle 1"/>
-          <p:cNvSpPr/>
-          <p:nvPr/>
-        </p:nvSpPr>
-        <p:spPr>
-          <a:xfrm>
-            <a:off x="0" y="0"/>
-            <a:ext cx="12191695" cy="164592"/>
-          </a:xfrm>
-          <a:prstGeom prst="rect">
-            <a:avLst/>
-          </a:prstGeom>
-          <a:solidFill>
-            <a:srgbClr val="C41230"/>
-          </a:solidFill>
-          <a:ln>
-            <a:noFill/>
-          </a:ln>
-          <a:effectLst/>
-        </p:spPr>
-        <p:style>
-          <a:lnRef idx="1">
-            <a:schemeClr val="accent1"/>
-          </a:lnRef>
-          <a:fillRef idx="3">
-            <a:schemeClr val="accent1"/>
-          </a:fillRef>
-          <a:effectRef idx="2">
-            <a:schemeClr val="accent1"/>
-          </a:effectRef>
-          <a:fontRef idx="minor">
-            <a:schemeClr val="lt1"/>
-          </a:fontRef>
-        </p:style>
-        <p:txBody>
-          <a:bodyPr rtlCol="0" anchor="ctr"/>
-          <a:lstStyle/>
-          <a:p>
-            <a:pPr algn="ctr"/>
-          </a:p>
-        </p:txBody>
-      </p:sp>
-      <p:sp>
-        <p:nvSpPr>
-          <p:cNvPr id="3" name="TextBox 2"/>
-          <p:cNvSpPr txBox="1"/>
-          <p:nvPr/>
-        </p:nvSpPr>
-        <p:spPr>
-          <a:xfrm>
-            <a:off x="548640" y="384048"/>
-            <a:ext cx="11064240" cy="365760"/>
-          </a:xfrm>
-          <a:prstGeom prst="rect">
-            <a:avLst/>
-          </a:prstGeom>
-          <a:noFill/>
-        </p:spPr>
-        <p:txBody>
-          <a:bodyPr wrap="square">
-            <a:spAutoFit/>
-          </a:bodyPr>
-          <a:lstStyle/>
-          <a:p>
-            <a:pPr>
-              <a:spcAft>
-                <a:spcPts val="200"/>
-              </a:spcAft>
-            </a:pPr>
-            <a:r>
-              <a:rPr sz="1300" b="1" i="0">
-                <a:solidFill>
-                  <a:srgbClr val="C41230"/>
-                </a:solidFill>
-                <a:latin typeface="Segoe UI"/>
-              </a:rPr>
-              <a:t>DOES IT WORK?</a:t>
-            </a:r>
-          </a:p>
-        </p:txBody>
-      </p:sp>
-      <p:sp>
-        <p:nvSpPr>
-          <p:cNvPr id="4" name="TextBox 3"/>
-          <p:cNvSpPr txBox="1"/>
-          <p:nvPr/>
-        </p:nvSpPr>
-        <p:spPr>
-          <a:xfrm>
-            <a:off x="548640" y="749808"/>
-            <a:ext cx="11064240" cy="914400"/>
-          </a:xfrm>
-          <a:prstGeom prst="rect">
-            <a:avLst/>
-          </a:prstGeom>
-          <a:noFill/>
-        </p:spPr>
-        <p:txBody>
-          <a:bodyPr wrap="square">
-            <a:spAutoFit/>
-          </a:bodyPr>
-          <a:lstStyle/>
-          <a:p>
-            <a:pPr>
-              <a:spcAft>
-                <a:spcPts val="0"/>
-              </a:spcAft>
-            </a:pPr>
-            <a:r>
-              <a:rPr sz="3000" b="1" i="0">
-                <a:solidFill>
-                  <a:srgbClr val="1E293B"/>
-                </a:solidFill>
-                <a:latin typeface="Segoe UI"/>
-              </a:rPr>
-              <a:t>Reproducible, validated, and free to run</a:t>
-            </a:r>
-          </a:p>
-        </p:txBody>
-      </p:sp>
-      <p:sp>
-        <p:nvSpPr>
-          <p:cNvPr id="5" name="TextBox 4"/>
-          <p:cNvSpPr txBox="1"/>
-          <p:nvPr/>
-        </p:nvSpPr>
-        <p:spPr>
-          <a:xfrm>
-            <a:off x="640080" y="1783080"/>
-            <a:ext cx="10881360" cy="4480560"/>
-          </a:xfrm>
-          <a:prstGeom prst="rect">
-            <a:avLst/>
-          </a:prstGeom>
-          <a:noFill/>
-        </p:spPr>
-        <p:txBody>
-          <a:bodyPr wrap="square">
-            <a:spAutoFit/>
-          </a:bodyPr>
-          <a:lstStyle/>
-          <a:p>
-            <a:pPr>
-              <a:spcAft>
-                <a:spcPts val="1000"/>
-              </a:spcAft>
-            </a:pPr>
-            <a:r>
-              <a:rPr sz="1900" b="0" i="0">
-                <a:solidFill>
-                  <a:srgbClr val="1E293B"/>
-                </a:solidFill>
-                <a:latin typeface="Segoe UI"/>
-              </a:rPr>
-              <a:t>•  Seeded ground truth: a fixed-seed world with a known story (conversion down ~23% from a paid-social shift, stockouts, and regional delays) — so I can verify it finds the right drivers.</a:t>
-            </a:r>
-          </a:p>
-          <a:p>
-            <a:pPr>
-              <a:spcAft>
-                <a:spcPts val="1000"/>
-              </a:spcAft>
-            </a:pPr>
-            <a:r>
-              <a:rPr sz="1900" b="0" i="0">
-                <a:solidFill>
-                  <a:srgbClr val="1E293B"/>
-                </a:solidFill>
-                <a:latin typeface="Segoe UI"/>
-              </a:rPr>
-              <a:t>•  Automated checks: 15 data/guardrail/routing validations pass; 25 tests pass; the UI renders all pages with 0 exceptions.</a:t>
-            </a:r>
-          </a:p>
-          <a:p>
-            <a:pPr>
-              <a:spcAft>
-                <a:spcPts val="1000"/>
-              </a:spcAft>
-            </a:pPr>
-            <a:r>
-              <a:rPr sz="1900" b="1" i="0">
-                <a:solidFill>
-                  <a:srgbClr val="1E293B"/>
-                </a:solidFill>
-                <a:latin typeface="Segoe UI"/>
-              </a:rPr>
-              <a:t>•  Reproducible by design — same seed, same evidence — and 100% free/local, no paid APIs.</a:t>
-            </a:r>
-          </a:p>
-        </p:txBody>
-      </p:sp>
-      <p:sp>
-        <p:nvSpPr>
-          <p:cNvPr id="6" name="TextBox 5"/>
-          <p:cNvSpPr txBox="1"/>
-          <p:nvPr/>
-        </p:nvSpPr>
-        <p:spPr>
-          <a:xfrm>
-            <a:off x="548640" y="6400800"/>
-            <a:ext cx="10607040" cy="365760"/>
-          </a:xfrm>
-          <a:prstGeom prst="rect">
-            <a:avLst/>
-          </a:prstGeom>
-          <a:noFill/>
-        </p:spPr>
-        <p:txBody>
-          <a:bodyPr wrap="square">
-            <a:spAutoFit/>
-          </a:bodyPr>
-          <a:lstStyle/>
-          <a:p>
-            <a:pPr>
-              <a:spcAft>
-                <a:spcPts val="800"/>
-              </a:spcAft>
-            </a:pPr>
-            <a:r>
-              <a:rPr sz="1000" b="0" i="0">
-                <a:solidFill>
-                  <a:srgbClr val="475569"/>
-                </a:solidFill>
-                <a:latin typeface="Segoe UI"/>
-              </a:rPr>
-              <a:t>Omnichannel Retail Analytics Assistant  ·  CMU Capstone  ·  8-min</a:t>
-            </a:r>
-          </a:p>
-        </p:txBody>
-      </p:sp>
-      <p:sp>
-        <p:nvSpPr>
-          <p:cNvPr id="7" name="TextBox 6"/>
-          <p:cNvSpPr txBox="1"/>
-          <p:nvPr/>
-        </p:nvSpPr>
-        <p:spPr>
-          <a:xfrm>
-            <a:off x="11430000" y="6400800"/>
-            <a:ext cx="548640" cy="365760"/>
-          </a:xfrm>
-          <a:prstGeom prst="rect">
-            <a:avLst/>
-          </a:prstGeom>
-          <a:noFill/>
-        </p:spPr>
-        <p:txBody>
-          <a:bodyPr wrap="square">
-            <a:spAutoFit/>
-          </a:bodyPr>
-          <a:lstStyle/>
-          <a:p>
-            <a:pPr>
-              <a:spcAft>
-                <a:spcPts val="800"/>
-              </a:spcAft>
-            </a:pPr>
-            <a:r>
-              <a:rPr sz="1100" b="1" i="0">
-                <a:solidFill>
-                  <a:srgbClr val="475569"/>
-                </a:solidFill>
-                <a:latin typeface="Segoe UI"/>
-              </a:rPr>
-              <a:t>6</a:t>
-            </a:r>
-          </a:p>
-        </p:txBody>
-      </p:sp>
-    </p:spTree>
-  </p:cSld>
-  <p:clrMapOvr>
-    <a:masterClrMapping/>
-  </p:clrMapOvr>
-</p:sld>
-</file>
-
-<file path=ppt/slides/slide7.xml><?xml version="1.0" encoding="utf-8"?>
-<p:sld xmlns:a="http://schemas.openxmlformats.org/drawingml/2006/main" xmlns:p="http://schemas.openxmlformats.org/presentationml/2006/main" xmlns:r="http://schemas.openxmlformats.org/officeDocument/2006/relationships">
-  <p:cSld>
-    <p:spTree>
-      <p:nvGrpSpPr>
-        <p:cNvPr id="1" name=""/>
-        <p:cNvGrpSpPr/>
-        <p:nvPr/>
-      </p:nvGrpSpPr>
-      <p:grpSpPr/>
-      <p:sp>
-        <p:nvSpPr>
-          <p:cNvPr id="2" name="Rectangle 1"/>
-          <p:cNvSpPr/>
-          <p:nvPr/>
-        </p:nvSpPr>
-        <p:spPr>
-          <a:xfrm>
-            <a:off x="0" y="0"/>
-            <a:ext cx="12191695" cy="164592"/>
-          </a:xfrm>
-          <a:prstGeom prst="rect">
-            <a:avLst/>
-          </a:prstGeom>
-          <a:solidFill>
-            <a:srgbClr val="C41230"/>
-          </a:solidFill>
-          <a:ln>
-            <a:noFill/>
-          </a:ln>
-          <a:effectLst/>
-        </p:spPr>
-        <p:style>
-          <a:lnRef idx="1">
-            <a:schemeClr val="accent1"/>
-          </a:lnRef>
-          <a:fillRef idx="3">
-            <a:schemeClr val="accent1"/>
-          </a:fillRef>
-          <a:effectRef idx="2">
-            <a:schemeClr val="accent1"/>
-          </a:effectRef>
-          <a:fontRef idx="minor">
-            <a:schemeClr val="lt1"/>
-          </a:fontRef>
-        </p:style>
-        <p:txBody>
-          <a:bodyPr rtlCol="0" anchor="ctr"/>
-          <a:lstStyle/>
-          <a:p>
-            <a:pPr algn="ctr"/>
-          </a:p>
-        </p:txBody>
-      </p:sp>
-      <p:sp>
-        <p:nvSpPr>
-          <p:cNvPr id="3" name="TextBox 2"/>
-          <p:cNvSpPr txBox="1"/>
-          <p:nvPr/>
-        </p:nvSpPr>
-        <p:spPr>
-          <a:xfrm>
-            <a:off x="548640" y="384048"/>
-            <a:ext cx="11064240" cy="365760"/>
-          </a:xfrm>
-          <a:prstGeom prst="rect">
-            <a:avLst/>
-          </a:prstGeom>
-          <a:noFill/>
-        </p:spPr>
-        <p:txBody>
-          <a:bodyPr wrap="square">
-            <a:spAutoFit/>
-          </a:bodyPr>
-          <a:lstStyle/>
-          <a:p>
-            <a:pPr>
-              <a:spcAft>
-                <a:spcPts val="200"/>
-              </a:spcAft>
-            </a:pPr>
-            <a:r>
-              <a:rPr sz="1300" b="1" i="0">
-                <a:solidFill>
-                  <a:srgbClr val="C41230"/>
-                </a:solidFill>
-                <a:latin typeface="Segoe UI"/>
-              </a:rPr>
-              <a:t>WHY IT MATTERS</a:t>
-            </a:r>
-          </a:p>
-        </p:txBody>
-      </p:sp>
-      <p:sp>
-        <p:nvSpPr>
-          <p:cNvPr id="4" name="TextBox 3"/>
-          <p:cNvSpPr txBox="1"/>
-          <p:nvPr/>
-        </p:nvSpPr>
-        <p:spPr>
-          <a:xfrm>
-            <a:off x="548640" y="749808"/>
-            <a:ext cx="11064240" cy="914400"/>
-          </a:xfrm>
-          <a:prstGeom prst="rect">
-            <a:avLst/>
-          </a:prstGeom>
-          <a:noFill/>
-        </p:spPr>
-        <p:txBody>
-          <a:bodyPr wrap="square">
-            <a:spAutoFit/>
-          </a:bodyPr>
-          <a:lstStyle/>
-          <a:p>
-            <a:pPr>
-              <a:spcAft>
-                <a:spcPts val="0"/>
-              </a:spcAft>
-            </a:pPr>
-            <a:r>
-              <a:rPr sz="3000" b="1" i="0">
-                <a:solidFill>
-                  <a:srgbClr val="1E293B"/>
-                </a:solidFill>
-                <a:latin typeface="Segoe UI"/>
-              </a:rPr>
-              <a:t>From a 2-day fire drill to a governed answer in seconds</a:t>
-            </a:r>
-          </a:p>
-        </p:txBody>
-      </p:sp>
-      <p:sp>
-        <p:nvSpPr>
-          <p:cNvPr id="5" name="TextBox 4"/>
-          <p:cNvSpPr txBox="1"/>
-          <p:nvPr/>
-        </p:nvSpPr>
-        <p:spPr>
-          <a:xfrm>
-            <a:off x="640080" y="1783080"/>
-            <a:ext cx="10881360" cy="4480560"/>
-          </a:xfrm>
-          <a:prstGeom prst="rect">
-            <a:avLst/>
-          </a:prstGeom>
-          <a:noFill/>
-        </p:spPr>
-        <p:txBody>
-          <a:bodyPr wrap="square">
-            <a:spAutoFit/>
-          </a:bodyPr>
-          <a:lstStyle/>
-          <a:p>
-            <a:pPr>
-              <a:spcAft>
-                <a:spcPts val="1000"/>
-              </a:spcAft>
-            </a:pPr>
-            <a:r>
-              <a:rPr sz="1900" b="0" i="0">
-                <a:solidFill>
-                  <a:srgbClr val="1E293B"/>
-                </a:solidFill>
-                <a:latin typeface="Segoe UI"/>
-              </a:rPr>
-              <a:t>•  Impact: fast AND trustworthy — the tension we started with, resolved.</a:t>
-            </a:r>
-          </a:p>
-          <a:p>
-            <a:pPr>
-              <a:spcAft>
-                <a:spcPts val="1000"/>
-              </a:spcAft>
-            </a:pPr>
-            <a:r>
-              <a:rPr sz="1900" b="1" i="0">
-                <a:solidFill>
-                  <a:srgbClr val="1E293B"/>
-                </a:solidFill>
-                <a:latin typeface="Segoe UI"/>
-              </a:rPr>
-              <a:t>•  The lesson: the hard part of agentic AI isn't generating answers — it's governing, evaluating, and observing them.</a:t>
-            </a:r>
-          </a:p>
-          <a:p>
-            <a:pPr>
-              <a:spcAft>
-                <a:spcPts val="1000"/>
-              </a:spcAft>
-            </a:pPr>
-            <a:r>
-              <a:rPr sz="1900" b="0" i="0">
-                <a:solidFill>
-                  <a:srgbClr val="1E293B"/>
-                </a:solidFill>
-                <a:latin typeface="Segoe UI"/>
-              </a:rPr>
-              <a:t>•  Extends to production: swap synthetic data for real warehouse tables behind the same catalog; the governance and reasoning are unchanged.</a:t>
-            </a:r>
-          </a:p>
-          <a:p>
-            <a:pPr>
-              <a:spcAft>
-                <a:spcPts val="1000"/>
-              </a:spcAft>
-            </a:pPr>
-            <a:r>
-              <a:rPr sz="1900" b="0" i="0">
-                <a:solidFill>
-                  <a:srgbClr val="1E293B"/>
-                </a:solidFill>
-                <a:latin typeface="Segoe UI"/>
-              </a:rPr>
-              <a:t>•  Thank you — happy to take questions.</a:t>
-            </a:r>
-          </a:p>
-        </p:txBody>
-      </p:sp>
-      <p:sp>
-        <p:nvSpPr>
-          <p:cNvPr id="6" name="TextBox 5"/>
-          <p:cNvSpPr txBox="1"/>
-          <p:nvPr/>
-        </p:nvSpPr>
-        <p:spPr>
-          <a:xfrm>
-            <a:off x="548640" y="6400800"/>
-            <a:ext cx="10607040" cy="365760"/>
-          </a:xfrm>
-          <a:prstGeom prst="rect">
-            <a:avLst/>
-          </a:prstGeom>
-          <a:noFill/>
-        </p:spPr>
-        <p:txBody>
-          <a:bodyPr wrap="square">
-            <a:spAutoFit/>
-          </a:bodyPr>
-          <a:lstStyle/>
-          <a:p>
-            <a:pPr>
-              <a:spcAft>
-                <a:spcPts val="800"/>
-              </a:spcAft>
-            </a:pPr>
-            <a:r>
-              <a:rPr sz="1000" b="0" i="0">
-                <a:solidFill>
-                  <a:srgbClr val="475569"/>
-                </a:solidFill>
-                <a:latin typeface="Segoe UI"/>
-              </a:rPr>
-              <a:t>Omnichannel Retail Analytics Assistant  ·  CMU Capstone  ·  8-min</a:t>
-            </a:r>
-          </a:p>
-        </p:txBody>
-      </p:sp>
-      <p:sp>
-        <p:nvSpPr>
-          <p:cNvPr id="7" name="TextBox 6"/>
-          <p:cNvSpPr txBox="1"/>
-          <p:nvPr/>
-        </p:nvSpPr>
-        <p:spPr>
-          <a:xfrm>
-            <a:off x="11430000" y="6400800"/>
-            <a:ext cx="548640" cy="365760"/>
-          </a:xfrm>
-          <a:prstGeom prst="rect">
-            <a:avLst/>
-          </a:prstGeom>
-          <a:noFill/>
-        </p:spPr>
-        <p:txBody>
-          <a:bodyPr wrap="square">
-            <a:spAutoFit/>
-          </a:bodyPr>
-          <a:lstStyle/>
-          <a:p>
-            <a:pPr>
-              <a:spcAft>
-                <a:spcPts val="800"/>
-              </a:spcAft>
-            </a:pPr>
-            <a:r>
-              <a:rPr sz="1100" b="1" i="0">
-                <a:solidFill>
-                  <a:srgbClr val="475569"/>
-                </a:solidFill>
-                <a:latin typeface="Segoe UI"/>
-              </a:rPr>
-              <a:t>7</a:t>
+              <a:t>5</a:t>
             </a:r>
           </a:p>
         </p:txBody>

</xml_diff>

<commit_message>
Restructure 8-min deck to pitch → architecture → demo → code walkthrough (#17)
Co-authored-by: Claude <noreply@anthropic.com>
</commit_message>
<xml_diff>
--- a/presentation/Omnichannel_8min.pptx
+++ b/presentation/Omnichannel_8min.pptx
@@ -10,8 +10,6 @@
     <p:sldId id="258" r:id="rId10"/>
     <p:sldId id="259" r:id="rId11"/>
     <p:sldId id="260" r:id="rId12"/>
-    <p:sldId id="261" r:id="rId13"/>
-    <p:sldId id="262" r:id="rId14"/>
   </p:sldIdLst>
   <p:sldSz cx="12191695" cy="6858000" type="screen4x3"/>
   <p:notesSz cx="6858000" cy="9144000"/>
@@ -508,7 +506,7 @@
           <a:lstStyle/>
           <a:p>
             <a:r>
-              <a:t>0:00–0:25. Lead with the 9-second pitch verbatim, then: 'In the next 8 minutes I'll show the problem, how it works, and a live demo.' Keep energy high; the demo is the star.</a:t>
+              <a:t>0:00–0:35. Say the 9-second pitch verbatim, then read the 4-part agenda in one line so they know the shape: pitch, architecture + concepts, demo, code walkthrough. Move fast.</a:t>
             </a:r>
           </a:p>
         </p:txBody>
@@ -578,7 +576,7 @@
           <a:lstStyle/>
           <a:p>
             <a:r>
-              <a:t>0:25–2:15. Frame the tension: fast AND trustworthy. Hit the two pains (speed + ungoverned AI) and land 'a confident wrong answer is a liability.' Then the one-line solution and the key idea: the answer is never just a number — it's a governed package with an owner action.</a:t>
+              <a:t>0:35–2:35 (~2 min). This is the 'architecture + concepts' segment. Walk the loop left-to-right ONCE, then point at the bracketed concept tags — that's you naming the program vocabulary out loud: governance/semantic layer, RAG, knowledge graph, multi-agent, Tree-of-Thoughts/beam, LLM grounding, responsible AI. The ONE principle to land: facts come from governed SQL over certified metrics; the LLM only phrases them. You'll prove each of these in the code walkthrough next.</a:t>
             </a:r>
           </a:p>
         </p:txBody>
@@ -648,7 +646,7 @@
           <a:lstStyle/>
           <a:p>
             <a:r>
-              <a:t>2:15–3:45. One architecture slide. Read the loop quickly, then stress the design principle: the LLM never invents facts — it only phrases proven ones. Name the concepts as you go (RAG, knowledge graph, multi-agent, beam search) so the committee hears the program vocabulary. Mention the free/local fallback so they know the demo is robust.</a:t>
+              <a:t>2:35–5:00 (~2.5 min). App already running and WARMED UP. (1) Run the conversion investigation; narrate the governed steps as the trace streams; land on Business answer → Evidence chart → owner actions + 🔴 human-review banner. (2) Type a write request → it refuses (fast, always lands). (3) Run one briefing. If time is tight, do #1 and #2 only. Keep a backup screenshot.</a:t>
             </a:r>
           </a:p>
         </p:txBody>
@@ -718,7 +716,7 @@
           <a:lstStyle/>
           <a:p>
             <a:r>
-              <a:t>3:45–4:45. This is what makes it a capstone, not a toy. Each line is an ENFORCED control, not a prompt. Emphasize causal humility (observational data → label likelihood) and human-in-the-loop + read-only = safe to deploy in a governed enterprise. Tease the guardrail demo.</a:t>
+              <a:t>5:00–7:30 (~2.5 min). Switch to your editor (VS Code). Open these SIX files in THIS order and say ONE sentence each (see the 'Code walkthrough — fast script' in CAPSTONE_SUBMISSION.md). Goal: show you understand the concepts, not read code line-by-line. The closer: in tot_skill.py point at ungoverned_branch() being pruned automatically — 'governance isn't a prompt, it's enforced.' If short on time, do metrics.yaml → sql_skill → graph.py → tot_skill (the 4 that best show understanding). Keep the files pre-opened as tabs so you don't fumble.</a:t>
             </a:r>
           </a:p>
         </p:txBody>
@@ -788,147 +786,7 @@
           <a:lstStyle/>
           <a:p>
             <a:r>
-              <a:t>4:45–7:45 (your centerpiece — keep it tight). App already running &amp; warmed up. (1) Run the conversion investigation; narrate the governed steps while the trace streams; land on Business answer → Evidence chart → owner actions + human-review banner. (2) Show the write refusal — fast, always lands. (3) Run ONE briefing to show cross-functional ranking. Have a backup screenshot. If short on time, do #1 and #2 only.</a:t>
-            </a:r>
-          </a:p>
-        </p:txBody>
-      </p:sp>
-      <p:sp>
-        <p:nvSpPr>
-          <p:cNvPr id="4" name="Slide Number Placeholder 3"/>
-          <p:cNvSpPr>
-            <a:spLocks noGrp="1"/>
-          </p:cNvSpPr>
-          <p:nvPr>
-            <p:ph type="sldNum" idx="5" sz="quarter"/>
-          </p:nvPr>
-        </p:nvSpPr>
-        <p:spPr/>
-      </p:sp>
-    </p:spTree>
-  </p:cSld>
-  <p:clrMapOvr>
-    <a:masterClrMapping/>
-  </p:clrMapOvr>
-</p:notes>
-</file>
-
-<file path=ppt/notesSlides/notesSlide6.xml><?xml version="1.0" encoding="utf-8"?>
-<p:notes xmlns:a="http://schemas.openxmlformats.org/drawingml/2006/main" xmlns:p="http://schemas.openxmlformats.org/presentationml/2006/main" xmlns:r="http://schemas.openxmlformats.org/officeDocument/2006/relationships">
-  <p:cSld>
-    <p:spTree>
-      <p:nvGrpSpPr>
-        <p:cNvPr id="1" name=""/>
-        <p:cNvGrpSpPr/>
-        <p:nvPr/>
-      </p:nvGrpSpPr>
-      <p:grpSpPr>
-        <a:xfrm>
-          <a:off x="0" y="0"/>
-          <a:ext cx="0" cy="0"/>
-          <a:chOff x="0" y="0"/>
-          <a:chExt cx="0" cy="0"/>
-        </a:xfrm>
-      </p:grpSpPr>
-      <p:sp>
-        <p:nvSpPr>
-          <p:cNvPr id="2" name="Slide Image Placeholder 1"/>
-          <p:cNvSpPr>
-            <a:spLocks noGrp="1"/>
-          </p:cNvSpPr>
-          <p:nvPr>
-            <p:ph type="sldImg" idx="2"/>
-          </p:nvPr>
-        </p:nvSpPr>
-        <p:spPr/>
-      </p:sp>
-      <p:sp>
-        <p:nvSpPr>
-          <p:cNvPr id="3" name="Notes Placeholder 2"/>
-          <p:cNvSpPr>
-            <a:spLocks noGrp="1"/>
-          </p:cNvSpPr>
-          <p:nvPr>
-            <p:ph type="body" idx="3" sz="quarter"/>
-          </p:nvPr>
-        </p:nvSpPr>
-        <p:spPr/>
-        <p:txBody>
-          <a:bodyPr/>
-          <a:lstStyle/>
-          <a:p>
-            <a:r>
-              <a:t>7:45–8:15 (overrun budget). Two evaluation layers: known ground truth + automated gates (data, guardrails, routing). Reproducibility from a fixed seed is itself a governance property. Keep this to ~20 seconds if the demo ran long.</a:t>
-            </a:r>
-          </a:p>
-        </p:txBody>
-      </p:sp>
-      <p:sp>
-        <p:nvSpPr>
-          <p:cNvPr id="4" name="Slide Number Placeholder 3"/>
-          <p:cNvSpPr>
-            <a:spLocks noGrp="1"/>
-          </p:cNvSpPr>
-          <p:nvPr>
-            <p:ph type="sldNum" idx="5" sz="quarter"/>
-          </p:nvPr>
-        </p:nvSpPr>
-        <p:spPr/>
-      </p:sp>
-    </p:spTree>
-  </p:cSld>
-  <p:clrMapOvr>
-    <a:masterClrMapping/>
-  </p:clrMapOvr>
-</p:notes>
-</file>
-
-<file path=ppt/notesSlides/notesSlide7.xml><?xml version="1.0" encoding="utf-8"?>
-<p:notes xmlns:a="http://schemas.openxmlformats.org/drawingml/2006/main" xmlns:p="http://schemas.openxmlformats.org/presentationml/2006/main" xmlns:r="http://schemas.openxmlformats.org/officeDocument/2006/relationships">
-  <p:cSld>
-    <p:spTree>
-      <p:nvGrpSpPr>
-        <p:cNvPr id="1" name=""/>
-        <p:cNvGrpSpPr/>
-        <p:nvPr/>
-      </p:nvGrpSpPr>
-      <p:grpSpPr>
-        <a:xfrm>
-          <a:off x="0" y="0"/>
-          <a:ext cx="0" cy="0"/>
-          <a:chOff x="0" y="0"/>
-          <a:chExt cx="0" cy="0"/>
-        </a:xfrm>
-      </p:grpSpPr>
-      <p:sp>
-        <p:nvSpPr>
-          <p:cNvPr id="2" name="Slide Image Placeholder 1"/>
-          <p:cNvSpPr>
-            <a:spLocks noGrp="1"/>
-          </p:cNvSpPr>
-          <p:nvPr>
-            <p:ph type="sldImg" idx="2"/>
-          </p:nvPr>
-        </p:nvSpPr>
-        <p:spPr/>
-      </p:sp>
-      <p:sp>
-        <p:nvSpPr>
-          <p:cNvPr id="3" name="Notes Placeholder 2"/>
-          <p:cNvSpPr>
-            <a:spLocks noGrp="1"/>
-          </p:cNvSpPr>
-          <p:nvPr>
-            <p:ph type="body" idx="3" sz="quarter"/>
-          </p:nvPr>
-        </p:nvSpPr>
-        <p:spPr/>
-        <p:txBody>
-          <a:bodyPr/>
-          <a:lstStyle/>
-          <a:p>
-            <a:r>
-              <a:t>8:15–8:30. Close on the opening promise (fast AND trustworthy) and the one-sentence lesson. Give the production path in one line to show it scales. Thank them and open Q&amp;A.</a:t>
+              <a:t>7:30–8:00. Tie back to the opening promise (fast AND trustworthy) and deliver the one-sentence lesson. Drop the evaluation numbers as proof in one breath. One line on the production path, then thank them and open Q&amp;A.</a:t>
             </a:r>
           </a:p>
         </p:txBody>
@@ -3986,7 +3844,7 @@
         </p:nvSpPr>
         <p:spPr>
           <a:xfrm>
-            <a:off x="0" y="2286000"/>
+            <a:off x="0" y="2148840"/>
             <a:ext cx="12191695" cy="91440"/>
           </a:xfrm>
           <a:prstGeom prst="rect">
@@ -4030,8 +3888,8 @@
         </p:nvSpPr>
         <p:spPr>
           <a:xfrm>
-            <a:off x="822960" y="1143000"/>
-            <a:ext cx="10515600" cy="1097280"/>
+            <a:off x="822960" y="1051560"/>
+            <a:ext cx="10515600" cy="1005840"/>
           </a:xfrm>
           <a:prstGeom prst="rect">
             <a:avLst/>
@@ -4050,7 +3908,7 @@
               </a:spcAft>
             </a:pPr>
             <a:r>
-              <a:rPr sz="4200" b="1" i="0">
+              <a:rPr sz="4000" b="1" i="0">
                 <a:solidFill>
                   <a:srgbClr val="FFFFFF"/>
                 </a:solidFill>
@@ -4069,8 +3927,8 @@
         </p:nvSpPr>
         <p:spPr>
           <a:xfrm>
-            <a:off x="822960" y="2514600"/>
-            <a:ext cx="10515600" cy="1463040"/>
+            <a:off x="822960" y="2377440"/>
+            <a:ext cx="10515600" cy="1371600"/>
           </a:xfrm>
           <a:prstGeom prst="rect">
             <a:avLst/>
@@ -4089,7 +3947,7 @@
               </a:spcAft>
             </a:pPr>
             <a:r>
-              <a:rPr sz="2200" b="0" i="0">
+              <a:rPr sz="2100" b="0" i="0">
                 <a:solidFill>
                   <a:srgbClr val="F1F5F9"/>
                 </a:solidFill>
@@ -4105,7 +3963,7 @@
               </a:spcAft>
             </a:pPr>
             <a:r>
-              <a:rPr sz="2200" b="0" i="0">
+              <a:rPr sz="2100" b="0" i="0">
                 <a:solidFill>
                   <a:srgbClr val="F1F5F9"/>
                 </a:solidFill>
@@ -4124,8 +3982,8 @@
         </p:nvSpPr>
         <p:spPr>
           <a:xfrm>
-            <a:off x="822960" y="5212080"/>
-            <a:ext cx="10515600" cy="1097280"/>
+            <a:off x="822960" y="4114800"/>
+            <a:ext cx="10515600" cy="1371600"/>
           </a:xfrm>
           <a:prstGeom prst="rect">
             <a:avLst/>
@@ -4144,9 +4002,48 @@
               </a:spcAft>
             </a:pPr>
             <a:r>
-              <a:rPr sz="1500" b="1" i="0">
+              <a:rPr sz="1600" b="1" i="0">
                 <a:solidFill>
                   <a:srgbClr val="FFFFFF"/>
+                </a:solidFill>
+                <a:latin typeface="Segoe UI"/>
+              </a:rPr>
+              <a:t>Today (8 min):  1) the pitch   2) architecture &amp; concepts   3) live demo   4) a quick code walkthrough</a:t>
+            </a:r>
+          </a:p>
+        </p:txBody>
+      </p:sp>
+      <p:sp>
+        <p:nvSpPr>
+          <p:cNvPr id="7" name="TextBox 6"/>
+          <p:cNvSpPr txBox="1"/>
+          <p:nvPr/>
+        </p:nvSpPr>
+        <p:spPr>
+          <a:xfrm>
+            <a:off x="822960" y="5943600"/>
+            <a:ext cx="10515600" cy="548640"/>
+          </a:xfrm>
+          <a:prstGeom prst="rect">
+            <a:avLst/>
+          </a:prstGeom>
+          <a:noFill/>
+        </p:spPr>
+        <p:txBody>
+          <a:bodyPr wrap="square">
+            <a:spAutoFit/>
+          </a:bodyPr>
+          <a:lstStyle/>
+          <a:p>
+            <a:pPr>
+              <a:spcAft>
+                <a:spcPts val="800"/>
+              </a:spcAft>
+            </a:pPr>
+            <a:r>
+              <a:rPr sz="1300" b="0" i="0">
+                <a:solidFill>
+                  <a:srgbClr val="94A3B8"/>
                 </a:solidFill>
                 <a:latin typeface="Segoe UI"/>
               </a:rPr>
@@ -4251,7 +4148,7 @@
                 </a:solidFill>
                 <a:latin typeface="Segoe UI"/>
               </a:rPr>
-              <a:t>PROBLEM → SOLUTION</a:t>
+              <a:t>PART 2 · ARCHITECTURE &amp; THE CONCEPTS I USED</a:t>
             </a:r>
           </a:p>
         </p:txBody>
@@ -4284,13 +4181,13 @@
               </a:spcAft>
             </a:pPr>
             <a:r>
-              <a:rPr sz="3000" b="1" i="0">
+              <a:rPr sz="2900" b="1" i="0">
                 <a:solidFill>
                   <a:srgbClr val="1E293B"/>
                 </a:solidFill>
                 <a:latin typeface="Segoe UI"/>
               </a:rPr>
-              <a:t>Fast answers and trustworthy answers — usually you pick one</a:t>
+              <a:t>Governed knowledge + a multi-agent reasoning loop</a:t>
             </a:r>
           </a:p>
         </p:txBody>
@@ -4303,7 +4200,7 @@
         </p:nvSpPr>
         <p:spPr>
           <a:xfrm>
-            <a:off x="640080" y="1783080"/>
+            <a:off x="640080" y="1737360"/>
             <a:ext cx="10881360" cy="4480560"/>
           </a:xfrm>
           <a:prstGeom prst="rect">
@@ -4319,81 +4216,97 @@
           <a:p>
             <a:pPr>
               <a:spcAft>
-                <a:spcPts val="1000"/>
+                <a:spcPts val="900"/>
               </a:spcAft>
             </a:pPr>
             <a:r>
-              <a:rPr sz="1900" b="0" i="0">
+              <a:rPr sz="1800" b="0" i="0">
                 <a:solidFill>
                   <a:srgbClr val="1E293B"/>
                 </a:solidFill>
                 <a:latin typeface="Segoe UI"/>
               </a:rPr>
-              <a:t>•  When a KPI moves, the 'why' spans many teams — marketing, merchandising, fulfillment, service, finance. Today that's a multi-day, multi-team fire drill.</a:t>
+              <a:t>•  Source of truth — a versioned, hashed YAML catalog of certified metrics, approved tables, drivers, and guardrails.   [data governance / semantic layer]</a:t>
             </a:r>
           </a:p>
           <a:p>
             <a:pPr>
               <a:spcAft>
-                <a:spcPts val="1000"/>
+                <a:spcPts val="900"/>
               </a:spcAft>
             </a:pPr>
             <a:r>
-              <a:rPr sz="1900" b="0" i="0">
+              <a:rPr sz="1800" b="0" i="0">
                 <a:solidFill>
                   <a:srgbClr val="1E293B"/>
                 </a:solidFill>
                 <a:latin typeface="Segoe UI"/>
               </a:rPr>
-              <a:t>•  Generic 'chat-with-your-data' AI is fast but ungoverned: it invents metric definitions, runs arbitrary queries, and asserts causation. A confident wrong answer is a liability.</a:t>
+              <a:t>•  The loop (LangGraph state machine):   classify → retrieve → validate → relate → baseline → dispatch team → critic + beam → human review → answer.   [agent orchestration / ReAct]</a:t>
             </a:r>
           </a:p>
           <a:p>
             <a:pPr>
               <a:spcAft>
-                <a:spcPts val="1000"/>
+                <a:spcPts val="900"/>
               </a:spcAft>
             </a:pPr>
             <a:r>
-              <a:rPr sz="1900" b="1" i="0">
+              <a:rPr sz="1800" b="0" i="0">
                 <a:solidFill>
                   <a:srgbClr val="1E293B"/>
                 </a:solidFill>
                 <a:latin typeface="Segoe UI"/>
               </a:rPr>
-              <a:t>•  My solution: a governed multi-agent analyst. Ask in plain English → it retrieves CERTIFIED definitions, runs read-only queries, reasons across domains, and returns:</a:t>
-            </a:r>
-          </a:p>
-          <a:p>
-            <a:pPr lvl="1">
+              <a:t>•  retrieve = RAG over a ChromaDB vector index;  relate = a NetworkX knowledge graph (metric → driver → table → owner).   [RAG + embeddings · knowledge graph]</a:t>
+            </a:r>
+          </a:p>
+          <a:p>
+            <a:pPr>
               <a:spcAft>
-                <a:spcPts val="500"/>
+                <a:spcPts val="900"/>
               </a:spcAft>
             </a:pPr>
             <a:r>
-              <a:rPr sz="1600" b="0" i="0">
-                <a:solidFill>
-                  <a:srgbClr val="475569"/>
-                </a:solidFill>
-                <a:latin typeface="Segoe UI"/>
-              </a:rPr>
-              <a:t>–  answer + evidence + the definition used + confidence + caveats + an owner-routed action.</a:t>
-            </a:r>
-          </a:p>
-          <a:p>
-            <a:pPr>
-              <a:spcAft>
-                <a:spcPts val="1000"/>
-              </a:spcAft>
-            </a:pPr>
-            <a:r>
-              <a:rPr sz="1900" b="0" i="0">
+              <a:rPr sz="1800" b="0" i="0">
                 <a:solidFill>
                   <a:srgbClr val="1E293B"/>
                 </a:solidFill>
                 <a:latin typeface="Segoe UI"/>
               </a:rPr>
-              <a:t>•  100% free and local — synthetic data, local models, nothing leaves the laptop.</a:t>
+              <a:t>•  dispatch = 7 specialized analysts run in parallel;  the Critic scores each on a 0–14 rubric and beam search keeps the strongest.   [multi-agent systems · Tree-of-Thoughts + beam]</a:t>
+            </a:r>
+          </a:p>
+          <a:p>
+            <a:pPr>
+              <a:spcAft>
+                <a:spcPts val="900"/>
+              </a:spcAft>
+            </a:pPr>
+            <a:r>
+              <a:rPr sz="1800" b="1" i="0">
+                <a:solidFill>
+                  <a:srgbClr val="1E293B"/>
+                </a:solidFill>
+                <a:latin typeface="Segoe UI"/>
+              </a:rPr>
+              <a:t>•  The LLM only DRAFTS the prose — every number comes from governed SQL.   [LLM grounding]</a:t>
+            </a:r>
+          </a:p>
+          <a:p>
+            <a:pPr>
+              <a:spcAft>
+                <a:spcPts val="900"/>
+              </a:spcAft>
+            </a:pPr>
+            <a:r>
+              <a:rPr sz="1800" b="0" i="0">
+                <a:solidFill>
+                  <a:srgbClr val="1E293B"/>
+                </a:solidFill>
+                <a:latin typeface="Segoe UI"/>
+              </a:rPr>
+              <a:t>•  Read-only · causality labeled (not asserted) · human-in-the-loop · full audit trail.   [responsible AI / governance]</a:t>
             </a:r>
           </a:p>
         </p:txBody>
@@ -4485,6 +4398,300 @@
 </file>
 
 <file path=ppt/slides/slide3.xml><?xml version="1.0" encoding="utf-8"?>
+<p:sld xmlns:a="http://schemas.openxmlformats.org/drawingml/2006/main" xmlns:p="http://schemas.openxmlformats.org/presentationml/2006/main" xmlns:r="http://schemas.openxmlformats.org/officeDocument/2006/relationships">
+  <p:cSld>
+    <p:spTree>
+      <p:nvGrpSpPr>
+        <p:cNvPr id="1" name=""/>
+        <p:cNvGrpSpPr/>
+        <p:nvPr/>
+      </p:nvGrpSpPr>
+      <p:grpSpPr/>
+      <p:sp>
+        <p:nvSpPr>
+          <p:cNvPr id="2" name="Rectangle 1"/>
+          <p:cNvSpPr/>
+          <p:nvPr/>
+        </p:nvSpPr>
+        <p:spPr>
+          <a:xfrm>
+            <a:off x="0" y="0"/>
+            <a:ext cx="12191695" cy="6858000"/>
+          </a:xfrm>
+          <a:prstGeom prst="rect">
+            <a:avLst/>
+          </a:prstGeom>
+          <a:solidFill>
+            <a:srgbClr val="1E293B"/>
+          </a:solidFill>
+          <a:ln>
+            <a:noFill/>
+          </a:ln>
+          <a:effectLst/>
+        </p:spPr>
+        <p:style>
+          <a:lnRef idx="1">
+            <a:schemeClr val="accent1"/>
+          </a:lnRef>
+          <a:fillRef idx="3">
+            <a:schemeClr val="accent1"/>
+          </a:fillRef>
+          <a:effectRef idx="2">
+            <a:schemeClr val="accent1"/>
+          </a:effectRef>
+          <a:fontRef idx="minor">
+            <a:schemeClr val="lt1"/>
+          </a:fontRef>
+        </p:style>
+        <p:txBody>
+          <a:bodyPr rtlCol="0" anchor="ctr"/>
+          <a:lstStyle/>
+          <a:p>
+            <a:pPr algn="ctr"/>
+          </a:p>
+        </p:txBody>
+      </p:sp>
+      <p:sp>
+        <p:nvSpPr>
+          <p:cNvPr id="3" name="Rectangle 2"/>
+          <p:cNvSpPr/>
+          <p:nvPr/>
+        </p:nvSpPr>
+        <p:spPr>
+          <a:xfrm>
+            <a:off x="0" y="2331720"/>
+            <a:ext cx="12191695" cy="91440"/>
+          </a:xfrm>
+          <a:prstGeom prst="rect">
+            <a:avLst/>
+          </a:prstGeom>
+          <a:solidFill>
+            <a:srgbClr val="C41230"/>
+          </a:solidFill>
+          <a:ln>
+            <a:noFill/>
+          </a:ln>
+          <a:effectLst/>
+        </p:spPr>
+        <p:style>
+          <a:lnRef idx="1">
+            <a:schemeClr val="accent1"/>
+          </a:lnRef>
+          <a:fillRef idx="3">
+            <a:schemeClr val="accent1"/>
+          </a:fillRef>
+          <a:effectRef idx="2">
+            <a:schemeClr val="accent1"/>
+          </a:effectRef>
+          <a:fontRef idx="minor">
+            <a:schemeClr val="lt1"/>
+          </a:fontRef>
+        </p:style>
+        <p:txBody>
+          <a:bodyPr rtlCol="0" anchor="ctr"/>
+          <a:lstStyle/>
+          <a:p>
+            <a:pPr algn="ctr"/>
+          </a:p>
+        </p:txBody>
+      </p:sp>
+      <p:sp>
+        <p:nvSpPr>
+          <p:cNvPr id="4" name="TextBox 3"/>
+          <p:cNvSpPr txBox="1"/>
+          <p:nvPr/>
+        </p:nvSpPr>
+        <p:spPr>
+          <a:xfrm>
+            <a:off x="822960" y="1463040"/>
+            <a:ext cx="10515600" cy="457200"/>
+          </a:xfrm>
+          <a:prstGeom prst="rect">
+            <a:avLst/>
+          </a:prstGeom>
+          <a:noFill/>
+        </p:spPr>
+        <p:txBody>
+          <a:bodyPr wrap="square">
+            <a:spAutoFit/>
+          </a:bodyPr>
+          <a:lstStyle/>
+          <a:p>
+            <a:pPr>
+              <a:spcAft>
+                <a:spcPts val="800"/>
+              </a:spcAft>
+            </a:pPr>
+            <a:r>
+              <a:rPr sz="1700" b="1" i="0">
+                <a:solidFill>
+                  <a:srgbClr val="F87171"/>
+                </a:solidFill>
+                <a:latin typeface="Segoe UI"/>
+              </a:rPr>
+              <a:t>PART 3 · LIVE DEMO (~2.5 MIN)</a:t>
+            </a:r>
+          </a:p>
+        </p:txBody>
+      </p:sp>
+      <p:sp>
+        <p:nvSpPr>
+          <p:cNvPr id="5" name="TextBox 4"/>
+          <p:cNvSpPr txBox="1"/>
+          <p:nvPr/>
+        </p:nvSpPr>
+        <p:spPr>
+          <a:xfrm>
+            <a:off x="822960" y="2423160"/>
+            <a:ext cx="10515600" cy="914400"/>
+          </a:xfrm>
+          <a:prstGeom prst="rect">
+            <a:avLst/>
+          </a:prstGeom>
+          <a:noFill/>
+        </p:spPr>
+        <p:txBody>
+          <a:bodyPr wrap="square">
+            <a:spAutoFit/>
+          </a:bodyPr>
+          <a:lstStyle/>
+          <a:p>
+            <a:pPr>
+              <a:spcAft>
+                <a:spcPts val="800"/>
+              </a:spcAft>
+            </a:pPr>
+            <a:r>
+              <a:rPr sz="3200" b="1" i="0">
+                <a:solidFill>
+                  <a:srgbClr val="FFFFFF"/>
+                </a:solidFill>
+                <a:latin typeface="Segoe UI"/>
+              </a:rPr>
+              <a:t>Seeing it run on a seeded 'bad day'</a:t>
+            </a:r>
+          </a:p>
+        </p:txBody>
+      </p:sp>
+      <p:sp>
+        <p:nvSpPr>
+          <p:cNvPr id="6" name="TextBox 5"/>
+          <p:cNvSpPr txBox="1"/>
+          <p:nvPr/>
+        </p:nvSpPr>
+        <p:spPr>
+          <a:xfrm>
+            <a:off x="822960" y="3566160"/>
+            <a:ext cx="10515600" cy="2560320"/>
+          </a:xfrm>
+          <a:prstGeom prst="rect">
+            <a:avLst/>
+          </a:prstGeom>
+          <a:noFill/>
+        </p:spPr>
+        <p:txBody>
+          <a:bodyPr wrap="square">
+            <a:spAutoFit/>
+          </a:bodyPr>
+          <a:lstStyle/>
+          <a:p>
+            <a:pPr>
+              <a:spcAft>
+                <a:spcPts val="800"/>
+              </a:spcAft>
+            </a:pPr>
+            <a:r>
+              <a:rPr sz="1600" b="0" i="0">
+                <a:solidFill>
+                  <a:srgbClr val="F1F5F9"/>
+                </a:solidFill>
+                <a:latin typeface="Segoe UI"/>
+              </a:rPr>
+              <a:t>1.  'Why did conversion drop yesterday?' → team dispatch + live trace → drivers &amp; evidence chart → owner actions + the human-review banner.</a:t>
+            </a:r>
+          </a:p>
+          <a:p>
+            <a:pPr>
+              <a:spcAft>
+                <a:spcPts val="800"/>
+              </a:spcAft>
+            </a:pPr>
+            <a:r>
+              <a:rPr sz="1600" b="0" i="0">
+                <a:solidFill>
+                  <a:srgbClr val="F1F5F9"/>
+                </a:solidFill>
+                <a:latin typeface="Segoe UI"/>
+              </a:rPr>
+              <a:t>2.  'Update the paid-social budget' → the read-only guardrail refuses.</a:t>
+            </a:r>
+          </a:p>
+          <a:p>
+            <a:pPr>
+              <a:spcAft>
+                <a:spcPts val="800"/>
+              </a:spcAft>
+            </a:pPr>
+            <a:r>
+              <a:rPr sz="1600" b="0" i="0">
+                <a:solidFill>
+                  <a:srgbClr val="F1F5F9"/>
+                </a:solidFill>
+                <a:latin typeface="Segoe UI"/>
+              </a:rPr>
+              <a:t>3.  An executive briefing → the multi-agent path ranks the biggest cross-functional issues.</a:t>
+            </a:r>
+          </a:p>
+        </p:txBody>
+      </p:sp>
+      <p:sp>
+        <p:nvSpPr>
+          <p:cNvPr id="7" name="TextBox 6"/>
+          <p:cNvSpPr txBox="1"/>
+          <p:nvPr/>
+        </p:nvSpPr>
+        <p:spPr>
+          <a:xfrm>
+            <a:off x="11430000" y="6400800"/>
+            <a:ext cx="548640" cy="365760"/>
+          </a:xfrm>
+          <a:prstGeom prst="rect">
+            <a:avLst/>
+          </a:prstGeom>
+          <a:noFill/>
+        </p:spPr>
+        <p:txBody>
+          <a:bodyPr wrap="square">
+            <a:spAutoFit/>
+          </a:bodyPr>
+          <a:lstStyle/>
+          <a:p>
+            <a:pPr>
+              <a:spcAft>
+                <a:spcPts val="800"/>
+              </a:spcAft>
+            </a:pPr>
+            <a:r>
+              <a:rPr sz="1100" b="1" i="0">
+                <a:solidFill>
+                  <a:srgbClr val="94A3B8"/>
+                </a:solidFill>
+                <a:latin typeface="Segoe UI"/>
+              </a:rPr>
+              <a:t>3</a:t>
+            </a:r>
+          </a:p>
+        </p:txBody>
+      </p:sp>
+    </p:spTree>
+  </p:cSld>
+  <p:clrMapOvr>
+    <a:masterClrMapping/>
+  </p:clrMapOvr>
+</p:sld>
+</file>
+
+<file path=ppt/slides/slide4.xml><?xml version="1.0" encoding="utf-8"?>
 <p:sld xmlns:a="http://schemas.openxmlformats.org/drawingml/2006/main" xmlns:p="http://schemas.openxmlformats.org/presentationml/2006/main" xmlns:r="http://schemas.openxmlformats.org/officeDocument/2006/relationships">
   <p:cSld>
     <p:spTree>
@@ -4572,7 +4779,7 @@
                 </a:solidFill>
                 <a:latin typeface="Segoe UI"/>
               </a:rPr>
-              <a:t>HOW IT WORKS</a:t>
+              <a:t>PART 4 · QUICK CODE WALKTHROUGH</a:t>
             </a:r>
           </a:p>
         </p:txBody>
@@ -4605,13 +4812,13 @@
               </a:spcAft>
             </a:pPr>
             <a:r>
-              <a:rPr sz="3000" b="1" i="0">
+              <a:rPr sz="2900" b="1" i="0">
                 <a:solidFill>
                   <a:srgbClr val="1E293B"/>
                 </a:solidFill>
                 <a:latin typeface="Segoe UI"/>
               </a:rPr>
-              <a:t>Governed knowledge + a multi-agent reasoning loop</a:t>
+              <a:t>Six files — each is one concept, end to end</a:t>
             </a:r>
           </a:p>
         </p:txBody>
@@ -4624,7 +4831,7 @@
         </p:nvSpPr>
         <p:spPr>
           <a:xfrm>
-            <a:off x="640080" y="1783080"/>
+            <a:off x="640080" y="1737360"/>
             <a:ext cx="10881360" cy="4480560"/>
           </a:xfrm>
           <a:prstGeom prst="rect">
@@ -4640,49 +4847,97 @@
           <a:p>
             <a:pPr>
               <a:spcAft>
-                <a:spcPts val="1000"/>
+                <a:spcPts val="900"/>
               </a:spcAft>
             </a:pPr>
             <a:r>
-              <a:rPr sz="1900" b="0" i="0">
+              <a:rPr sz="1800" b="0" i="0">
                 <a:solidFill>
                   <a:srgbClr val="1E293B"/>
                 </a:solidFill>
                 <a:latin typeface="Segoe UI"/>
               </a:rPr>
-              <a:t>•  Source of truth: a versioned YAML catalog of certified metrics, approved tables, drivers, and guardrails — queried read-only over 18 tables in DuckDB.</a:t>
+              <a:t>•  catalog/metrics.yaml — the certified definitions everything resolves to.   [governance / source of truth]</a:t>
             </a:r>
           </a:p>
           <a:p>
             <a:pPr>
               <a:spcAft>
-                <a:spcPts val="1000"/>
+                <a:spcPts val="900"/>
               </a:spcAft>
             </a:pPr>
             <a:r>
-              <a:rPr sz="1900" b="0" i="0">
+              <a:rPr sz="1800" b="0" i="0">
                 <a:solidFill>
                   <a:srgbClr val="1E293B"/>
                 </a:solidFill>
                 <a:latin typeface="Segoe UI"/>
               </a:rPr>
-              <a:t>•  A LangGraph workflow runs the loop: classify → retrieve (RAG/ChromaDB) → validate (YAML) → relate (NetworkX graph) → dispatch a 7-analyst team in parallel → Critic scores each on a 0–14 rubric → beam search keeps the strongest → human review → answer.</a:t>
+              <a:t>•  skills/sql_skill.py · check_sql() — only read-only SELECTs over approved tables run.   [guardrails]</a:t>
             </a:r>
           </a:p>
           <a:p>
             <a:pPr>
               <a:spcAft>
-                <a:spcPts val="1000"/>
+                <a:spcPts val="900"/>
               </a:spcAft>
             </a:pPr>
             <a:r>
-              <a:rPr sz="1900" b="1" i="0">
+              <a:rPr sz="1800" b="0" i="0">
                 <a:solidFill>
                   <a:srgbClr val="1E293B"/>
                 </a:solidFill>
                 <a:latin typeface="Segoe UI"/>
               </a:rPr>
-              <a:t>•  The LLM is on a short leash — it only DRAFTS the prose; every number comes from governed SQL. No model running? A deterministic fallback writes it, so the demo can't break.</a:t>
+              <a:t>•  skills/retrieval_skill.py · retrieve() — top-k vector lookup + a staleness/sync gate.   [RAG]</a:t>
+            </a:r>
+          </a:p>
+          <a:p>
+            <a:pPr>
+              <a:spcAft>
+                <a:spcPts val="900"/>
+              </a:spcAft>
+            </a:pPr>
+            <a:r>
+              <a:rPr sz="1800" b="0" i="0">
+                <a:solidFill>
+                  <a:srgbClr val="1E293B"/>
+                </a:solidFill>
+                <a:latin typeface="Segoe UI"/>
+              </a:rPr>
+              <a:t>•  workflows/graph.py · build_workflow() + classify_intent() — the LangGraph loop &amp; routing.   [orchestration]</a:t>
+            </a:r>
+          </a:p>
+          <a:p>
+            <a:pPr>
+              <a:spcAft>
+                <a:spcPts val="900"/>
+              </a:spcAft>
+            </a:pPr>
+            <a:r>
+              <a:rPr sz="1800" b="0" i="0">
+                <a:solidFill>
+                  <a:srgbClr val="1E293B"/>
+                </a:solidFill>
+                <a:latin typeface="Segoe UI"/>
+              </a:rPr>
+              <a:t>•  agents/team.py · dispatch() — 7 analysts in parallel; a failure is isolated.   [multi-agent]</a:t>
+            </a:r>
+          </a:p>
+          <a:p>
+            <a:pPr>
+              <a:spcAft>
+                <a:spcPts val="900"/>
+              </a:spcAft>
+            </a:pPr>
+            <a:r>
+              <a:rPr sz="1800" b="0" i="0">
+                <a:solidFill>
+                  <a:srgbClr val="1E293B"/>
+                </a:solidFill>
+                <a:latin typeface="Segoe UI"/>
+              </a:rPr>
+              <a:t>•  skills/tot_skill.py · score_branch() + ungoverned_branch() — the 0–14 rubric prunes the ungoverned 'maybe prices rose' idea automatically.   [ToT/beam + responsible AI]</a:t>
             </a:r>
           </a:p>
         </p:txBody>
@@ -4760,7 +5015,7 @@
                 </a:solidFill>
                 <a:latin typeface="Segoe UI"/>
               </a:rPr>
-              <a:t>3</a:t>
+              <a:t>4</a:t>
             </a:r>
           </a:p>
         </p:txBody>
@@ -4773,7 +5028,7 @@
 </p:sld>
 </file>
 
-<file path=ppt/slides/slide4.xml><?xml version="1.0" encoding="utf-8"?>
+<file path=ppt/slides/slide5.xml><?xml version="1.0" encoding="utf-8"?>
 <p:sld xmlns:a="http://schemas.openxmlformats.org/drawingml/2006/main" xmlns:p="http://schemas.openxmlformats.org/presentationml/2006/main" xmlns:r="http://schemas.openxmlformats.org/officeDocument/2006/relationships">
   <p:cSld>
     <p:spTree>
@@ -4861,7 +5116,7 @@
                 </a:solidFill>
                 <a:latin typeface="Segoe UI"/>
               </a:rPr>
-              <a:t>WHY IT'S TRUSTWORTHY</a:t>
+              <a:t>CLOSE</a:t>
             </a:r>
           </a:p>
         </p:txBody>
@@ -4894,13 +5149,13 @@
               </a:spcAft>
             </a:pPr>
             <a:r>
-              <a:rPr sz="3000" b="1" i="0">
+              <a:rPr sz="2900" b="1" i="0">
                 <a:solidFill>
                   <a:srgbClr val="1E293B"/>
                 </a:solidFill>
                 <a:latin typeface="Segoe UI"/>
               </a:rPr>
-              <a:t>Governance enforced in code — the differentiator</a:t>
+              <a:t>From a 2-day fire drill to a governed answer in seconds</a:t>
             </a:r>
           </a:p>
         </p:txBody>
@@ -4913,7 +5168,7 @@
         </p:nvSpPr>
         <p:spPr>
           <a:xfrm>
-            <a:off x="640080" y="1783080"/>
+            <a:off x="640080" y="1737360"/>
             <a:ext cx="10881360" cy="4480560"/>
           </a:xfrm>
           <a:prstGeom prst="rect">
@@ -4929,81 +5184,65 @@
           <a:p>
             <a:pPr>
               <a:spcAft>
-                <a:spcPts val="1000"/>
+                <a:spcPts val="900"/>
               </a:spcAft>
             </a:pPr>
             <a:r>
-              <a:rPr sz="1900" b="0" i="0">
+              <a:rPr sz="1800" b="0" i="0">
                 <a:solidFill>
                   <a:srgbClr val="1E293B"/>
                 </a:solidFill>
                 <a:latin typeface="Segoe UI"/>
               </a:rPr>
-              <a:t>•  Read-only guardrail: a SQL validator allows only SELECT over APPROVED tables; any write is blocked before it runs. (I'll show it refuse a write.)</a:t>
+              <a:t>•  Fast AND trustworthy — the tension I opened with, resolved.</a:t>
             </a:r>
           </a:p>
           <a:p>
             <a:pPr>
               <a:spcAft>
-                <a:spcPts val="1000"/>
+                <a:spcPts val="900"/>
               </a:spcAft>
             </a:pPr>
             <a:r>
-              <a:rPr sz="1900" b="0" i="0">
+              <a:rPr sz="1800" b="1" i="0">
                 <a:solidFill>
                   <a:srgbClr val="1E293B"/>
                 </a:solidFill>
                 <a:latin typeface="Segoe UI"/>
               </a:rPr>
-              <a:t>•  Certified definitions only — metrics resolve from the versioned, hashed catalog, never invented.</a:t>
+              <a:t>•  The lesson: the hard part of agentic AI isn't generating answers — it's governing, evaluating, and observing them.</a:t>
             </a:r>
           </a:p>
           <a:p>
             <a:pPr>
               <a:spcAft>
-                <a:spcPts val="1000"/>
+                <a:spcPts val="900"/>
               </a:spcAft>
             </a:pPr>
             <a:r>
-              <a:rPr sz="1900" b="1" i="0">
+              <a:rPr sz="1800" b="0" i="0">
                 <a:solidFill>
                   <a:srgbClr val="1E293B"/>
                 </a:solidFill>
                 <a:latin typeface="Segoe UI"/>
               </a:rPr>
-              <a:t>•  Causality is LABELED, not asserted — 'likely driver' / 'possible contributor', never 'caused'.</a:t>
+              <a:t>•  Proven &amp; reproducible: seeded ground truth, 15 validation checks, 25 tests, 0 UI exceptions — and 100% free/local.</a:t>
             </a:r>
           </a:p>
           <a:p>
             <a:pPr>
               <a:spcAft>
-                <a:spcPts val="1000"/>
+                <a:spcPts val="900"/>
               </a:spcAft>
             </a:pPr>
             <a:r>
-              <a:rPr sz="1900" b="0" i="0">
+              <a:rPr sz="1800" b="0" i="0">
                 <a:solidFill>
                   <a:srgbClr val="1E293B"/>
                 </a:solidFill>
                 <a:latin typeface="Segoe UI"/>
               </a:rPr>
-              <a:t>•  Human-in-the-loop — every recommendation routes to an owner; no system is changed automatically.</a:t>
-            </a:r>
-          </a:p>
-          <a:p>
-            <a:pPr>
-              <a:spcAft>
-                <a:spcPts val="1000"/>
-              </a:spcAft>
-            </a:pPr>
-            <a:r>
-              <a:rPr sz="1900" b="0" i="0">
-                <a:solidFill>
-                  <a:srgbClr val="1E293B"/>
-                </a:solidFill>
-                <a:latin typeface="Segoe UI"/>
-              </a:rPr>
-              <a:t>•  Full audit trail + version/hash on every answer — reproducible and inspectable.</a:t>
+              <a:t>•  Extends to production: swap synthetic data for real tables behind the same catalog. Thank you — questions?</a:t>
             </a:r>
           </a:p>
         </p:txBody>
@@ -5081,856 +5320,7 @@
                 </a:solidFill>
                 <a:latin typeface="Segoe UI"/>
               </a:rPr>
-              <a:t>4</a:t>
-            </a:r>
-          </a:p>
-        </p:txBody>
-      </p:sp>
-    </p:spTree>
-  </p:cSld>
-  <p:clrMapOvr>
-    <a:masterClrMapping/>
-  </p:clrMapOvr>
-</p:sld>
-</file>
-
-<file path=ppt/slides/slide5.xml><?xml version="1.0" encoding="utf-8"?>
-<p:sld xmlns:a="http://schemas.openxmlformats.org/drawingml/2006/main" xmlns:p="http://schemas.openxmlformats.org/presentationml/2006/main" xmlns:r="http://schemas.openxmlformats.org/officeDocument/2006/relationships">
-  <p:cSld>
-    <p:spTree>
-      <p:nvGrpSpPr>
-        <p:cNvPr id="1" name=""/>
-        <p:cNvGrpSpPr/>
-        <p:nvPr/>
-      </p:nvGrpSpPr>
-      <p:grpSpPr/>
-      <p:sp>
-        <p:nvSpPr>
-          <p:cNvPr id="2" name="Rectangle 1"/>
-          <p:cNvSpPr/>
-          <p:nvPr/>
-        </p:nvSpPr>
-        <p:spPr>
-          <a:xfrm>
-            <a:off x="0" y="0"/>
-            <a:ext cx="12191695" cy="6858000"/>
-          </a:xfrm>
-          <a:prstGeom prst="rect">
-            <a:avLst/>
-          </a:prstGeom>
-          <a:solidFill>
-            <a:srgbClr val="1E293B"/>
-          </a:solidFill>
-          <a:ln>
-            <a:noFill/>
-          </a:ln>
-          <a:effectLst/>
-        </p:spPr>
-        <p:style>
-          <a:lnRef idx="1">
-            <a:schemeClr val="accent1"/>
-          </a:lnRef>
-          <a:fillRef idx="3">
-            <a:schemeClr val="accent1"/>
-          </a:fillRef>
-          <a:effectRef idx="2">
-            <a:schemeClr val="accent1"/>
-          </a:effectRef>
-          <a:fontRef idx="minor">
-            <a:schemeClr val="lt1"/>
-          </a:fontRef>
-        </p:style>
-        <p:txBody>
-          <a:bodyPr rtlCol="0" anchor="ctr"/>
-          <a:lstStyle/>
-          <a:p>
-            <a:pPr algn="ctr"/>
-          </a:p>
-        </p:txBody>
-      </p:sp>
-      <p:sp>
-        <p:nvSpPr>
-          <p:cNvPr id="3" name="Rectangle 2"/>
-          <p:cNvSpPr/>
-          <p:nvPr/>
-        </p:nvSpPr>
-        <p:spPr>
-          <a:xfrm>
-            <a:off x="0" y="2468880"/>
-            <a:ext cx="12191695" cy="91440"/>
-          </a:xfrm>
-          <a:prstGeom prst="rect">
-            <a:avLst/>
-          </a:prstGeom>
-          <a:solidFill>
-            <a:srgbClr val="C41230"/>
-          </a:solidFill>
-          <a:ln>
-            <a:noFill/>
-          </a:ln>
-          <a:effectLst/>
-        </p:spPr>
-        <p:style>
-          <a:lnRef idx="1">
-            <a:schemeClr val="accent1"/>
-          </a:lnRef>
-          <a:fillRef idx="3">
-            <a:schemeClr val="accent1"/>
-          </a:fillRef>
-          <a:effectRef idx="2">
-            <a:schemeClr val="accent1"/>
-          </a:effectRef>
-          <a:fontRef idx="minor">
-            <a:schemeClr val="lt1"/>
-          </a:fontRef>
-        </p:style>
-        <p:txBody>
-          <a:bodyPr rtlCol="0" anchor="ctr"/>
-          <a:lstStyle/>
-          <a:p>
-            <a:pPr algn="ctr"/>
-          </a:p>
-        </p:txBody>
-      </p:sp>
-      <p:sp>
-        <p:nvSpPr>
-          <p:cNvPr id="4" name="TextBox 3"/>
-          <p:cNvSpPr txBox="1"/>
-          <p:nvPr/>
-        </p:nvSpPr>
-        <p:spPr>
-          <a:xfrm>
-            <a:off x="822960" y="1828800"/>
-            <a:ext cx="10515600" cy="457200"/>
-          </a:xfrm>
-          <a:prstGeom prst="rect">
-            <a:avLst/>
-          </a:prstGeom>
-          <a:noFill/>
-        </p:spPr>
-        <p:txBody>
-          <a:bodyPr wrap="square">
-            <a:spAutoFit/>
-          </a:bodyPr>
-          <a:lstStyle/>
-          <a:p>
-            <a:pPr>
-              <a:spcAft>
-                <a:spcPts val="800"/>
-              </a:spcAft>
-            </a:pPr>
-            <a:r>
-              <a:rPr sz="1800" b="1" i="0">
-                <a:solidFill>
-                  <a:srgbClr val="C41230"/>
-                </a:solidFill>
-                <a:latin typeface="Segoe UI"/>
-              </a:rPr>
-              <a:t>LIVE DEMO  ·  ~3 minutes</a:t>
-            </a:r>
-          </a:p>
-        </p:txBody>
-      </p:sp>
-      <p:sp>
-        <p:nvSpPr>
-          <p:cNvPr id="5" name="TextBox 4"/>
-          <p:cNvSpPr txBox="1"/>
-          <p:nvPr/>
-        </p:nvSpPr>
-        <p:spPr>
-          <a:xfrm>
-            <a:off x="822960" y="2651760"/>
-            <a:ext cx="10515600" cy="914400"/>
-          </a:xfrm>
-          <a:prstGeom prst="rect">
-            <a:avLst/>
-          </a:prstGeom>
-          <a:noFill/>
-        </p:spPr>
-        <p:txBody>
-          <a:bodyPr wrap="square">
-            <a:spAutoFit/>
-          </a:bodyPr>
-          <a:lstStyle/>
-          <a:p>
-            <a:pPr>
-              <a:spcAft>
-                <a:spcPts val="800"/>
-              </a:spcAft>
-            </a:pPr>
-            <a:r>
-              <a:rPr sz="3400" b="1" i="0">
-                <a:solidFill>
-                  <a:srgbClr val="FFFFFF"/>
-                </a:solidFill>
-                <a:latin typeface="Segoe UI"/>
-              </a:rPr>
-              <a:t>On a seeded 'bad day'</a:t>
-            </a:r>
-          </a:p>
-        </p:txBody>
-      </p:sp>
-      <p:sp>
-        <p:nvSpPr>
-          <p:cNvPr id="6" name="TextBox 5"/>
-          <p:cNvSpPr txBox="1"/>
-          <p:nvPr/>
-        </p:nvSpPr>
-        <p:spPr>
-          <a:xfrm>
-            <a:off x="822960" y="3749039"/>
-            <a:ext cx="10515600" cy="2011680"/>
-          </a:xfrm>
-          <a:prstGeom prst="rect">
-            <a:avLst/>
-          </a:prstGeom>
-          <a:noFill/>
-        </p:spPr>
-        <p:txBody>
-          <a:bodyPr wrap="square">
-            <a:spAutoFit/>
-          </a:bodyPr>
-          <a:lstStyle/>
-          <a:p>
-            <a:pPr>
-              <a:spcAft>
-                <a:spcPts val="900"/>
-              </a:spcAft>
-            </a:pPr>
-            <a:r>
-              <a:rPr sz="1700" b="0" i="0">
-                <a:solidFill>
-                  <a:srgbClr val="F1F5F9"/>
-                </a:solidFill>
-                <a:latin typeface="Segoe UI"/>
-              </a:rPr>
-              <a:t>1.  'Why did conversion drop yesterday?' — team dispatch, live trace, drivers + evidence chart, owner actions, human-review banner.</a:t>
-            </a:r>
-          </a:p>
-          <a:p>
-            <a:pPr>
-              <a:spcAft>
-                <a:spcPts val="900"/>
-              </a:spcAft>
-            </a:pPr>
-            <a:r>
-              <a:rPr sz="1700" b="0" i="0">
-                <a:solidFill>
-                  <a:srgbClr val="F1F5F9"/>
-                </a:solidFill>
-                <a:latin typeface="Segoe UI"/>
-              </a:rPr>
-              <a:t>2.  'Update the paid-social budget' — the read-only guardrail refuses.</a:t>
-            </a:r>
-          </a:p>
-          <a:p>
-            <a:pPr>
-              <a:spcAft>
-                <a:spcPts val="800"/>
-              </a:spcAft>
-            </a:pPr>
-            <a:r>
-              <a:rPr sz="1700" b="0" i="0">
-                <a:solidFill>
-                  <a:srgbClr val="F1F5F9"/>
-                </a:solidFill>
-                <a:latin typeface="Segoe UI"/>
-              </a:rPr>
-              <a:t>3.  An executive briefing — the multi-agent path ranks the biggest cross-functional issues.</a:t>
-            </a:r>
-          </a:p>
-        </p:txBody>
-      </p:sp>
-    </p:spTree>
-  </p:cSld>
-  <p:clrMapOvr>
-    <a:masterClrMapping/>
-  </p:clrMapOvr>
-</p:sld>
-</file>
-
-<file path=ppt/slides/slide6.xml><?xml version="1.0" encoding="utf-8"?>
-<p:sld xmlns:a="http://schemas.openxmlformats.org/drawingml/2006/main" xmlns:p="http://schemas.openxmlformats.org/presentationml/2006/main" xmlns:r="http://schemas.openxmlformats.org/officeDocument/2006/relationships">
-  <p:cSld>
-    <p:spTree>
-      <p:nvGrpSpPr>
-        <p:cNvPr id="1" name=""/>
-        <p:cNvGrpSpPr/>
-        <p:nvPr/>
-      </p:nvGrpSpPr>
-      <p:grpSpPr/>
-      <p:sp>
-        <p:nvSpPr>
-          <p:cNvPr id="2" name="Rectangle 1"/>
-          <p:cNvSpPr/>
-          <p:nvPr/>
-        </p:nvSpPr>
-        <p:spPr>
-          <a:xfrm>
-            <a:off x="0" y="0"/>
-            <a:ext cx="12191695" cy="164592"/>
-          </a:xfrm>
-          <a:prstGeom prst="rect">
-            <a:avLst/>
-          </a:prstGeom>
-          <a:solidFill>
-            <a:srgbClr val="C41230"/>
-          </a:solidFill>
-          <a:ln>
-            <a:noFill/>
-          </a:ln>
-          <a:effectLst/>
-        </p:spPr>
-        <p:style>
-          <a:lnRef idx="1">
-            <a:schemeClr val="accent1"/>
-          </a:lnRef>
-          <a:fillRef idx="3">
-            <a:schemeClr val="accent1"/>
-          </a:fillRef>
-          <a:effectRef idx="2">
-            <a:schemeClr val="accent1"/>
-          </a:effectRef>
-          <a:fontRef idx="minor">
-            <a:schemeClr val="lt1"/>
-          </a:fontRef>
-        </p:style>
-        <p:txBody>
-          <a:bodyPr rtlCol="0" anchor="ctr"/>
-          <a:lstStyle/>
-          <a:p>
-            <a:pPr algn="ctr"/>
-          </a:p>
-        </p:txBody>
-      </p:sp>
-      <p:sp>
-        <p:nvSpPr>
-          <p:cNvPr id="3" name="TextBox 2"/>
-          <p:cNvSpPr txBox="1"/>
-          <p:nvPr/>
-        </p:nvSpPr>
-        <p:spPr>
-          <a:xfrm>
-            <a:off x="548640" y="384048"/>
-            <a:ext cx="11064240" cy="365760"/>
-          </a:xfrm>
-          <a:prstGeom prst="rect">
-            <a:avLst/>
-          </a:prstGeom>
-          <a:noFill/>
-        </p:spPr>
-        <p:txBody>
-          <a:bodyPr wrap="square">
-            <a:spAutoFit/>
-          </a:bodyPr>
-          <a:lstStyle/>
-          <a:p>
-            <a:pPr>
-              <a:spcAft>
-                <a:spcPts val="200"/>
-              </a:spcAft>
-            </a:pPr>
-            <a:r>
-              <a:rPr sz="1300" b="1" i="0">
-                <a:solidFill>
-                  <a:srgbClr val="C41230"/>
-                </a:solidFill>
-                <a:latin typeface="Segoe UI"/>
-              </a:rPr>
-              <a:t>DOES IT WORK?</a:t>
-            </a:r>
-          </a:p>
-        </p:txBody>
-      </p:sp>
-      <p:sp>
-        <p:nvSpPr>
-          <p:cNvPr id="4" name="TextBox 3"/>
-          <p:cNvSpPr txBox="1"/>
-          <p:nvPr/>
-        </p:nvSpPr>
-        <p:spPr>
-          <a:xfrm>
-            <a:off x="548640" y="749808"/>
-            <a:ext cx="11064240" cy="914400"/>
-          </a:xfrm>
-          <a:prstGeom prst="rect">
-            <a:avLst/>
-          </a:prstGeom>
-          <a:noFill/>
-        </p:spPr>
-        <p:txBody>
-          <a:bodyPr wrap="square">
-            <a:spAutoFit/>
-          </a:bodyPr>
-          <a:lstStyle/>
-          <a:p>
-            <a:pPr>
-              <a:spcAft>
-                <a:spcPts val="0"/>
-              </a:spcAft>
-            </a:pPr>
-            <a:r>
-              <a:rPr sz="3000" b="1" i="0">
-                <a:solidFill>
-                  <a:srgbClr val="1E293B"/>
-                </a:solidFill>
-                <a:latin typeface="Segoe UI"/>
-              </a:rPr>
-              <a:t>Reproducible, validated, and free to run</a:t>
-            </a:r>
-          </a:p>
-        </p:txBody>
-      </p:sp>
-      <p:sp>
-        <p:nvSpPr>
-          <p:cNvPr id="5" name="TextBox 4"/>
-          <p:cNvSpPr txBox="1"/>
-          <p:nvPr/>
-        </p:nvSpPr>
-        <p:spPr>
-          <a:xfrm>
-            <a:off x="640080" y="1783080"/>
-            <a:ext cx="10881360" cy="4480560"/>
-          </a:xfrm>
-          <a:prstGeom prst="rect">
-            <a:avLst/>
-          </a:prstGeom>
-          <a:noFill/>
-        </p:spPr>
-        <p:txBody>
-          <a:bodyPr wrap="square">
-            <a:spAutoFit/>
-          </a:bodyPr>
-          <a:lstStyle/>
-          <a:p>
-            <a:pPr>
-              <a:spcAft>
-                <a:spcPts val="1000"/>
-              </a:spcAft>
-            </a:pPr>
-            <a:r>
-              <a:rPr sz="1900" b="0" i="0">
-                <a:solidFill>
-                  <a:srgbClr val="1E293B"/>
-                </a:solidFill>
-                <a:latin typeface="Segoe UI"/>
-              </a:rPr>
-              <a:t>•  Seeded ground truth: a fixed-seed world with a known story (conversion down ~23% from a paid-social shift, stockouts, and regional delays) — so I can verify it finds the right drivers.</a:t>
-            </a:r>
-          </a:p>
-          <a:p>
-            <a:pPr>
-              <a:spcAft>
-                <a:spcPts val="1000"/>
-              </a:spcAft>
-            </a:pPr>
-            <a:r>
-              <a:rPr sz="1900" b="0" i="0">
-                <a:solidFill>
-                  <a:srgbClr val="1E293B"/>
-                </a:solidFill>
-                <a:latin typeface="Segoe UI"/>
-              </a:rPr>
-              <a:t>•  Automated checks: 15 data/guardrail/routing validations pass; 25 tests pass; the UI renders all pages with 0 exceptions.</a:t>
-            </a:r>
-          </a:p>
-          <a:p>
-            <a:pPr>
-              <a:spcAft>
-                <a:spcPts val="1000"/>
-              </a:spcAft>
-            </a:pPr>
-            <a:r>
-              <a:rPr sz="1900" b="1" i="0">
-                <a:solidFill>
-                  <a:srgbClr val="1E293B"/>
-                </a:solidFill>
-                <a:latin typeface="Segoe UI"/>
-              </a:rPr>
-              <a:t>•  Reproducible by design — same seed, same evidence — and 100% free/local, no paid APIs.</a:t>
-            </a:r>
-          </a:p>
-        </p:txBody>
-      </p:sp>
-      <p:sp>
-        <p:nvSpPr>
-          <p:cNvPr id="6" name="TextBox 5"/>
-          <p:cNvSpPr txBox="1"/>
-          <p:nvPr/>
-        </p:nvSpPr>
-        <p:spPr>
-          <a:xfrm>
-            <a:off x="548640" y="6400800"/>
-            <a:ext cx="10607040" cy="365760"/>
-          </a:xfrm>
-          <a:prstGeom prst="rect">
-            <a:avLst/>
-          </a:prstGeom>
-          <a:noFill/>
-        </p:spPr>
-        <p:txBody>
-          <a:bodyPr wrap="square">
-            <a:spAutoFit/>
-          </a:bodyPr>
-          <a:lstStyle/>
-          <a:p>
-            <a:pPr>
-              <a:spcAft>
-                <a:spcPts val="800"/>
-              </a:spcAft>
-            </a:pPr>
-            <a:r>
-              <a:rPr sz="1000" b="0" i="0">
-                <a:solidFill>
-                  <a:srgbClr val="475569"/>
-                </a:solidFill>
-                <a:latin typeface="Segoe UI"/>
-              </a:rPr>
-              <a:t>Omnichannel Retail Analytics Assistant  ·  CMU Capstone  ·  8-min</a:t>
-            </a:r>
-          </a:p>
-        </p:txBody>
-      </p:sp>
-      <p:sp>
-        <p:nvSpPr>
-          <p:cNvPr id="7" name="TextBox 6"/>
-          <p:cNvSpPr txBox="1"/>
-          <p:nvPr/>
-        </p:nvSpPr>
-        <p:spPr>
-          <a:xfrm>
-            <a:off x="11430000" y="6400800"/>
-            <a:ext cx="548640" cy="365760"/>
-          </a:xfrm>
-          <a:prstGeom prst="rect">
-            <a:avLst/>
-          </a:prstGeom>
-          <a:noFill/>
-        </p:spPr>
-        <p:txBody>
-          <a:bodyPr wrap="square">
-            <a:spAutoFit/>
-          </a:bodyPr>
-          <a:lstStyle/>
-          <a:p>
-            <a:pPr>
-              <a:spcAft>
-                <a:spcPts val="800"/>
-              </a:spcAft>
-            </a:pPr>
-            <a:r>
-              <a:rPr sz="1100" b="1" i="0">
-                <a:solidFill>
-                  <a:srgbClr val="475569"/>
-                </a:solidFill>
-                <a:latin typeface="Segoe UI"/>
-              </a:rPr>
-              <a:t>6</a:t>
-            </a:r>
-          </a:p>
-        </p:txBody>
-      </p:sp>
-    </p:spTree>
-  </p:cSld>
-  <p:clrMapOvr>
-    <a:masterClrMapping/>
-  </p:clrMapOvr>
-</p:sld>
-</file>
-
-<file path=ppt/slides/slide7.xml><?xml version="1.0" encoding="utf-8"?>
-<p:sld xmlns:a="http://schemas.openxmlformats.org/drawingml/2006/main" xmlns:p="http://schemas.openxmlformats.org/presentationml/2006/main" xmlns:r="http://schemas.openxmlformats.org/officeDocument/2006/relationships">
-  <p:cSld>
-    <p:spTree>
-      <p:nvGrpSpPr>
-        <p:cNvPr id="1" name=""/>
-        <p:cNvGrpSpPr/>
-        <p:nvPr/>
-      </p:nvGrpSpPr>
-      <p:grpSpPr/>
-      <p:sp>
-        <p:nvSpPr>
-          <p:cNvPr id="2" name="Rectangle 1"/>
-          <p:cNvSpPr/>
-          <p:nvPr/>
-        </p:nvSpPr>
-        <p:spPr>
-          <a:xfrm>
-            <a:off x="0" y="0"/>
-            <a:ext cx="12191695" cy="164592"/>
-          </a:xfrm>
-          <a:prstGeom prst="rect">
-            <a:avLst/>
-          </a:prstGeom>
-          <a:solidFill>
-            <a:srgbClr val="C41230"/>
-          </a:solidFill>
-          <a:ln>
-            <a:noFill/>
-          </a:ln>
-          <a:effectLst/>
-        </p:spPr>
-        <p:style>
-          <a:lnRef idx="1">
-            <a:schemeClr val="accent1"/>
-          </a:lnRef>
-          <a:fillRef idx="3">
-            <a:schemeClr val="accent1"/>
-          </a:fillRef>
-          <a:effectRef idx="2">
-            <a:schemeClr val="accent1"/>
-          </a:effectRef>
-          <a:fontRef idx="minor">
-            <a:schemeClr val="lt1"/>
-          </a:fontRef>
-        </p:style>
-        <p:txBody>
-          <a:bodyPr rtlCol="0" anchor="ctr"/>
-          <a:lstStyle/>
-          <a:p>
-            <a:pPr algn="ctr"/>
-          </a:p>
-        </p:txBody>
-      </p:sp>
-      <p:sp>
-        <p:nvSpPr>
-          <p:cNvPr id="3" name="TextBox 2"/>
-          <p:cNvSpPr txBox="1"/>
-          <p:nvPr/>
-        </p:nvSpPr>
-        <p:spPr>
-          <a:xfrm>
-            <a:off x="548640" y="384048"/>
-            <a:ext cx="11064240" cy="365760"/>
-          </a:xfrm>
-          <a:prstGeom prst="rect">
-            <a:avLst/>
-          </a:prstGeom>
-          <a:noFill/>
-        </p:spPr>
-        <p:txBody>
-          <a:bodyPr wrap="square">
-            <a:spAutoFit/>
-          </a:bodyPr>
-          <a:lstStyle/>
-          <a:p>
-            <a:pPr>
-              <a:spcAft>
-                <a:spcPts val="200"/>
-              </a:spcAft>
-            </a:pPr>
-            <a:r>
-              <a:rPr sz="1300" b="1" i="0">
-                <a:solidFill>
-                  <a:srgbClr val="C41230"/>
-                </a:solidFill>
-                <a:latin typeface="Segoe UI"/>
-              </a:rPr>
-              <a:t>WHY IT MATTERS</a:t>
-            </a:r>
-          </a:p>
-        </p:txBody>
-      </p:sp>
-      <p:sp>
-        <p:nvSpPr>
-          <p:cNvPr id="4" name="TextBox 3"/>
-          <p:cNvSpPr txBox="1"/>
-          <p:nvPr/>
-        </p:nvSpPr>
-        <p:spPr>
-          <a:xfrm>
-            <a:off x="548640" y="749808"/>
-            <a:ext cx="11064240" cy="914400"/>
-          </a:xfrm>
-          <a:prstGeom prst="rect">
-            <a:avLst/>
-          </a:prstGeom>
-          <a:noFill/>
-        </p:spPr>
-        <p:txBody>
-          <a:bodyPr wrap="square">
-            <a:spAutoFit/>
-          </a:bodyPr>
-          <a:lstStyle/>
-          <a:p>
-            <a:pPr>
-              <a:spcAft>
-                <a:spcPts val="0"/>
-              </a:spcAft>
-            </a:pPr>
-            <a:r>
-              <a:rPr sz="3000" b="1" i="0">
-                <a:solidFill>
-                  <a:srgbClr val="1E293B"/>
-                </a:solidFill>
-                <a:latin typeface="Segoe UI"/>
-              </a:rPr>
-              <a:t>From a 2-day fire drill to a governed answer in seconds</a:t>
-            </a:r>
-          </a:p>
-        </p:txBody>
-      </p:sp>
-      <p:sp>
-        <p:nvSpPr>
-          <p:cNvPr id="5" name="TextBox 4"/>
-          <p:cNvSpPr txBox="1"/>
-          <p:nvPr/>
-        </p:nvSpPr>
-        <p:spPr>
-          <a:xfrm>
-            <a:off x="640080" y="1783080"/>
-            <a:ext cx="10881360" cy="4480560"/>
-          </a:xfrm>
-          <a:prstGeom prst="rect">
-            <a:avLst/>
-          </a:prstGeom>
-          <a:noFill/>
-        </p:spPr>
-        <p:txBody>
-          <a:bodyPr wrap="square">
-            <a:spAutoFit/>
-          </a:bodyPr>
-          <a:lstStyle/>
-          <a:p>
-            <a:pPr>
-              <a:spcAft>
-                <a:spcPts val="1000"/>
-              </a:spcAft>
-            </a:pPr>
-            <a:r>
-              <a:rPr sz="1900" b="0" i="0">
-                <a:solidFill>
-                  <a:srgbClr val="1E293B"/>
-                </a:solidFill>
-                <a:latin typeface="Segoe UI"/>
-              </a:rPr>
-              <a:t>•  Impact: fast AND trustworthy — the tension we started with, resolved.</a:t>
-            </a:r>
-          </a:p>
-          <a:p>
-            <a:pPr>
-              <a:spcAft>
-                <a:spcPts val="1000"/>
-              </a:spcAft>
-            </a:pPr>
-            <a:r>
-              <a:rPr sz="1900" b="1" i="0">
-                <a:solidFill>
-                  <a:srgbClr val="1E293B"/>
-                </a:solidFill>
-                <a:latin typeface="Segoe UI"/>
-              </a:rPr>
-              <a:t>•  The lesson: the hard part of agentic AI isn't generating answers — it's governing, evaluating, and observing them.</a:t>
-            </a:r>
-          </a:p>
-          <a:p>
-            <a:pPr>
-              <a:spcAft>
-                <a:spcPts val="1000"/>
-              </a:spcAft>
-            </a:pPr>
-            <a:r>
-              <a:rPr sz="1900" b="0" i="0">
-                <a:solidFill>
-                  <a:srgbClr val="1E293B"/>
-                </a:solidFill>
-                <a:latin typeface="Segoe UI"/>
-              </a:rPr>
-              <a:t>•  Extends to production: swap synthetic data for real warehouse tables behind the same catalog; the governance and reasoning are unchanged.</a:t>
-            </a:r>
-          </a:p>
-          <a:p>
-            <a:pPr>
-              <a:spcAft>
-                <a:spcPts val="1000"/>
-              </a:spcAft>
-            </a:pPr>
-            <a:r>
-              <a:rPr sz="1900" b="0" i="0">
-                <a:solidFill>
-                  <a:srgbClr val="1E293B"/>
-                </a:solidFill>
-                <a:latin typeface="Segoe UI"/>
-              </a:rPr>
-              <a:t>•  Thank you — happy to take questions.</a:t>
-            </a:r>
-          </a:p>
-        </p:txBody>
-      </p:sp>
-      <p:sp>
-        <p:nvSpPr>
-          <p:cNvPr id="6" name="TextBox 5"/>
-          <p:cNvSpPr txBox="1"/>
-          <p:nvPr/>
-        </p:nvSpPr>
-        <p:spPr>
-          <a:xfrm>
-            <a:off x="548640" y="6400800"/>
-            <a:ext cx="10607040" cy="365760"/>
-          </a:xfrm>
-          <a:prstGeom prst="rect">
-            <a:avLst/>
-          </a:prstGeom>
-          <a:noFill/>
-        </p:spPr>
-        <p:txBody>
-          <a:bodyPr wrap="square">
-            <a:spAutoFit/>
-          </a:bodyPr>
-          <a:lstStyle/>
-          <a:p>
-            <a:pPr>
-              <a:spcAft>
-                <a:spcPts val="800"/>
-              </a:spcAft>
-            </a:pPr>
-            <a:r>
-              <a:rPr sz="1000" b="0" i="0">
-                <a:solidFill>
-                  <a:srgbClr val="475569"/>
-                </a:solidFill>
-                <a:latin typeface="Segoe UI"/>
-              </a:rPr>
-              <a:t>Omnichannel Retail Analytics Assistant  ·  CMU Capstone  ·  8-min</a:t>
-            </a:r>
-          </a:p>
-        </p:txBody>
-      </p:sp>
-      <p:sp>
-        <p:nvSpPr>
-          <p:cNvPr id="7" name="TextBox 6"/>
-          <p:cNvSpPr txBox="1"/>
-          <p:nvPr/>
-        </p:nvSpPr>
-        <p:spPr>
-          <a:xfrm>
-            <a:off x="11430000" y="6400800"/>
-            <a:ext cx="548640" cy="365760"/>
-          </a:xfrm>
-          <a:prstGeom prst="rect">
-            <a:avLst/>
-          </a:prstGeom>
-          <a:noFill/>
-        </p:spPr>
-        <p:txBody>
-          <a:bodyPr wrap="square">
-            <a:spAutoFit/>
-          </a:bodyPr>
-          <a:lstStyle/>
-          <a:p>
-            <a:pPr>
-              <a:spcAft>
-                <a:spcPts val="800"/>
-              </a:spcAft>
-            </a:pPr>
-            <a:r>
-              <a:rPr sz="1100" b="1" i="0">
-                <a:solidFill>
-                  <a:srgbClr val="475569"/>
-                </a:solidFill>
-                <a:latin typeface="Segoe UI"/>
-              </a:rPr>
-              <a:t>7</a:t>
+              <a:t>5</a:t>
             </a:r>
           </a:p>
         </p:txBody>

</xml_diff>

<commit_message>
Redesign 8-min deck: image-composed slides with a drawn architecture diagram
</commit_message>
<xml_diff>
--- a/presentation/Omnichannel_8min.pptx
+++ b/presentation/Omnichannel_8min.pptx
@@ -506,7 +506,7 @@
           <a:lstStyle/>
           <a:p>
             <a:r>
-              <a:t>0:00–0:35. Say the 9-second pitch verbatim, then read the 4-part agenda in one line so they know the shape: pitch, architecture + concepts, demo, code walkthrough. Move fast.</a:t>
+              <a:t>0:00–0:35. Say the pitch verbatim (big text), then read the 4 chips as your agenda. Energy up.</a:t>
             </a:r>
           </a:p>
         </p:txBody>
@@ -576,7 +576,7 @@
           <a:lstStyle/>
           <a:p>
             <a:r>
-              <a:t>0:35–2:35 (~2 min). This is the 'architecture + concepts' segment. Walk the loop left-to-right ONCE, then point at the bracketed concept tags — that's you naming the program vocabulary out loud: governance/semantic layer, RAG, knowledge graph, multi-agent, Tree-of-Thoughts/beam, LLM grounding, responsible AI. The ONE principle to land: facts come from governed SQL over certified metrics; the LLM only phrases them. You'll prove each of these in the code walkthrough next.</a:t>
+              <a:t>0:35–2:35 (~2 min) — centerpiece. Trace it: a question comes in; the LangGraph ORCHESTRATOR runs a governed loop — RETRIEVES certified context (RAG/ChromaDB), VALIDATES vs the YAML catalog, RELATES metric→drivers via a NetworkX knowledge graph. It dispatches a TEAM of 7 analysts in PARALLEL; a CRITIC scores each on a 0–14 rubric, BEAM keeps the strongest, every recommendation goes to an owner for review. Two anchors: the whole loop runs inside GUARDRAILS (top band: read-only, version-gated, write-refusing, audited), fed by the GOVERNED FOUNDATION (YAML = source of truth, DuckDB read-only). Close: 'the LLM only drafts the wording — every number comes from governed SQL.' Point at each chip.</a:t>
             </a:r>
           </a:p>
         </p:txBody>
@@ -646,7 +646,7 @@
           <a:lstStyle/>
           <a:p>
             <a:r>
-              <a:t>2:35–5:00 (~2.5 min). App already running and WARMED UP. (1) Run the conversion investigation; narrate the governed steps as the trace streams; land on Business answer → Evidence chart → owner actions + 🔴 human-review banner. (2) Type a write request → it refuses (fast, always lands). (3) Run one briefing. If time is tight, do #1 and #2 only. Keep a backup screenshot.</a:t>
+              <a:t>2:35–5:00. App running and WARMED UP. (1) Run the conversion investigation; narrate the steps as the trace streams; land on Business answer → Evidence chart → owner actions + 🔴 human-review banner. (2) Type a write request → it refuses (fast, always lands). (3) One briefing. Short on time → #1 and #2 only. Keep a backup screenshot.</a:t>
             </a:r>
           </a:p>
         </p:txBody>
@@ -716,7 +716,7 @@
           <a:lstStyle/>
           <a:p>
             <a:r>
-              <a:t>5:00–7:30 (~2.5 min). Switch to your editor (VS Code). Open these SIX files in THIS order and say ONE sentence each (see the 'Code walkthrough — fast script' in CAPSTONE_SUBMISSION.md). Goal: show you understand the concepts, not read code line-by-line. The closer: in tot_skill.py point at ungoverned_branch() being pruned automatically — 'governance isn't a prompt, it's enforced.' If short on time, do metrics.yaml → sql_skill → graph.py → tot_skill (the 4 that best show understanding). Keep the files pre-opened as tabs so you don't fumble.</a:t>
+              <a:t>5:00–7:30 (~2.5 min). Switch to VS Code with these SIX files PRE-OPENED as tabs. Open in order; ONE sentence each. Goal: show you understand the concepts, not read code. End on ungoverned_branch() being auto-pruned. Short on time → the four starred files. Bump editor font so it's readable on video.</a:t>
             </a:r>
           </a:p>
         </p:txBody>
@@ -786,7 +786,7 @@
           <a:lstStyle/>
           <a:p>
             <a:r>
-              <a:t>7:30–8:00. Tie back to the opening promise (fast AND trustworthy) and deliver the one-sentence lesson. Drop the evaluation numbers as proof in one breath. One line on the production path, then thank them and open Q&amp;A.</a:t>
+              <a:t>7:30–8:00. Tie back to fast AND trustworthy. Deliver the one-sentence lesson slowly. Sweep the proof chips in one breath. One line on the production path, thank them, open Q&amp;A.</a:t>
             </a:r>
           </a:p>
         </p:txBody>
@@ -3792,12 +3792,20 @@
         <p:nvPr/>
       </p:nvGrpSpPr>
       <p:grpSpPr/>
-      <p:sp>
-        <p:nvSpPr>
-          <p:cNvPr id="2" name="Rectangle 1"/>
-          <p:cNvSpPr/>
+      <p:pic>
+        <p:nvPicPr>
+          <p:cNvPr id="2" name="Picture 1" descr="s1.png"/>
+          <p:cNvPicPr>
+            <a:picLocks noChangeAspect="1"/>
+          </p:cNvPicPr>
           <p:nvPr/>
-        </p:nvSpPr>
+        </p:nvPicPr>
+        <p:blipFill>
+          <a:blip r:embed="rId2"/>
+          <a:stretch>
+            <a:fillRect/>
+          </a:stretch>
+        </p:blipFill>
         <p:spPr>
           <a:xfrm>
             <a:off x="0" y="0"/>
@@ -3806,252 +3814,8 @@
           <a:prstGeom prst="rect">
             <a:avLst/>
           </a:prstGeom>
-          <a:solidFill>
-            <a:srgbClr val="1E293B"/>
-          </a:solidFill>
-          <a:ln>
-            <a:noFill/>
-          </a:ln>
-          <a:effectLst/>
         </p:spPr>
-        <p:style>
-          <a:lnRef idx="1">
-            <a:schemeClr val="accent1"/>
-          </a:lnRef>
-          <a:fillRef idx="3">
-            <a:schemeClr val="accent1"/>
-          </a:fillRef>
-          <a:effectRef idx="2">
-            <a:schemeClr val="accent1"/>
-          </a:effectRef>
-          <a:fontRef idx="minor">
-            <a:schemeClr val="lt1"/>
-          </a:fontRef>
-        </p:style>
-        <p:txBody>
-          <a:bodyPr rtlCol="0" anchor="ctr"/>
-          <a:lstStyle/>
-          <a:p>
-            <a:pPr algn="ctr"/>
-          </a:p>
-        </p:txBody>
-      </p:sp>
-      <p:sp>
-        <p:nvSpPr>
-          <p:cNvPr id="3" name="Rectangle 2"/>
-          <p:cNvSpPr/>
-          <p:nvPr/>
-        </p:nvSpPr>
-        <p:spPr>
-          <a:xfrm>
-            <a:off x="0" y="2148840"/>
-            <a:ext cx="12191695" cy="91440"/>
-          </a:xfrm>
-          <a:prstGeom prst="rect">
-            <a:avLst/>
-          </a:prstGeom>
-          <a:solidFill>
-            <a:srgbClr val="C41230"/>
-          </a:solidFill>
-          <a:ln>
-            <a:noFill/>
-          </a:ln>
-          <a:effectLst/>
-        </p:spPr>
-        <p:style>
-          <a:lnRef idx="1">
-            <a:schemeClr val="accent1"/>
-          </a:lnRef>
-          <a:fillRef idx="3">
-            <a:schemeClr val="accent1"/>
-          </a:fillRef>
-          <a:effectRef idx="2">
-            <a:schemeClr val="accent1"/>
-          </a:effectRef>
-          <a:fontRef idx="minor">
-            <a:schemeClr val="lt1"/>
-          </a:fontRef>
-        </p:style>
-        <p:txBody>
-          <a:bodyPr rtlCol="0" anchor="ctr"/>
-          <a:lstStyle/>
-          <a:p>
-            <a:pPr algn="ctr"/>
-          </a:p>
-        </p:txBody>
-      </p:sp>
-      <p:sp>
-        <p:nvSpPr>
-          <p:cNvPr id="4" name="TextBox 3"/>
-          <p:cNvSpPr txBox="1"/>
-          <p:nvPr/>
-        </p:nvSpPr>
-        <p:spPr>
-          <a:xfrm>
-            <a:off x="822960" y="1051560"/>
-            <a:ext cx="10515600" cy="1005840"/>
-          </a:xfrm>
-          <a:prstGeom prst="rect">
-            <a:avLst/>
-          </a:prstGeom>
-          <a:noFill/>
-        </p:spPr>
-        <p:txBody>
-          <a:bodyPr wrap="square">
-            <a:spAutoFit/>
-          </a:bodyPr>
-          <a:lstStyle/>
-          <a:p>
-            <a:pPr>
-              <a:spcAft>
-                <a:spcPts val="800"/>
-              </a:spcAft>
-            </a:pPr>
-            <a:r>
-              <a:rPr sz="4000" b="1" i="0">
-                <a:solidFill>
-                  <a:srgbClr val="FFFFFF"/>
-                </a:solidFill>
-                <a:latin typeface="Segoe UI"/>
-              </a:rPr>
-              <a:t>Omnichannel Retail Analytics Assistant</a:t>
-            </a:r>
-          </a:p>
-        </p:txBody>
-      </p:sp>
-      <p:sp>
-        <p:nvSpPr>
-          <p:cNvPr id="5" name="TextBox 4"/>
-          <p:cNvSpPr txBox="1"/>
-          <p:nvPr/>
-        </p:nvSpPr>
-        <p:spPr>
-          <a:xfrm>
-            <a:off x="822960" y="2377440"/>
-            <a:ext cx="10515600" cy="1371600"/>
-          </a:xfrm>
-          <a:prstGeom prst="rect">
-            <a:avLst/>
-          </a:prstGeom>
-          <a:noFill/>
-        </p:spPr>
-        <p:txBody>
-          <a:bodyPr wrap="square">
-            <a:spAutoFit/>
-          </a:bodyPr>
-          <a:lstStyle/>
-          <a:p>
-            <a:pPr>
-              <a:spcAft>
-                <a:spcPts val="200"/>
-              </a:spcAft>
-            </a:pPr>
-            <a:r>
-              <a:rPr sz="2100" b="0" i="0">
-                <a:solidFill>
-                  <a:srgbClr val="F1F5F9"/>
-                </a:solidFill>
-                <a:latin typeface="Segoe UI"/>
-              </a:rPr>
-              <a:t>A governed AI analyst that tells retail leaders why a KPI moved —</a:t>
-            </a:r>
-          </a:p>
-          <a:p>
-            <a:pPr>
-              <a:spcAft>
-                <a:spcPts val="800"/>
-              </a:spcAft>
-            </a:pPr>
-            <a:r>
-              <a:rPr sz="2100" b="0" i="0">
-                <a:solidFill>
-                  <a:srgbClr val="F1F5F9"/>
-                </a:solidFill>
-                <a:latin typeface="Segoe UI"/>
-              </a:rPr>
-              <a:t>across every team, in seconds, using only certified data. It never guesses.</a:t>
-            </a:r>
-          </a:p>
-        </p:txBody>
-      </p:sp>
-      <p:sp>
-        <p:nvSpPr>
-          <p:cNvPr id="6" name="TextBox 5"/>
-          <p:cNvSpPr txBox="1"/>
-          <p:nvPr/>
-        </p:nvSpPr>
-        <p:spPr>
-          <a:xfrm>
-            <a:off x="822960" y="4114800"/>
-            <a:ext cx="10515600" cy="1371600"/>
-          </a:xfrm>
-          <a:prstGeom prst="rect">
-            <a:avLst/>
-          </a:prstGeom>
-          <a:noFill/>
-        </p:spPr>
-        <p:txBody>
-          <a:bodyPr wrap="square">
-            <a:spAutoFit/>
-          </a:bodyPr>
-          <a:lstStyle/>
-          <a:p>
-            <a:pPr>
-              <a:spcAft>
-                <a:spcPts val="800"/>
-              </a:spcAft>
-            </a:pPr>
-            <a:r>
-              <a:rPr sz="1600" b="1" i="0">
-                <a:solidFill>
-                  <a:srgbClr val="FFFFFF"/>
-                </a:solidFill>
-                <a:latin typeface="Segoe UI"/>
-              </a:rPr>
-              <a:t>Today (8 min):  1) the pitch   2) architecture &amp; concepts   3) live demo   4) a quick code walkthrough</a:t>
-            </a:r>
-          </a:p>
-        </p:txBody>
-      </p:sp>
-      <p:sp>
-        <p:nvSpPr>
-          <p:cNvPr id="7" name="TextBox 6"/>
-          <p:cNvSpPr txBox="1"/>
-          <p:nvPr/>
-        </p:nvSpPr>
-        <p:spPr>
-          <a:xfrm>
-            <a:off x="822960" y="5943600"/>
-            <a:ext cx="10515600" cy="548640"/>
-          </a:xfrm>
-          <a:prstGeom prst="rect">
-            <a:avLst/>
-          </a:prstGeom>
-          <a:noFill/>
-        </p:spPr>
-        <p:txBody>
-          <a:bodyPr wrap="square">
-            <a:spAutoFit/>
-          </a:bodyPr>
-          <a:lstStyle/>
-          <a:p>
-            <a:pPr>
-              <a:spcAft>
-                <a:spcPts val="800"/>
-              </a:spcAft>
-            </a:pPr>
-            <a:r>
-              <a:rPr sz="1300" b="0" i="0">
-                <a:solidFill>
-                  <a:srgbClr val="94A3B8"/>
-                </a:solidFill>
-                <a:latin typeface="Segoe UI"/>
-              </a:rPr>
-              <a:t>Final Capstone  ·  Carnegie Mellon University  ·  Sreddy  ·  June 2026</a:t>
-            </a:r>
-          </a:p>
-        </p:txBody>
-      </p:sp>
+      </p:pic>
     </p:spTree>
   </p:cSld>
   <p:clrMapOvr>
@@ -4070,325 +3834,30 @@
         <p:nvPr/>
       </p:nvGrpSpPr>
       <p:grpSpPr/>
-      <p:sp>
-        <p:nvSpPr>
-          <p:cNvPr id="2" name="Rectangle 1"/>
-          <p:cNvSpPr/>
+      <p:pic>
+        <p:nvPicPr>
+          <p:cNvPr id="2" name="Picture 1" descr="s2.png"/>
+          <p:cNvPicPr>
+            <a:picLocks noChangeAspect="1"/>
+          </p:cNvPicPr>
           <p:nvPr/>
-        </p:nvSpPr>
+        </p:nvPicPr>
+        <p:blipFill>
+          <a:blip r:embed="rId2"/>
+          <a:stretch>
+            <a:fillRect/>
+          </a:stretch>
+        </p:blipFill>
         <p:spPr>
           <a:xfrm>
             <a:off x="0" y="0"/>
-            <a:ext cx="12191695" cy="164592"/>
+            <a:ext cx="12191695" cy="6858000"/>
           </a:xfrm>
           <a:prstGeom prst="rect">
             <a:avLst/>
           </a:prstGeom>
-          <a:solidFill>
-            <a:srgbClr val="C41230"/>
-          </a:solidFill>
-          <a:ln>
-            <a:noFill/>
-          </a:ln>
-          <a:effectLst/>
         </p:spPr>
-        <p:style>
-          <a:lnRef idx="1">
-            <a:schemeClr val="accent1"/>
-          </a:lnRef>
-          <a:fillRef idx="3">
-            <a:schemeClr val="accent1"/>
-          </a:fillRef>
-          <a:effectRef idx="2">
-            <a:schemeClr val="accent1"/>
-          </a:effectRef>
-          <a:fontRef idx="minor">
-            <a:schemeClr val="lt1"/>
-          </a:fontRef>
-        </p:style>
-        <p:txBody>
-          <a:bodyPr rtlCol="0" anchor="ctr"/>
-          <a:lstStyle/>
-          <a:p>
-            <a:pPr algn="ctr"/>
-          </a:p>
-        </p:txBody>
-      </p:sp>
-      <p:sp>
-        <p:nvSpPr>
-          <p:cNvPr id="3" name="TextBox 2"/>
-          <p:cNvSpPr txBox="1"/>
-          <p:nvPr/>
-        </p:nvSpPr>
-        <p:spPr>
-          <a:xfrm>
-            <a:off x="548640" y="384048"/>
-            <a:ext cx="11064240" cy="365760"/>
-          </a:xfrm>
-          <a:prstGeom prst="rect">
-            <a:avLst/>
-          </a:prstGeom>
-          <a:noFill/>
-        </p:spPr>
-        <p:txBody>
-          <a:bodyPr wrap="square">
-            <a:spAutoFit/>
-          </a:bodyPr>
-          <a:lstStyle/>
-          <a:p>
-            <a:pPr>
-              <a:spcAft>
-                <a:spcPts val="200"/>
-              </a:spcAft>
-            </a:pPr>
-            <a:r>
-              <a:rPr sz="1300" b="1" i="0">
-                <a:solidFill>
-                  <a:srgbClr val="C41230"/>
-                </a:solidFill>
-                <a:latin typeface="Segoe UI"/>
-              </a:rPr>
-              <a:t>PART 2 · ARCHITECTURE &amp; THE CONCEPTS I USED</a:t>
-            </a:r>
-          </a:p>
-        </p:txBody>
-      </p:sp>
-      <p:sp>
-        <p:nvSpPr>
-          <p:cNvPr id="4" name="TextBox 3"/>
-          <p:cNvSpPr txBox="1"/>
-          <p:nvPr/>
-        </p:nvSpPr>
-        <p:spPr>
-          <a:xfrm>
-            <a:off x="548640" y="749808"/>
-            <a:ext cx="11064240" cy="914400"/>
-          </a:xfrm>
-          <a:prstGeom prst="rect">
-            <a:avLst/>
-          </a:prstGeom>
-          <a:noFill/>
-        </p:spPr>
-        <p:txBody>
-          <a:bodyPr wrap="square">
-            <a:spAutoFit/>
-          </a:bodyPr>
-          <a:lstStyle/>
-          <a:p>
-            <a:pPr>
-              <a:spcAft>
-                <a:spcPts val="0"/>
-              </a:spcAft>
-            </a:pPr>
-            <a:r>
-              <a:rPr sz="2900" b="1" i="0">
-                <a:solidFill>
-                  <a:srgbClr val="1E293B"/>
-                </a:solidFill>
-                <a:latin typeface="Segoe UI"/>
-              </a:rPr>
-              <a:t>Governed knowledge + a multi-agent reasoning loop</a:t>
-            </a:r>
-          </a:p>
-        </p:txBody>
-      </p:sp>
-      <p:sp>
-        <p:nvSpPr>
-          <p:cNvPr id="5" name="TextBox 4"/>
-          <p:cNvSpPr txBox="1"/>
-          <p:nvPr/>
-        </p:nvSpPr>
-        <p:spPr>
-          <a:xfrm>
-            <a:off x="640080" y="1737360"/>
-            <a:ext cx="10881360" cy="4480560"/>
-          </a:xfrm>
-          <a:prstGeom prst="rect">
-            <a:avLst/>
-          </a:prstGeom>
-          <a:noFill/>
-        </p:spPr>
-        <p:txBody>
-          <a:bodyPr wrap="square">
-            <a:spAutoFit/>
-          </a:bodyPr>
-          <a:lstStyle/>
-          <a:p>
-            <a:pPr>
-              <a:spcAft>
-                <a:spcPts val="900"/>
-              </a:spcAft>
-            </a:pPr>
-            <a:r>
-              <a:rPr sz="1800" b="0" i="0">
-                <a:solidFill>
-                  <a:srgbClr val="1E293B"/>
-                </a:solidFill>
-                <a:latin typeface="Segoe UI"/>
-              </a:rPr>
-              <a:t>•  Source of truth — a versioned, hashed YAML catalog of certified metrics, approved tables, drivers, and guardrails.   [data governance / semantic layer]</a:t>
-            </a:r>
-          </a:p>
-          <a:p>
-            <a:pPr>
-              <a:spcAft>
-                <a:spcPts val="900"/>
-              </a:spcAft>
-            </a:pPr>
-            <a:r>
-              <a:rPr sz="1800" b="0" i="0">
-                <a:solidFill>
-                  <a:srgbClr val="1E293B"/>
-                </a:solidFill>
-                <a:latin typeface="Segoe UI"/>
-              </a:rPr>
-              <a:t>•  The loop (LangGraph state machine):   classify → retrieve → validate → relate → baseline → dispatch team → critic + beam → human review → answer.   [agent orchestration / ReAct]</a:t>
-            </a:r>
-          </a:p>
-          <a:p>
-            <a:pPr>
-              <a:spcAft>
-                <a:spcPts val="900"/>
-              </a:spcAft>
-            </a:pPr>
-            <a:r>
-              <a:rPr sz="1800" b="0" i="0">
-                <a:solidFill>
-                  <a:srgbClr val="1E293B"/>
-                </a:solidFill>
-                <a:latin typeface="Segoe UI"/>
-              </a:rPr>
-              <a:t>•  retrieve = RAG over a ChromaDB vector index;  relate = a NetworkX knowledge graph (metric → driver → table → owner).   [RAG + embeddings · knowledge graph]</a:t>
-            </a:r>
-          </a:p>
-          <a:p>
-            <a:pPr>
-              <a:spcAft>
-                <a:spcPts val="900"/>
-              </a:spcAft>
-            </a:pPr>
-            <a:r>
-              <a:rPr sz="1800" b="0" i="0">
-                <a:solidFill>
-                  <a:srgbClr val="1E293B"/>
-                </a:solidFill>
-                <a:latin typeface="Segoe UI"/>
-              </a:rPr>
-              <a:t>•  dispatch = 7 specialized analysts run in parallel;  the Critic scores each on a 0–14 rubric and beam search keeps the strongest.   [multi-agent systems · Tree-of-Thoughts + beam]</a:t>
-            </a:r>
-          </a:p>
-          <a:p>
-            <a:pPr>
-              <a:spcAft>
-                <a:spcPts val="900"/>
-              </a:spcAft>
-            </a:pPr>
-            <a:r>
-              <a:rPr sz="1800" b="1" i="0">
-                <a:solidFill>
-                  <a:srgbClr val="1E293B"/>
-                </a:solidFill>
-                <a:latin typeface="Segoe UI"/>
-              </a:rPr>
-              <a:t>•  The LLM only DRAFTS the prose — every number comes from governed SQL.   [LLM grounding]</a:t>
-            </a:r>
-          </a:p>
-          <a:p>
-            <a:pPr>
-              <a:spcAft>
-                <a:spcPts val="900"/>
-              </a:spcAft>
-            </a:pPr>
-            <a:r>
-              <a:rPr sz="1800" b="0" i="0">
-                <a:solidFill>
-                  <a:srgbClr val="1E293B"/>
-                </a:solidFill>
-                <a:latin typeface="Segoe UI"/>
-              </a:rPr>
-              <a:t>•  Read-only · causality labeled (not asserted) · human-in-the-loop · full audit trail.   [responsible AI / governance]</a:t>
-            </a:r>
-          </a:p>
-        </p:txBody>
-      </p:sp>
-      <p:sp>
-        <p:nvSpPr>
-          <p:cNvPr id="6" name="TextBox 5"/>
-          <p:cNvSpPr txBox="1"/>
-          <p:nvPr/>
-        </p:nvSpPr>
-        <p:spPr>
-          <a:xfrm>
-            <a:off x="548640" y="6400800"/>
-            <a:ext cx="10607040" cy="365760"/>
-          </a:xfrm>
-          <a:prstGeom prst="rect">
-            <a:avLst/>
-          </a:prstGeom>
-          <a:noFill/>
-        </p:spPr>
-        <p:txBody>
-          <a:bodyPr wrap="square">
-            <a:spAutoFit/>
-          </a:bodyPr>
-          <a:lstStyle/>
-          <a:p>
-            <a:pPr>
-              <a:spcAft>
-                <a:spcPts val="800"/>
-              </a:spcAft>
-            </a:pPr>
-            <a:r>
-              <a:rPr sz="1000" b="0" i="0">
-                <a:solidFill>
-                  <a:srgbClr val="475569"/>
-                </a:solidFill>
-                <a:latin typeface="Segoe UI"/>
-              </a:rPr>
-              <a:t>Omnichannel Retail Analytics Assistant  ·  CMU Capstone  ·  8-min</a:t>
-            </a:r>
-          </a:p>
-        </p:txBody>
-      </p:sp>
-      <p:sp>
-        <p:nvSpPr>
-          <p:cNvPr id="7" name="TextBox 6"/>
-          <p:cNvSpPr txBox="1"/>
-          <p:nvPr/>
-        </p:nvSpPr>
-        <p:spPr>
-          <a:xfrm>
-            <a:off x="11430000" y="6400800"/>
-            <a:ext cx="548640" cy="365760"/>
-          </a:xfrm>
-          <a:prstGeom prst="rect">
-            <a:avLst/>
-          </a:prstGeom>
-          <a:noFill/>
-        </p:spPr>
-        <p:txBody>
-          <a:bodyPr wrap="square">
-            <a:spAutoFit/>
-          </a:bodyPr>
-          <a:lstStyle/>
-          <a:p>
-            <a:pPr>
-              <a:spcAft>
-                <a:spcPts val="800"/>
-              </a:spcAft>
-            </a:pPr>
-            <a:r>
-              <a:rPr sz="1100" b="1" i="0">
-                <a:solidFill>
-                  <a:srgbClr val="475569"/>
-                </a:solidFill>
-                <a:latin typeface="Segoe UI"/>
-              </a:rPr>
-              <a:t>2</a:t>
-            </a:r>
-          </a:p>
-        </p:txBody>
-      </p:sp>
+      </p:pic>
     </p:spTree>
   </p:cSld>
   <p:clrMapOvr>
@@ -4407,12 +3876,20 @@
         <p:nvPr/>
       </p:nvGrpSpPr>
       <p:grpSpPr/>
-      <p:sp>
-        <p:nvSpPr>
-          <p:cNvPr id="2" name="Rectangle 1"/>
-          <p:cNvSpPr/>
+      <p:pic>
+        <p:nvPicPr>
+          <p:cNvPr id="2" name="Picture 1" descr="s3.png"/>
+          <p:cNvPicPr>
+            <a:picLocks noChangeAspect="1"/>
+          </p:cNvPicPr>
           <p:nvPr/>
-        </p:nvSpPr>
+        </p:nvPicPr>
+        <p:blipFill>
+          <a:blip r:embed="rId2"/>
+          <a:stretch>
+            <a:fillRect/>
+          </a:stretch>
+        </p:blipFill>
         <p:spPr>
           <a:xfrm>
             <a:off x="0" y="0"/>
@@ -4421,268 +3898,8 @@
           <a:prstGeom prst="rect">
             <a:avLst/>
           </a:prstGeom>
-          <a:solidFill>
-            <a:srgbClr val="1E293B"/>
-          </a:solidFill>
-          <a:ln>
-            <a:noFill/>
-          </a:ln>
-          <a:effectLst/>
         </p:spPr>
-        <p:style>
-          <a:lnRef idx="1">
-            <a:schemeClr val="accent1"/>
-          </a:lnRef>
-          <a:fillRef idx="3">
-            <a:schemeClr val="accent1"/>
-          </a:fillRef>
-          <a:effectRef idx="2">
-            <a:schemeClr val="accent1"/>
-          </a:effectRef>
-          <a:fontRef idx="minor">
-            <a:schemeClr val="lt1"/>
-          </a:fontRef>
-        </p:style>
-        <p:txBody>
-          <a:bodyPr rtlCol="0" anchor="ctr"/>
-          <a:lstStyle/>
-          <a:p>
-            <a:pPr algn="ctr"/>
-          </a:p>
-        </p:txBody>
-      </p:sp>
-      <p:sp>
-        <p:nvSpPr>
-          <p:cNvPr id="3" name="Rectangle 2"/>
-          <p:cNvSpPr/>
-          <p:nvPr/>
-        </p:nvSpPr>
-        <p:spPr>
-          <a:xfrm>
-            <a:off x="0" y="2331720"/>
-            <a:ext cx="12191695" cy="91440"/>
-          </a:xfrm>
-          <a:prstGeom prst="rect">
-            <a:avLst/>
-          </a:prstGeom>
-          <a:solidFill>
-            <a:srgbClr val="C41230"/>
-          </a:solidFill>
-          <a:ln>
-            <a:noFill/>
-          </a:ln>
-          <a:effectLst/>
-        </p:spPr>
-        <p:style>
-          <a:lnRef idx="1">
-            <a:schemeClr val="accent1"/>
-          </a:lnRef>
-          <a:fillRef idx="3">
-            <a:schemeClr val="accent1"/>
-          </a:fillRef>
-          <a:effectRef idx="2">
-            <a:schemeClr val="accent1"/>
-          </a:effectRef>
-          <a:fontRef idx="minor">
-            <a:schemeClr val="lt1"/>
-          </a:fontRef>
-        </p:style>
-        <p:txBody>
-          <a:bodyPr rtlCol="0" anchor="ctr"/>
-          <a:lstStyle/>
-          <a:p>
-            <a:pPr algn="ctr"/>
-          </a:p>
-        </p:txBody>
-      </p:sp>
-      <p:sp>
-        <p:nvSpPr>
-          <p:cNvPr id="4" name="TextBox 3"/>
-          <p:cNvSpPr txBox="1"/>
-          <p:nvPr/>
-        </p:nvSpPr>
-        <p:spPr>
-          <a:xfrm>
-            <a:off x="822960" y="1463040"/>
-            <a:ext cx="10515600" cy="457200"/>
-          </a:xfrm>
-          <a:prstGeom prst="rect">
-            <a:avLst/>
-          </a:prstGeom>
-          <a:noFill/>
-        </p:spPr>
-        <p:txBody>
-          <a:bodyPr wrap="square">
-            <a:spAutoFit/>
-          </a:bodyPr>
-          <a:lstStyle/>
-          <a:p>
-            <a:pPr>
-              <a:spcAft>
-                <a:spcPts val="800"/>
-              </a:spcAft>
-            </a:pPr>
-            <a:r>
-              <a:rPr sz="1700" b="1" i="0">
-                <a:solidFill>
-                  <a:srgbClr val="F87171"/>
-                </a:solidFill>
-                <a:latin typeface="Segoe UI"/>
-              </a:rPr>
-              <a:t>PART 3 · LIVE DEMO (~2.5 MIN)</a:t>
-            </a:r>
-          </a:p>
-        </p:txBody>
-      </p:sp>
-      <p:sp>
-        <p:nvSpPr>
-          <p:cNvPr id="5" name="TextBox 4"/>
-          <p:cNvSpPr txBox="1"/>
-          <p:nvPr/>
-        </p:nvSpPr>
-        <p:spPr>
-          <a:xfrm>
-            <a:off x="822960" y="2423160"/>
-            <a:ext cx="10515600" cy="914400"/>
-          </a:xfrm>
-          <a:prstGeom prst="rect">
-            <a:avLst/>
-          </a:prstGeom>
-          <a:noFill/>
-        </p:spPr>
-        <p:txBody>
-          <a:bodyPr wrap="square">
-            <a:spAutoFit/>
-          </a:bodyPr>
-          <a:lstStyle/>
-          <a:p>
-            <a:pPr>
-              <a:spcAft>
-                <a:spcPts val="800"/>
-              </a:spcAft>
-            </a:pPr>
-            <a:r>
-              <a:rPr sz="3200" b="1" i="0">
-                <a:solidFill>
-                  <a:srgbClr val="FFFFFF"/>
-                </a:solidFill>
-                <a:latin typeface="Segoe UI"/>
-              </a:rPr>
-              <a:t>Seeing it run on a seeded 'bad day'</a:t>
-            </a:r>
-          </a:p>
-        </p:txBody>
-      </p:sp>
-      <p:sp>
-        <p:nvSpPr>
-          <p:cNvPr id="6" name="TextBox 5"/>
-          <p:cNvSpPr txBox="1"/>
-          <p:nvPr/>
-        </p:nvSpPr>
-        <p:spPr>
-          <a:xfrm>
-            <a:off x="822960" y="3566160"/>
-            <a:ext cx="10515600" cy="2560320"/>
-          </a:xfrm>
-          <a:prstGeom prst="rect">
-            <a:avLst/>
-          </a:prstGeom>
-          <a:noFill/>
-        </p:spPr>
-        <p:txBody>
-          <a:bodyPr wrap="square">
-            <a:spAutoFit/>
-          </a:bodyPr>
-          <a:lstStyle/>
-          <a:p>
-            <a:pPr>
-              <a:spcAft>
-                <a:spcPts val="800"/>
-              </a:spcAft>
-            </a:pPr>
-            <a:r>
-              <a:rPr sz="1600" b="0" i="0">
-                <a:solidFill>
-                  <a:srgbClr val="F1F5F9"/>
-                </a:solidFill>
-                <a:latin typeface="Segoe UI"/>
-              </a:rPr>
-              <a:t>1.  'Why did conversion drop yesterday?' → team dispatch + live trace → drivers &amp; evidence chart → owner actions + the human-review banner.</a:t>
-            </a:r>
-          </a:p>
-          <a:p>
-            <a:pPr>
-              <a:spcAft>
-                <a:spcPts val="800"/>
-              </a:spcAft>
-            </a:pPr>
-            <a:r>
-              <a:rPr sz="1600" b="0" i="0">
-                <a:solidFill>
-                  <a:srgbClr val="F1F5F9"/>
-                </a:solidFill>
-                <a:latin typeface="Segoe UI"/>
-              </a:rPr>
-              <a:t>2.  'Update the paid-social budget' → the read-only guardrail refuses.</a:t>
-            </a:r>
-          </a:p>
-          <a:p>
-            <a:pPr>
-              <a:spcAft>
-                <a:spcPts val="800"/>
-              </a:spcAft>
-            </a:pPr>
-            <a:r>
-              <a:rPr sz="1600" b="0" i="0">
-                <a:solidFill>
-                  <a:srgbClr val="F1F5F9"/>
-                </a:solidFill>
-                <a:latin typeface="Segoe UI"/>
-              </a:rPr>
-              <a:t>3.  An executive briefing → the multi-agent path ranks the biggest cross-functional issues.</a:t>
-            </a:r>
-          </a:p>
-        </p:txBody>
-      </p:sp>
-      <p:sp>
-        <p:nvSpPr>
-          <p:cNvPr id="7" name="TextBox 6"/>
-          <p:cNvSpPr txBox="1"/>
-          <p:nvPr/>
-        </p:nvSpPr>
-        <p:spPr>
-          <a:xfrm>
-            <a:off x="11430000" y="6400800"/>
-            <a:ext cx="548640" cy="365760"/>
-          </a:xfrm>
-          <a:prstGeom prst="rect">
-            <a:avLst/>
-          </a:prstGeom>
-          <a:noFill/>
-        </p:spPr>
-        <p:txBody>
-          <a:bodyPr wrap="square">
-            <a:spAutoFit/>
-          </a:bodyPr>
-          <a:lstStyle/>
-          <a:p>
-            <a:pPr>
-              <a:spcAft>
-                <a:spcPts val="800"/>
-              </a:spcAft>
-            </a:pPr>
-            <a:r>
-              <a:rPr sz="1100" b="1" i="0">
-                <a:solidFill>
-                  <a:srgbClr val="94A3B8"/>
-                </a:solidFill>
-                <a:latin typeface="Segoe UI"/>
-              </a:rPr>
-              <a:t>3</a:t>
-            </a:r>
-          </a:p>
-        </p:txBody>
-      </p:sp>
+      </p:pic>
     </p:spTree>
   </p:cSld>
   <p:clrMapOvr>
@@ -4701,325 +3918,30 @@
         <p:nvPr/>
       </p:nvGrpSpPr>
       <p:grpSpPr/>
-      <p:sp>
-        <p:nvSpPr>
-          <p:cNvPr id="2" name="Rectangle 1"/>
-          <p:cNvSpPr/>
+      <p:pic>
+        <p:nvPicPr>
+          <p:cNvPr id="2" name="Picture 1" descr="s4.png"/>
+          <p:cNvPicPr>
+            <a:picLocks noChangeAspect="1"/>
+          </p:cNvPicPr>
           <p:nvPr/>
-        </p:nvSpPr>
+        </p:nvPicPr>
+        <p:blipFill>
+          <a:blip r:embed="rId2"/>
+          <a:stretch>
+            <a:fillRect/>
+          </a:stretch>
+        </p:blipFill>
         <p:spPr>
           <a:xfrm>
             <a:off x="0" y="0"/>
-            <a:ext cx="12191695" cy="164592"/>
+            <a:ext cx="12191695" cy="6858000"/>
           </a:xfrm>
           <a:prstGeom prst="rect">
             <a:avLst/>
           </a:prstGeom>
-          <a:solidFill>
-            <a:srgbClr val="C41230"/>
-          </a:solidFill>
-          <a:ln>
-            <a:noFill/>
-          </a:ln>
-          <a:effectLst/>
         </p:spPr>
-        <p:style>
-          <a:lnRef idx="1">
-            <a:schemeClr val="accent1"/>
-          </a:lnRef>
-          <a:fillRef idx="3">
-            <a:schemeClr val="accent1"/>
-          </a:fillRef>
-          <a:effectRef idx="2">
-            <a:schemeClr val="accent1"/>
-          </a:effectRef>
-          <a:fontRef idx="minor">
-            <a:schemeClr val="lt1"/>
-          </a:fontRef>
-        </p:style>
-        <p:txBody>
-          <a:bodyPr rtlCol="0" anchor="ctr"/>
-          <a:lstStyle/>
-          <a:p>
-            <a:pPr algn="ctr"/>
-          </a:p>
-        </p:txBody>
-      </p:sp>
-      <p:sp>
-        <p:nvSpPr>
-          <p:cNvPr id="3" name="TextBox 2"/>
-          <p:cNvSpPr txBox="1"/>
-          <p:nvPr/>
-        </p:nvSpPr>
-        <p:spPr>
-          <a:xfrm>
-            <a:off x="548640" y="384048"/>
-            <a:ext cx="11064240" cy="365760"/>
-          </a:xfrm>
-          <a:prstGeom prst="rect">
-            <a:avLst/>
-          </a:prstGeom>
-          <a:noFill/>
-        </p:spPr>
-        <p:txBody>
-          <a:bodyPr wrap="square">
-            <a:spAutoFit/>
-          </a:bodyPr>
-          <a:lstStyle/>
-          <a:p>
-            <a:pPr>
-              <a:spcAft>
-                <a:spcPts val="200"/>
-              </a:spcAft>
-            </a:pPr>
-            <a:r>
-              <a:rPr sz="1300" b="1" i="0">
-                <a:solidFill>
-                  <a:srgbClr val="C41230"/>
-                </a:solidFill>
-                <a:latin typeface="Segoe UI"/>
-              </a:rPr>
-              <a:t>PART 4 · QUICK CODE WALKTHROUGH</a:t>
-            </a:r>
-          </a:p>
-        </p:txBody>
-      </p:sp>
-      <p:sp>
-        <p:nvSpPr>
-          <p:cNvPr id="4" name="TextBox 3"/>
-          <p:cNvSpPr txBox="1"/>
-          <p:nvPr/>
-        </p:nvSpPr>
-        <p:spPr>
-          <a:xfrm>
-            <a:off x="548640" y="749808"/>
-            <a:ext cx="11064240" cy="914400"/>
-          </a:xfrm>
-          <a:prstGeom prst="rect">
-            <a:avLst/>
-          </a:prstGeom>
-          <a:noFill/>
-        </p:spPr>
-        <p:txBody>
-          <a:bodyPr wrap="square">
-            <a:spAutoFit/>
-          </a:bodyPr>
-          <a:lstStyle/>
-          <a:p>
-            <a:pPr>
-              <a:spcAft>
-                <a:spcPts val="0"/>
-              </a:spcAft>
-            </a:pPr>
-            <a:r>
-              <a:rPr sz="2900" b="1" i="0">
-                <a:solidFill>
-                  <a:srgbClr val="1E293B"/>
-                </a:solidFill>
-                <a:latin typeface="Segoe UI"/>
-              </a:rPr>
-              <a:t>Six files — each is one concept, end to end</a:t>
-            </a:r>
-          </a:p>
-        </p:txBody>
-      </p:sp>
-      <p:sp>
-        <p:nvSpPr>
-          <p:cNvPr id="5" name="TextBox 4"/>
-          <p:cNvSpPr txBox="1"/>
-          <p:nvPr/>
-        </p:nvSpPr>
-        <p:spPr>
-          <a:xfrm>
-            <a:off x="640080" y="1737360"/>
-            <a:ext cx="10881360" cy="4480560"/>
-          </a:xfrm>
-          <a:prstGeom prst="rect">
-            <a:avLst/>
-          </a:prstGeom>
-          <a:noFill/>
-        </p:spPr>
-        <p:txBody>
-          <a:bodyPr wrap="square">
-            <a:spAutoFit/>
-          </a:bodyPr>
-          <a:lstStyle/>
-          <a:p>
-            <a:pPr>
-              <a:spcAft>
-                <a:spcPts val="900"/>
-              </a:spcAft>
-            </a:pPr>
-            <a:r>
-              <a:rPr sz="1800" b="0" i="0">
-                <a:solidFill>
-                  <a:srgbClr val="1E293B"/>
-                </a:solidFill>
-                <a:latin typeface="Segoe UI"/>
-              </a:rPr>
-              <a:t>•  catalog/metrics.yaml — the certified definitions everything resolves to.   [governance / source of truth]</a:t>
-            </a:r>
-          </a:p>
-          <a:p>
-            <a:pPr>
-              <a:spcAft>
-                <a:spcPts val="900"/>
-              </a:spcAft>
-            </a:pPr>
-            <a:r>
-              <a:rPr sz="1800" b="0" i="0">
-                <a:solidFill>
-                  <a:srgbClr val="1E293B"/>
-                </a:solidFill>
-                <a:latin typeface="Segoe UI"/>
-              </a:rPr>
-              <a:t>•  skills/sql_skill.py · check_sql() — only read-only SELECTs over approved tables run.   [guardrails]</a:t>
-            </a:r>
-          </a:p>
-          <a:p>
-            <a:pPr>
-              <a:spcAft>
-                <a:spcPts val="900"/>
-              </a:spcAft>
-            </a:pPr>
-            <a:r>
-              <a:rPr sz="1800" b="0" i="0">
-                <a:solidFill>
-                  <a:srgbClr val="1E293B"/>
-                </a:solidFill>
-                <a:latin typeface="Segoe UI"/>
-              </a:rPr>
-              <a:t>•  skills/retrieval_skill.py · retrieve() — top-k vector lookup + a staleness/sync gate.   [RAG]</a:t>
-            </a:r>
-          </a:p>
-          <a:p>
-            <a:pPr>
-              <a:spcAft>
-                <a:spcPts val="900"/>
-              </a:spcAft>
-            </a:pPr>
-            <a:r>
-              <a:rPr sz="1800" b="0" i="0">
-                <a:solidFill>
-                  <a:srgbClr val="1E293B"/>
-                </a:solidFill>
-                <a:latin typeface="Segoe UI"/>
-              </a:rPr>
-              <a:t>•  workflows/graph.py · build_workflow() + classify_intent() — the LangGraph loop &amp; routing.   [orchestration]</a:t>
-            </a:r>
-          </a:p>
-          <a:p>
-            <a:pPr>
-              <a:spcAft>
-                <a:spcPts val="900"/>
-              </a:spcAft>
-            </a:pPr>
-            <a:r>
-              <a:rPr sz="1800" b="0" i="0">
-                <a:solidFill>
-                  <a:srgbClr val="1E293B"/>
-                </a:solidFill>
-                <a:latin typeface="Segoe UI"/>
-              </a:rPr>
-              <a:t>•  agents/team.py · dispatch() — 7 analysts in parallel; a failure is isolated.   [multi-agent]</a:t>
-            </a:r>
-          </a:p>
-          <a:p>
-            <a:pPr>
-              <a:spcAft>
-                <a:spcPts val="900"/>
-              </a:spcAft>
-            </a:pPr>
-            <a:r>
-              <a:rPr sz="1800" b="0" i="0">
-                <a:solidFill>
-                  <a:srgbClr val="1E293B"/>
-                </a:solidFill>
-                <a:latin typeface="Segoe UI"/>
-              </a:rPr>
-              <a:t>•  skills/tot_skill.py · score_branch() + ungoverned_branch() — the 0–14 rubric prunes the ungoverned 'maybe prices rose' idea automatically.   [ToT/beam + responsible AI]</a:t>
-            </a:r>
-          </a:p>
-        </p:txBody>
-      </p:sp>
-      <p:sp>
-        <p:nvSpPr>
-          <p:cNvPr id="6" name="TextBox 5"/>
-          <p:cNvSpPr txBox="1"/>
-          <p:nvPr/>
-        </p:nvSpPr>
-        <p:spPr>
-          <a:xfrm>
-            <a:off x="548640" y="6400800"/>
-            <a:ext cx="10607040" cy="365760"/>
-          </a:xfrm>
-          <a:prstGeom prst="rect">
-            <a:avLst/>
-          </a:prstGeom>
-          <a:noFill/>
-        </p:spPr>
-        <p:txBody>
-          <a:bodyPr wrap="square">
-            <a:spAutoFit/>
-          </a:bodyPr>
-          <a:lstStyle/>
-          <a:p>
-            <a:pPr>
-              <a:spcAft>
-                <a:spcPts val="800"/>
-              </a:spcAft>
-            </a:pPr>
-            <a:r>
-              <a:rPr sz="1000" b="0" i="0">
-                <a:solidFill>
-                  <a:srgbClr val="475569"/>
-                </a:solidFill>
-                <a:latin typeface="Segoe UI"/>
-              </a:rPr>
-              <a:t>Omnichannel Retail Analytics Assistant  ·  CMU Capstone  ·  8-min</a:t>
-            </a:r>
-          </a:p>
-        </p:txBody>
-      </p:sp>
-      <p:sp>
-        <p:nvSpPr>
-          <p:cNvPr id="7" name="TextBox 6"/>
-          <p:cNvSpPr txBox="1"/>
-          <p:nvPr/>
-        </p:nvSpPr>
-        <p:spPr>
-          <a:xfrm>
-            <a:off x="11430000" y="6400800"/>
-            <a:ext cx="548640" cy="365760"/>
-          </a:xfrm>
-          <a:prstGeom prst="rect">
-            <a:avLst/>
-          </a:prstGeom>
-          <a:noFill/>
-        </p:spPr>
-        <p:txBody>
-          <a:bodyPr wrap="square">
-            <a:spAutoFit/>
-          </a:bodyPr>
-          <a:lstStyle/>
-          <a:p>
-            <a:pPr>
-              <a:spcAft>
-                <a:spcPts val="800"/>
-              </a:spcAft>
-            </a:pPr>
-            <a:r>
-              <a:rPr sz="1100" b="1" i="0">
-                <a:solidFill>
-                  <a:srgbClr val="475569"/>
-                </a:solidFill>
-                <a:latin typeface="Segoe UI"/>
-              </a:rPr>
-              <a:t>4</a:t>
-            </a:r>
-          </a:p>
-        </p:txBody>
-      </p:sp>
+      </p:pic>
     </p:spTree>
   </p:cSld>
   <p:clrMapOvr>
@@ -5038,293 +3960,30 @@
         <p:nvPr/>
       </p:nvGrpSpPr>
       <p:grpSpPr/>
-      <p:sp>
-        <p:nvSpPr>
-          <p:cNvPr id="2" name="Rectangle 1"/>
-          <p:cNvSpPr/>
+      <p:pic>
+        <p:nvPicPr>
+          <p:cNvPr id="2" name="Picture 1" descr="s5.png"/>
+          <p:cNvPicPr>
+            <a:picLocks noChangeAspect="1"/>
+          </p:cNvPicPr>
           <p:nvPr/>
-        </p:nvSpPr>
+        </p:nvPicPr>
+        <p:blipFill>
+          <a:blip r:embed="rId2"/>
+          <a:stretch>
+            <a:fillRect/>
+          </a:stretch>
+        </p:blipFill>
         <p:spPr>
           <a:xfrm>
             <a:off x="0" y="0"/>
-            <a:ext cx="12191695" cy="164592"/>
+            <a:ext cx="12191695" cy="6858000"/>
           </a:xfrm>
           <a:prstGeom prst="rect">
             <a:avLst/>
           </a:prstGeom>
-          <a:solidFill>
-            <a:srgbClr val="C41230"/>
-          </a:solidFill>
-          <a:ln>
-            <a:noFill/>
-          </a:ln>
-          <a:effectLst/>
         </p:spPr>
-        <p:style>
-          <a:lnRef idx="1">
-            <a:schemeClr val="accent1"/>
-          </a:lnRef>
-          <a:fillRef idx="3">
-            <a:schemeClr val="accent1"/>
-          </a:fillRef>
-          <a:effectRef idx="2">
-            <a:schemeClr val="accent1"/>
-          </a:effectRef>
-          <a:fontRef idx="minor">
-            <a:schemeClr val="lt1"/>
-          </a:fontRef>
-        </p:style>
-        <p:txBody>
-          <a:bodyPr rtlCol="0" anchor="ctr"/>
-          <a:lstStyle/>
-          <a:p>
-            <a:pPr algn="ctr"/>
-          </a:p>
-        </p:txBody>
-      </p:sp>
-      <p:sp>
-        <p:nvSpPr>
-          <p:cNvPr id="3" name="TextBox 2"/>
-          <p:cNvSpPr txBox="1"/>
-          <p:nvPr/>
-        </p:nvSpPr>
-        <p:spPr>
-          <a:xfrm>
-            <a:off x="548640" y="384048"/>
-            <a:ext cx="11064240" cy="365760"/>
-          </a:xfrm>
-          <a:prstGeom prst="rect">
-            <a:avLst/>
-          </a:prstGeom>
-          <a:noFill/>
-        </p:spPr>
-        <p:txBody>
-          <a:bodyPr wrap="square">
-            <a:spAutoFit/>
-          </a:bodyPr>
-          <a:lstStyle/>
-          <a:p>
-            <a:pPr>
-              <a:spcAft>
-                <a:spcPts val="200"/>
-              </a:spcAft>
-            </a:pPr>
-            <a:r>
-              <a:rPr sz="1300" b="1" i="0">
-                <a:solidFill>
-                  <a:srgbClr val="C41230"/>
-                </a:solidFill>
-                <a:latin typeface="Segoe UI"/>
-              </a:rPr>
-              <a:t>CLOSE</a:t>
-            </a:r>
-          </a:p>
-        </p:txBody>
-      </p:sp>
-      <p:sp>
-        <p:nvSpPr>
-          <p:cNvPr id="4" name="TextBox 3"/>
-          <p:cNvSpPr txBox="1"/>
-          <p:nvPr/>
-        </p:nvSpPr>
-        <p:spPr>
-          <a:xfrm>
-            <a:off x="548640" y="749808"/>
-            <a:ext cx="11064240" cy="914400"/>
-          </a:xfrm>
-          <a:prstGeom prst="rect">
-            <a:avLst/>
-          </a:prstGeom>
-          <a:noFill/>
-        </p:spPr>
-        <p:txBody>
-          <a:bodyPr wrap="square">
-            <a:spAutoFit/>
-          </a:bodyPr>
-          <a:lstStyle/>
-          <a:p>
-            <a:pPr>
-              <a:spcAft>
-                <a:spcPts val="0"/>
-              </a:spcAft>
-            </a:pPr>
-            <a:r>
-              <a:rPr sz="2900" b="1" i="0">
-                <a:solidFill>
-                  <a:srgbClr val="1E293B"/>
-                </a:solidFill>
-                <a:latin typeface="Segoe UI"/>
-              </a:rPr>
-              <a:t>From a 2-day fire drill to a governed answer in seconds</a:t>
-            </a:r>
-          </a:p>
-        </p:txBody>
-      </p:sp>
-      <p:sp>
-        <p:nvSpPr>
-          <p:cNvPr id="5" name="TextBox 4"/>
-          <p:cNvSpPr txBox="1"/>
-          <p:nvPr/>
-        </p:nvSpPr>
-        <p:spPr>
-          <a:xfrm>
-            <a:off x="640080" y="1737360"/>
-            <a:ext cx="10881360" cy="4480560"/>
-          </a:xfrm>
-          <a:prstGeom prst="rect">
-            <a:avLst/>
-          </a:prstGeom>
-          <a:noFill/>
-        </p:spPr>
-        <p:txBody>
-          <a:bodyPr wrap="square">
-            <a:spAutoFit/>
-          </a:bodyPr>
-          <a:lstStyle/>
-          <a:p>
-            <a:pPr>
-              <a:spcAft>
-                <a:spcPts val="900"/>
-              </a:spcAft>
-            </a:pPr>
-            <a:r>
-              <a:rPr sz="1800" b="0" i="0">
-                <a:solidFill>
-                  <a:srgbClr val="1E293B"/>
-                </a:solidFill>
-                <a:latin typeface="Segoe UI"/>
-              </a:rPr>
-              <a:t>•  Fast AND trustworthy — the tension I opened with, resolved.</a:t>
-            </a:r>
-          </a:p>
-          <a:p>
-            <a:pPr>
-              <a:spcAft>
-                <a:spcPts val="900"/>
-              </a:spcAft>
-            </a:pPr>
-            <a:r>
-              <a:rPr sz="1800" b="1" i="0">
-                <a:solidFill>
-                  <a:srgbClr val="1E293B"/>
-                </a:solidFill>
-                <a:latin typeface="Segoe UI"/>
-              </a:rPr>
-              <a:t>•  The lesson: the hard part of agentic AI isn't generating answers — it's governing, evaluating, and observing them.</a:t>
-            </a:r>
-          </a:p>
-          <a:p>
-            <a:pPr>
-              <a:spcAft>
-                <a:spcPts val="900"/>
-              </a:spcAft>
-            </a:pPr>
-            <a:r>
-              <a:rPr sz="1800" b="0" i="0">
-                <a:solidFill>
-                  <a:srgbClr val="1E293B"/>
-                </a:solidFill>
-                <a:latin typeface="Segoe UI"/>
-              </a:rPr>
-              <a:t>•  Proven &amp; reproducible: seeded ground truth, 15 validation checks, 25 tests, 0 UI exceptions — and 100% free/local.</a:t>
-            </a:r>
-          </a:p>
-          <a:p>
-            <a:pPr>
-              <a:spcAft>
-                <a:spcPts val="900"/>
-              </a:spcAft>
-            </a:pPr>
-            <a:r>
-              <a:rPr sz="1800" b="0" i="0">
-                <a:solidFill>
-                  <a:srgbClr val="1E293B"/>
-                </a:solidFill>
-                <a:latin typeface="Segoe UI"/>
-              </a:rPr>
-              <a:t>•  Extends to production: swap synthetic data for real tables behind the same catalog. Thank you — questions?</a:t>
-            </a:r>
-          </a:p>
-        </p:txBody>
-      </p:sp>
-      <p:sp>
-        <p:nvSpPr>
-          <p:cNvPr id="6" name="TextBox 5"/>
-          <p:cNvSpPr txBox="1"/>
-          <p:nvPr/>
-        </p:nvSpPr>
-        <p:spPr>
-          <a:xfrm>
-            <a:off x="548640" y="6400800"/>
-            <a:ext cx="10607040" cy="365760"/>
-          </a:xfrm>
-          <a:prstGeom prst="rect">
-            <a:avLst/>
-          </a:prstGeom>
-          <a:noFill/>
-        </p:spPr>
-        <p:txBody>
-          <a:bodyPr wrap="square">
-            <a:spAutoFit/>
-          </a:bodyPr>
-          <a:lstStyle/>
-          <a:p>
-            <a:pPr>
-              <a:spcAft>
-                <a:spcPts val="800"/>
-              </a:spcAft>
-            </a:pPr>
-            <a:r>
-              <a:rPr sz="1000" b="0" i="0">
-                <a:solidFill>
-                  <a:srgbClr val="475569"/>
-                </a:solidFill>
-                <a:latin typeface="Segoe UI"/>
-              </a:rPr>
-              <a:t>Omnichannel Retail Analytics Assistant  ·  CMU Capstone  ·  8-min</a:t>
-            </a:r>
-          </a:p>
-        </p:txBody>
-      </p:sp>
-      <p:sp>
-        <p:nvSpPr>
-          <p:cNvPr id="7" name="TextBox 6"/>
-          <p:cNvSpPr txBox="1"/>
-          <p:nvPr/>
-        </p:nvSpPr>
-        <p:spPr>
-          <a:xfrm>
-            <a:off x="11430000" y="6400800"/>
-            <a:ext cx="548640" cy="365760"/>
-          </a:xfrm>
-          <a:prstGeom prst="rect">
-            <a:avLst/>
-          </a:prstGeom>
-          <a:noFill/>
-        </p:spPr>
-        <p:txBody>
-          <a:bodyPr wrap="square">
-            <a:spAutoFit/>
-          </a:bodyPr>
-          <a:lstStyle/>
-          <a:p>
-            <a:pPr>
-              <a:spcAft>
-                <a:spcPts val="800"/>
-              </a:spcAft>
-            </a:pPr>
-            <a:r>
-              <a:rPr sz="1100" b="1" i="0">
-                <a:solidFill>
-                  <a:srgbClr val="475569"/>
-                </a:solidFill>
-                <a:latin typeface="Segoe UI"/>
-              </a:rPr>
-              <a:t>5</a:t>
-            </a:r>
-          </a:p>
-        </p:txBody>
-      </p:sp>
+      </p:pic>
     </p:spTree>
   </p:cSld>
   <p:clrMapOvr>

</xml_diff>

<commit_message>
Redesign 8-min deck with a drawn architecture diagram (#18)
Co-authored-by: Claude <noreply@anthropic.com>
</commit_message>
<xml_diff>
--- a/presentation/Omnichannel_8min.pptx
+++ b/presentation/Omnichannel_8min.pptx
@@ -506,7 +506,7 @@
           <a:lstStyle/>
           <a:p>
             <a:r>
-              <a:t>0:00–0:35. Say the 9-second pitch verbatim, then read the 4-part agenda in one line so they know the shape: pitch, architecture + concepts, demo, code walkthrough. Move fast.</a:t>
+              <a:t>0:00–0:35. Say the pitch verbatim (big text), then read the 4 chips as your agenda. Energy up.</a:t>
             </a:r>
           </a:p>
         </p:txBody>
@@ -576,7 +576,7 @@
           <a:lstStyle/>
           <a:p>
             <a:r>
-              <a:t>0:35–2:35 (~2 min). This is the 'architecture + concepts' segment. Walk the loop left-to-right ONCE, then point at the bracketed concept tags — that's you naming the program vocabulary out loud: governance/semantic layer, RAG, knowledge graph, multi-agent, Tree-of-Thoughts/beam, LLM grounding, responsible AI. The ONE principle to land: facts come from governed SQL over certified metrics; the LLM only phrases them. You'll prove each of these in the code walkthrough next.</a:t>
+              <a:t>0:35–2:35 (~2 min) — centerpiece. Trace it: a question comes in; the LangGraph ORCHESTRATOR runs a governed loop — RETRIEVES certified context (RAG/ChromaDB), VALIDATES vs the YAML catalog, RELATES metric→drivers via a NetworkX knowledge graph. It dispatches a TEAM of 7 analysts in PARALLEL; a CRITIC scores each on a 0–14 rubric, BEAM keeps the strongest, every recommendation goes to an owner for review. Two anchors: the whole loop runs inside GUARDRAILS (top band: read-only, version-gated, write-refusing, audited), fed by the GOVERNED FOUNDATION (YAML = source of truth, DuckDB read-only). Close: 'the LLM only drafts the wording — every number comes from governed SQL.' Point at each chip.</a:t>
             </a:r>
           </a:p>
         </p:txBody>
@@ -646,7 +646,7 @@
           <a:lstStyle/>
           <a:p>
             <a:r>
-              <a:t>2:35–5:00 (~2.5 min). App already running and WARMED UP. (1) Run the conversion investigation; narrate the governed steps as the trace streams; land on Business answer → Evidence chart → owner actions + 🔴 human-review banner. (2) Type a write request → it refuses (fast, always lands). (3) Run one briefing. If time is tight, do #1 and #2 only. Keep a backup screenshot.</a:t>
+              <a:t>2:35–5:00. App running and WARMED UP. (1) Run the conversion investigation; narrate the steps as the trace streams; land on Business answer → Evidence chart → owner actions + 🔴 human-review banner. (2) Type a write request → it refuses (fast, always lands). (3) One briefing. Short on time → #1 and #2 only. Keep a backup screenshot.</a:t>
             </a:r>
           </a:p>
         </p:txBody>
@@ -716,7 +716,7 @@
           <a:lstStyle/>
           <a:p>
             <a:r>
-              <a:t>5:00–7:30 (~2.5 min). Switch to your editor (VS Code). Open these SIX files in THIS order and say ONE sentence each (see the 'Code walkthrough — fast script' in CAPSTONE_SUBMISSION.md). Goal: show you understand the concepts, not read code line-by-line. The closer: in tot_skill.py point at ungoverned_branch() being pruned automatically — 'governance isn't a prompt, it's enforced.' If short on time, do metrics.yaml → sql_skill → graph.py → tot_skill (the 4 that best show understanding). Keep the files pre-opened as tabs so you don't fumble.</a:t>
+              <a:t>5:00–7:30 (~2.5 min). Switch to VS Code with these SIX files PRE-OPENED as tabs. Open in order; ONE sentence each. Goal: show you understand the concepts, not read code. End on ungoverned_branch() being auto-pruned. Short on time → the four starred files. Bump editor font so it's readable on video.</a:t>
             </a:r>
           </a:p>
         </p:txBody>
@@ -786,7 +786,7 @@
           <a:lstStyle/>
           <a:p>
             <a:r>
-              <a:t>7:30–8:00. Tie back to the opening promise (fast AND trustworthy) and deliver the one-sentence lesson. Drop the evaluation numbers as proof in one breath. One line on the production path, then thank them and open Q&amp;A.</a:t>
+              <a:t>7:30–8:00. Tie back to fast AND trustworthy. Deliver the one-sentence lesson slowly. Sweep the proof chips in one breath. One line on the production path, thank them, open Q&amp;A.</a:t>
             </a:r>
           </a:p>
         </p:txBody>
@@ -3792,12 +3792,20 @@
         <p:nvPr/>
       </p:nvGrpSpPr>
       <p:grpSpPr/>
-      <p:sp>
-        <p:nvSpPr>
-          <p:cNvPr id="2" name="Rectangle 1"/>
-          <p:cNvSpPr/>
+      <p:pic>
+        <p:nvPicPr>
+          <p:cNvPr id="2" name="Picture 1" descr="s1.png"/>
+          <p:cNvPicPr>
+            <a:picLocks noChangeAspect="1"/>
+          </p:cNvPicPr>
           <p:nvPr/>
-        </p:nvSpPr>
+        </p:nvPicPr>
+        <p:blipFill>
+          <a:blip r:embed="rId2"/>
+          <a:stretch>
+            <a:fillRect/>
+          </a:stretch>
+        </p:blipFill>
         <p:spPr>
           <a:xfrm>
             <a:off x="0" y="0"/>
@@ -3806,252 +3814,8 @@
           <a:prstGeom prst="rect">
             <a:avLst/>
           </a:prstGeom>
-          <a:solidFill>
-            <a:srgbClr val="1E293B"/>
-          </a:solidFill>
-          <a:ln>
-            <a:noFill/>
-          </a:ln>
-          <a:effectLst/>
         </p:spPr>
-        <p:style>
-          <a:lnRef idx="1">
-            <a:schemeClr val="accent1"/>
-          </a:lnRef>
-          <a:fillRef idx="3">
-            <a:schemeClr val="accent1"/>
-          </a:fillRef>
-          <a:effectRef idx="2">
-            <a:schemeClr val="accent1"/>
-          </a:effectRef>
-          <a:fontRef idx="minor">
-            <a:schemeClr val="lt1"/>
-          </a:fontRef>
-        </p:style>
-        <p:txBody>
-          <a:bodyPr rtlCol="0" anchor="ctr"/>
-          <a:lstStyle/>
-          <a:p>
-            <a:pPr algn="ctr"/>
-          </a:p>
-        </p:txBody>
-      </p:sp>
-      <p:sp>
-        <p:nvSpPr>
-          <p:cNvPr id="3" name="Rectangle 2"/>
-          <p:cNvSpPr/>
-          <p:nvPr/>
-        </p:nvSpPr>
-        <p:spPr>
-          <a:xfrm>
-            <a:off x="0" y="2148840"/>
-            <a:ext cx="12191695" cy="91440"/>
-          </a:xfrm>
-          <a:prstGeom prst="rect">
-            <a:avLst/>
-          </a:prstGeom>
-          <a:solidFill>
-            <a:srgbClr val="C41230"/>
-          </a:solidFill>
-          <a:ln>
-            <a:noFill/>
-          </a:ln>
-          <a:effectLst/>
-        </p:spPr>
-        <p:style>
-          <a:lnRef idx="1">
-            <a:schemeClr val="accent1"/>
-          </a:lnRef>
-          <a:fillRef idx="3">
-            <a:schemeClr val="accent1"/>
-          </a:fillRef>
-          <a:effectRef idx="2">
-            <a:schemeClr val="accent1"/>
-          </a:effectRef>
-          <a:fontRef idx="minor">
-            <a:schemeClr val="lt1"/>
-          </a:fontRef>
-        </p:style>
-        <p:txBody>
-          <a:bodyPr rtlCol="0" anchor="ctr"/>
-          <a:lstStyle/>
-          <a:p>
-            <a:pPr algn="ctr"/>
-          </a:p>
-        </p:txBody>
-      </p:sp>
-      <p:sp>
-        <p:nvSpPr>
-          <p:cNvPr id="4" name="TextBox 3"/>
-          <p:cNvSpPr txBox="1"/>
-          <p:nvPr/>
-        </p:nvSpPr>
-        <p:spPr>
-          <a:xfrm>
-            <a:off x="822960" y="1051560"/>
-            <a:ext cx="10515600" cy="1005840"/>
-          </a:xfrm>
-          <a:prstGeom prst="rect">
-            <a:avLst/>
-          </a:prstGeom>
-          <a:noFill/>
-        </p:spPr>
-        <p:txBody>
-          <a:bodyPr wrap="square">
-            <a:spAutoFit/>
-          </a:bodyPr>
-          <a:lstStyle/>
-          <a:p>
-            <a:pPr>
-              <a:spcAft>
-                <a:spcPts val="800"/>
-              </a:spcAft>
-            </a:pPr>
-            <a:r>
-              <a:rPr sz="4000" b="1" i="0">
-                <a:solidFill>
-                  <a:srgbClr val="FFFFFF"/>
-                </a:solidFill>
-                <a:latin typeface="Segoe UI"/>
-              </a:rPr>
-              <a:t>Omnichannel Retail Analytics Assistant</a:t>
-            </a:r>
-          </a:p>
-        </p:txBody>
-      </p:sp>
-      <p:sp>
-        <p:nvSpPr>
-          <p:cNvPr id="5" name="TextBox 4"/>
-          <p:cNvSpPr txBox="1"/>
-          <p:nvPr/>
-        </p:nvSpPr>
-        <p:spPr>
-          <a:xfrm>
-            <a:off x="822960" y="2377440"/>
-            <a:ext cx="10515600" cy="1371600"/>
-          </a:xfrm>
-          <a:prstGeom prst="rect">
-            <a:avLst/>
-          </a:prstGeom>
-          <a:noFill/>
-        </p:spPr>
-        <p:txBody>
-          <a:bodyPr wrap="square">
-            <a:spAutoFit/>
-          </a:bodyPr>
-          <a:lstStyle/>
-          <a:p>
-            <a:pPr>
-              <a:spcAft>
-                <a:spcPts val="200"/>
-              </a:spcAft>
-            </a:pPr>
-            <a:r>
-              <a:rPr sz="2100" b="0" i="0">
-                <a:solidFill>
-                  <a:srgbClr val="F1F5F9"/>
-                </a:solidFill>
-                <a:latin typeface="Segoe UI"/>
-              </a:rPr>
-              <a:t>A governed AI analyst that tells retail leaders why a KPI moved —</a:t>
-            </a:r>
-          </a:p>
-          <a:p>
-            <a:pPr>
-              <a:spcAft>
-                <a:spcPts val="800"/>
-              </a:spcAft>
-            </a:pPr>
-            <a:r>
-              <a:rPr sz="2100" b="0" i="0">
-                <a:solidFill>
-                  <a:srgbClr val="F1F5F9"/>
-                </a:solidFill>
-                <a:latin typeface="Segoe UI"/>
-              </a:rPr>
-              <a:t>across every team, in seconds, using only certified data. It never guesses.</a:t>
-            </a:r>
-          </a:p>
-        </p:txBody>
-      </p:sp>
-      <p:sp>
-        <p:nvSpPr>
-          <p:cNvPr id="6" name="TextBox 5"/>
-          <p:cNvSpPr txBox="1"/>
-          <p:nvPr/>
-        </p:nvSpPr>
-        <p:spPr>
-          <a:xfrm>
-            <a:off x="822960" y="4114800"/>
-            <a:ext cx="10515600" cy="1371600"/>
-          </a:xfrm>
-          <a:prstGeom prst="rect">
-            <a:avLst/>
-          </a:prstGeom>
-          <a:noFill/>
-        </p:spPr>
-        <p:txBody>
-          <a:bodyPr wrap="square">
-            <a:spAutoFit/>
-          </a:bodyPr>
-          <a:lstStyle/>
-          <a:p>
-            <a:pPr>
-              <a:spcAft>
-                <a:spcPts val="800"/>
-              </a:spcAft>
-            </a:pPr>
-            <a:r>
-              <a:rPr sz="1600" b="1" i="0">
-                <a:solidFill>
-                  <a:srgbClr val="FFFFFF"/>
-                </a:solidFill>
-                <a:latin typeface="Segoe UI"/>
-              </a:rPr>
-              <a:t>Today (8 min):  1) the pitch   2) architecture &amp; concepts   3) live demo   4) a quick code walkthrough</a:t>
-            </a:r>
-          </a:p>
-        </p:txBody>
-      </p:sp>
-      <p:sp>
-        <p:nvSpPr>
-          <p:cNvPr id="7" name="TextBox 6"/>
-          <p:cNvSpPr txBox="1"/>
-          <p:nvPr/>
-        </p:nvSpPr>
-        <p:spPr>
-          <a:xfrm>
-            <a:off x="822960" y="5943600"/>
-            <a:ext cx="10515600" cy="548640"/>
-          </a:xfrm>
-          <a:prstGeom prst="rect">
-            <a:avLst/>
-          </a:prstGeom>
-          <a:noFill/>
-        </p:spPr>
-        <p:txBody>
-          <a:bodyPr wrap="square">
-            <a:spAutoFit/>
-          </a:bodyPr>
-          <a:lstStyle/>
-          <a:p>
-            <a:pPr>
-              <a:spcAft>
-                <a:spcPts val="800"/>
-              </a:spcAft>
-            </a:pPr>
-            <a:r>
-              <a:rPr sz="1300" b="0" i="0">
-                <a:solidFill>
-                  <a:srgbClr val="94A3B8"/>
-                </a:solidFill>
-                <a:latin typeface="Segoe UI"/>
-              </a:rPr>
-              <a:t>Final Capstone  ·  Carnegie Mellon University  ·  Sreddy  ·  June 2026</a:t>
-            </a:r>
-          </a:p>
-        </p:txBody>
-      </p:sp>
+      </p:pic>
     </p:spTree>
   </p:cSld>
   <p:clrMapOvr>
@@ -4070,325 +3834,30 @@
         <p:nvPr/>
       </p:nvGrpSpPr>
       <p:grpSpPr/>
-      <p:sp>
-        <p:nvSpPr>
-          <p:cNvPr id="2" name="Rectangle 1"/>
-          <p:cNvSpPr/>
+      <p:pic>
+        <p:nvPicPr>
+          <p:cNvPr id="2" name="Picture 1" descr="s2.png"/>
+          <p:cNvPicPr>
+            <a:picLocks noChangeAspect="1"/>
+          </p:cNvPicPr>
           <p:nvPr/>
-        </p:nvSpPr>
+        </p:nvPicPr>
+        <p:blipFill>
+          <a:blip r:embed="rId2"/>
+          <a:stretch>
+            <a:fillRect/>
+          </a:stretch>
+        </p:blipFill>
         <p:spPr>
           <a:xfrm>
             <a:off x="0" y="0"/>
-            <a:ext cx="12191695" cy="164592"/>
+            <a:ext cx="12191695" cy="6858000"/>
           </a:xfrm>
           <a:prstGeom prst="rect">
             <a:avLst/>
           </a:prstGeom>
-          <a:solidFill>
-            <a:srgbClr val="C41230"/>
-          </a:solidFill>
-          <a:ln>
-            <a:noFill/>
-          </a:ln>
-          <a:effectLst/>
         </p:spPr>
-        <p:style>
-          <a:lnRef idx="1">
-            <a:schemeClr val="accent1"/>
-          </a:lnRef>
-          <a:fillRef idx="3">
-            <a:schemeClr val="accent1"/>
-          </a:fillRef>
-          <a:effectRef idx="2">
-            <a:schemeClr val="accent1"/>
-          </a:effectRef>
-          <a:fontRef idx="minor">
-            <a:schemeClr val="lt1"/>
-          </a:fontRef>
-        </p:style>
-        <p:txBody>
-          <a:bodyPr rtlCol="0" anchor="ctr"/>
-          <a:lstStyle/>
-          <a:p>
-            <a:pPr algn="ctr"/>
-          </a:p>
-        </p:txBody>
-      </p:sp>
-      <p:sp>
-        <p:nvSpPr>
-          <p:cNvPr id="3" name="TextBox 2"/>
-          <p:cNvSpPr txBox="1"/>
-          <p:nvPr/>
-        </p:nvSpPr>
-        <p:spPr>
-          <a:xfrm>
-            <a:off x="548640" y="384048"/>
-            <a:ext cx="11064240" cy="365760"/>
-          </a:xfrm>
-          <a:prstGeom prst="rect">
-            <a:avLst/>
-          </a:prstGeom>
-          <a:noFill/>
-        </p:spPr>
-        <p:txBody>
-          <a:bodyPr wrap="square">
-            <a:spAutoFit/>
-          </a:bodyPr>
-          <a:lstStyle/>
-          <a:p>
-            <a:pPr>
-              <a:spcAft>
-                <a:spcPts val="200"/>
-              </a:spcAft>
-            </a:pPr>
-            <a:r>
-              <a:rPr sz="1300" b="1" i="0">
-                <a:solidFill>
-                  <a:srgbClr val="C41230"/>
-                </a:solidFill>
-                <a:latin typeface="Segoe UI"/>
-              </a:rPr>
-              <a:t>PART 2 · ARCHITECTURE &amp; THE CONCEPTS I USED</a:t>
-            </a:r>
-          </a:p>
-        </p:txBody>
-      </p:sp>
-      <p:sp>
-        <p:nvSpPr>
-          <p:cNvPr id="4" name="TextBox 3"/>
-          <p:cNvSpPr txBox="1"/>
-          <p:nvPr/>
-        </p:nvSpPr>
-        <p:spPr>
-          <a:xfrm>
-            <a:off x="548640" y="749808"/>
-            <a:ext cx="11064240" cy="914400"/>
-          </a:xfrm>
-          <a:prstGeom prst="rect">
-            <a:avLst/>
-          </a:prstGeom>
-          <a:noFill/>
-        </p:spPr>
-        <p:txBody>
-          <a:bodyPr wrap="square">
-            <a:spAutoFit/>
-          </a:bodyPr>
-          <a:lstStyle/>
-          <a:p>
-            <a:pPr>
-              <a:spcAft>
-                <a:spcPts val="0"/>
-              </a:spcAft>
-            </a:pPr>
-            <a:r>
-              <a:rPr sz="2900" b="1" i="0">
-                <a:solidFill>
-                  <a:srgbClr val="1E293B"/>
-                </a:solidFill>
-                <a:latin typeface="Segoe UI"/>
-              </a:rPr>
-              <a:t>Governed knowledge + a multi-agent reasoning loop</a:t>
-            </a:r>
-          </a:p>
-        </p:txBody>
-      </p:sp>
-      <p:sp>
-        <p:nvSpPr>
-          <p:cNvPr id="5" name="TextBox 4"/>
-          <p:cNvSpPr txBox="1"/>
-          <p:nvPr/>
-        </p:nvSpPr>
-        <p:spPr>
-          <a:xfrm>
-            <a:off x="640080" y="1737360"/>
-            <a:ext cx="10881360" cy="4480560"/>
-          </a:xfrm>
-          <a:prstGeom prst="rect">
-            <a:avLst/>
-          </a:prstGeom>
-          <a:noFill/>
-        </p:spPr>
-        <p:txBody>
-          <a:bodyPr wrap="square">
-            <a:spAutoFit/>
-          </a:bodyPr>
-          <a:lstStyle/>
-          <a:p>
-            <a:pPr>
-              <a:spcAft>
-                <a:spcPts val="900"/>
-              </a:spcAft>
-            </a:pPr>
-            <a:r>
-              <a:rPr sz="1800" b="0" i="0">
-                <a:solidFill>
-                  <a:srgbClr val="1E293B"/>
-                </a:solidFill>
-                <a:latin typeface="Segoe UI"/>
-              </a:rPr>
-              <a:t>•  Source of truth — a versioned, hashed YAML catalog of certified metrics, approved tables, drivers, and guardrails.   [data governance / semantic layer]</a:t>
-            </a:r>
-          </a:p>
-          <a:p>
-            <a:pPr>
-              <a:spcAft>
-                <a:spcPts val="900"/>
-              </a:spcAft>
-            </a:pPr>
-            <a:r>
-              <a:rPr sz="1800" b="0" i="0">
-                <a:solidFill>
-                  <a:srgbClr val="1E293B"/>
-                </a:solidFill>
-                <a:latin typeface="Segoe UI"/>
-              </a:rPr>
-              <a:t>•  The loop (LangGraph state machine):   classify → retrieve → validate → relate → baseline → dispatch team → critic + beam → human review → answer.   [agent orchestration / ReAct]</a:t>
-            </a:r>
-          </a:p>
-          <a:p>
-            <a:pPr>
-              <a:spcAft>
-                <a:spcPts val="900"/>
-              </a:spcAft>
-            </a:pPr>
-            <a:r>
-              <a:rPr sz="1800" b="0" i="0">
-                <a:solidFill>
-                  <a:srgbClr val="1E293B"/>
-                </a:solidFill>
-                <a:latin typeface="Segoe UI"/>
-              </a:rPr>
-              <a:t>•  retrieve = RAG over a ChromaDB vector index;  relate = a NetworkX knowledge graph (metric → driver → table → owner).   [RAG + embeddings · knowledge graph]</a:t>
-            </a:r>
-          </a:p>
-          <a:p>
-            <a:pPr>
-              <a:spcAft>
-                <a:spcPts val="900"/>
-              </a:spcAft>
-            </a:pPr>
-            <a:r>
-              <a:rPr sz="1800" b="0" i="0">
-                <a:solidFill>
-                  <a:srgbClr val="1E293B"/>
-                </a:solidFill>
-                <a:latin typeface="Segoe UI"/>
-              </a:rPr>
-              <a:t>•  dispatch = 7 specialized analysts run in parallel;  the Critic scores each on a 0–14 rubric and beam search keeps the strongest.   [multi-agent systems · Tree-of-Thoughts + beam]</a:t>
-            </a:r>
-          </a:p>
-          <a:p>
-            <a:pPr>
-              <a:spcAft>
-                <a:spcPts val="900"/>
-              </a:spcAft>
-            </a:pPr>
-            <a:r>
-              <a:rPr sz="1800" b="1" i="0">
-                <a:solidFill>
-                  <a:srgbClr val="1E293B"/>
-                </a:solidFill>
-                <a:latin typeface="Segoe UI"/>
-              </a:rPr>
-              <a:t>•  The LLM only DRAFTS the prose — every number comes from governed SQL.   [LLM grounding]</a:t>
-            </a:r>
-          </a:p>
-          <a:p>
-            <a:pPr>
-              <a:spcAft>
-                <a:spcPts val="900"/>
-              </a:spcAft>
-            </a:pPr>
-            <a:r>
-              <a:rPr sz="1800" b="0" i="0">
-                <a:solidFill>
-                  <a:srgbClr val="1E293B"/>
-                </a:solidFill>
-                <a:latin typeface="Segoe UI"/>
-              </a:rPr>
-              <a:t>•  Read-only · causality labeled (not asserted) · human-in-the-loop · full audit trail.   [responsible AI / governance]</a:t>
-            </a:r>
-          </a:p>
-        </p:txBody>
-      </p:sp>
-      <p:sp>
-        <p:nvSpPr>
-          <p:cNvPr id="6" name="TextBox 5"/>
-          <p:cNvSpPr txBox="1"/>
-          <p:nvPr/>
-        </p:nvSpPr>
-        <p:spPr>
-          <a:xfrm>
-            <a:off x="548640" y="6400800"/>
-            <a:ext cx="10607040" cy="365760"/>
-          </a:xfrm>
-          <a:prstGeom prst="rect">
-            <a:avLst/>
-          </a:prstGeom>
-          <a:noFill/>
-        </p:spPr>
-        <p:txBody>
-          <a:bodyPr wrap="square">
-            <a:spAutoFit/>
-          </a:bodyPr>
-          <a:lstStyle/>
-          <a:p>
-            <a:pPr>
-              <a:spcAft>
-                <a:spcPts val="800"/>
-              </a:spcAft>
-            </a:pPr>
-            <a:r>
-              <a:rPr sz="1000" b="0" i="0">
-                <a:solidFill>
-                  <a:srgbClr val="475569"/>
-                </a:solidFill>
-                <a:latin typeface="Segoe UI"/>
-              </a:rPr>
-              <a:t>Omnichannel Retail Analytics Assistant  ·  CMU Capstone  ·  8-min</a:t>
-            </a:r>
-          </a:p>
-        </p:txBody>
-      </p:sp>
-      <p:sp>
-        <p:nvSpPr>
-          <p:cNvPr id="7" name="TextBox 6"/>
-          <p:cNvSpPr txBox="1"/>
-          <p:nvPr/>
-        </p:nvSpPr>
-        <p:spPr>
-          <a:xfrm>
-            <a:off x="11430000" y="6400800"/>
-            <a:ext cx="548640" cy="365760"/>
-          </a:xfrm>
-          <a:prstGeom prst="rect">
-            <a:avLst/>
-          </a:prstGeom>
-          <a:noFill/>
-        </p:spPr>
-        <p:txBody>
-          <a:bodyPr wrap="square">
-            <a:spAutoFit/>
-          </a:bodyPr>
-          <a:lstStyle/>
-          <a:p>
-            <a:pPr>
-              <a:spcAft>
-                <a:spcPts val="800"/>
-              </a:spcAft>
-            </a:pPr>
-            <a:r>
-              <a:rPr sz="1100" b="1" i="0">
-                <a:solidFill>
-                  <a:srgbClr val="475569"/>
-                </a:solidFill>
-                <a:latin typeface="Segoe UI"/>
-              </a:rPr>
-              <a:t>2</a:t>
-            </a:r>
-          </a:p>
-        </p:txBody>
-      </p:sp>
+      </p:pic>
     </p:spTree>
   </p:cSld>
   <p:clrMapOvr>
@@ -4407,12 +3876,20 @@
         <p:nvPr/>
       </p:nvGrpSpPr>
       <p:grpSpPr/>
-      <p:sp>
-        <p:nvSpPr>
-          <p:cNvPr id="2" name="Rectangle 1"/>
-          <p:cNvSpPr/>
+      <p:pic>
+        <p:nvPicPr>
+          <p:cNvPr id="2" name="Picture 1" descr="s3.png"/>
+          <p:cNvPicPr>
+            <a:picLocks noChangeAspect="1"/>
+          </p:cNvPicPr>
           <p:nvPr/>
-        </p:nvSpPr>
+        </p:nvPicPr>
+        <p:blipFill>
+          <a:blip r:embed="rId2"/>
+          <a:stretch>
+            <a:fillRect/>
+          </a:stretch>
+        </p:blipFill>
         <p:spPr>
           <a:xfrm>
             <a:off x="0" y="0"/>
@@ -4421,268 +3898,8 @@
           <a:prstGeom prst="rect">
             <a:avLst/>
           </a:prstGeom>
-          <a:solidFill>
-            <a:srgbClr val="1E293B"/>
-          </a:solidFill>
-          <a:ln>
-            <a:noFill/>
-          </a:ln>
-          <a:effectLst/>
         </p:spPr>
-        <p:style>
-          <a:lnRef idx="1">
-            <a:schemeClr val="accent1"/>
-          </a:lnRef>
-          <a:fillRef idx="3">
-            <a:schemeClr val="accent1"/>
-          </a:fillRef>
-          <a:effectRef idx="2">
-            <a:schemeClr val="accent1"/>
-          </a:effectRef>
-          <a:fontRef idx="minor">
-            <a:schemeClr val="lt1"/>
-          </a:fontRef>
-        </p:style>
-        <p:txBody>
-          <a:bodyPr rtlCol="0" anchor="ctr"/>
-          <a:lstStyle/>
-          <a:p>
-            <a:pPr algn="ctr"/>
-          </a:p>
-        </p:txBody>
-      </p:sp>
-      <p:sp>
-        <p:nvSpPr>
-          <p:cNvPr id="3" name="Rectangle 2"/>
-          <p:cNvSpPr/>
-          <p:nvPr/>
-        </p:nvSpPr>
-        <p:spPr>
-          <a:xfrm>
-            <a:off x="0" y="2331720"/>
-            <a:ext cx="12191695" cy="91440"/>
-          </a:xfrm>
-          <a:prstGeom prst="rect">
-            <a:avLst/>
-          </a:prstGeom>
-          <a:solidFill>
-            <a:srgbClr val="C41230"/>
-          </a:solidFill>
-          <a:ln>
-            <a:noFill/>
-          </a:ln>
-          <a:effectLst/>
-        </p:spPr>
-        <p:style>
-          <a:lnRef idx="1">
-            <a:schemeClr val="accent1"/>
-          </a:lnRef>
-          <a:fillRef idx="3">
-            <a:schemeClr val="accent1"/>
-          </a:fillRef>
-          <a:effectRef idx="2">
-            <a:schemeClr val="accent1"/>
-          </a:effectRef>
-          <a:fontRef idx="minor">
-            <a:schemeClr val="lt1"/>
-          </a:fontRef>
-        </p:style>
-        <p:txBody>
-          <a:bodyPr rtlCol="0" anchor="ctr"/>
-          <a:lstStyle/>
-          <a:p>
-            <a:pPr algn="ctr"/>
-          </a:p>
-        </p:txBody>
-      </p:sp>
-      <p:sp>
-        <p:nvSpPr>
-          <p:cNvPr id="4" name="TextBox 3"/>
-          <p:cNvSpPr txBox="1"/>
-          <p:nvPr/>
-        </p:nvSpPr>
-        <p:spPr>
-          <a:xfrm>
-            <a:off x="822960" y="1463040"/>
-            <a:ext cx="10515600" cy="457200"/>
-          </a:xfrm>
-          <a:prstGeom prst="rect">
-            <a:avLst/>
-          </a:prstGeom>
-          <a:noFill/>
-        </p:spPr>
-        <p:txBody>
-          <a:bodyPr wrap="square">
-            <a:spAutoFit/>
-          </a:bodyPr>
-          <a:lstStyle/>
-          <a:p>
-            <a:pPr>
-              <a:spcAft>
-                <a:spcPts val="800"/>
-              </a:spcAft>
-            </a:pPr>
-            <a:r>
-              <a:rPr sz="1700" b="1" i="0">
-                <a:solidFill>
-                  <a:srgbClr val="F87171"/>
-                </a:solidFill>
-                <a:latin typeface="Segoe UI"/>
-              </a:rPr>
-              <a:t>PART 3 · LIVE DEMO (~2.5 MIN)</a:t>
-            </a:r>
-          </a:p>
-        </p:txBody>
-      </p:sp>
-      <p:sp>
-        <p:nvSpPr>
-          <p:cNvPr id="5" name="TextBox 4"/>
-          <p:cNvSpPr txBox="1"/>
-          <p:nvPr/>
-        </p:nvSpPr>
-        <p:spPr>
-          <a:xfrm>
-            <a:off x="822960" y="2423160"/>
-            <a:ext cx="10515600" cy="914400"/>
-          </a:xfrm>
-          <a:prstGeom prst="rect">
-            <a:avLst/>
-          </a:prstGeom>
-          <a:noFill/>
-        </p:spPr>
-        <p:txBody>
-          <a:bodyPr wrap="square">
-            <a:spAutoFit/>
-          </a:bodyPr>
-          <a:lstStyle/>
-          <a:p>
-            <a:pPr>
-              <a:spcAft>
-                <a:spcPts val="800"/>
-              </a:spcAft>
-            </a:pPr>
-            <a:r>
-              <a:rPr sz="3200" b="1" i="0">
-                <a:solidFill>
-                  <a:srgbClr val="FFFFFF"/>
-                </a:solidFill>
-                <a:latin typeface="Segoe UI"/>
-              </a:rPr>
-              <a:t>Seeing it run on a seeded 'bad day'</a:t>
-            </a:r>
-          </a:p>
-        </p:txBody>
-      </p:sp>
-      <p:sp>
-        <p:nvSpPr>
-          <p:cNvPr id="6" name="TextBox 5"/>
-          <p:cNvSpPr txBox="1"/>
-          <p:nvPr/>
-        </p:nvSpPr>
-        <p:spPr>
-          <a:xfrm>
-            <a:off x="822960" y="3566160"/>
-            <a:ext cx="10515600" cy="2560320"/>
-          </a:xfrm>
-          <a:prstGeom prst="rect">
-            <a:avLst/>
-          </a:prstGeom>
-          <a:noFill/>
-        </p:spPr>
-        <p:txBody>
-          <a:bodyPr wrap="square">
-            <a:spAutoFit/>
-          </a:bodyPr>
-          <a:lstStyle/>
-          <a:p>
-            <a:pPr>
-              <a:spcAft>
-                <a:spcPts val="800"/>
-              </a:spcAft>
-            </a:pPr>
-            <a:r>
-              <a:rPr sz="1600" b="0" i="0">
-                <a:solidFill>
-                  <a:srgbClr val="F1F5F9"/>
-                </a:solidFill>
-                <a:latin typeface="Segoe UI"/>
-              </a:rPr>
-              <a:t>1.  'Why did conversion drop yesterday?' → team dispatch + live trace → drivers &amp; evidence chart → owner actions + the human-review banner.</a:t>
-            </a:r>
-          </a:p>
-          <a:p>
-            <a:pPr>
-              <a:spcAft>
-                <a:spcPts val="800"/>
-              </a:spcAft>
-            </a:pPr>
-            <a:r>
-              <a:rPr sz="1600" b="0" i="0">
-                <a:solidFill>
-                  <a:srgbClr val="F1F5F9"/>
-                </a:solidFill>
-                <a:latin typeface="Segoe UI"/>
-              </a:rPr>
-              <a:t>2.  'Update the paid-social budget' → the read-only guardrail refuses.</a:t>
-            </a:r>
-          </a:p>
-          <a:p>
-            <a:pPr>
-              <a:spcAft>
-                <a:spcPts val="800"/>
-              </a:spcAft>
-            </a:pPr>
-            <a:r>
-              <a:rPr sz="1600" b="0" i="0">
-                <a:solidFill>
-                  <a:srgbClr val="F1F5F9"/>
-                </a:solidFill>
-                <a:latin typeface="Segoe UI"/>
-              </a:rPr>
-              <a:t>3.  An executive briefing → the multi-agent path ranks the biggest cross-functional issues.</a:t>
-            </a:r>
-          </a:p>
-        </p:txBody>
-      </p:sp>
-      <p:sp>
-        <p:nvSpPr>
-          <p:cNvPr id="7" name="TextBox 6"/>
-          <p:cNvSpPr txBox="1"/>
-          <p:nvPr/>
-        </p:nvSpPr>
-        <p:spPr>
-          <a:xfrm>
-            <a:off x="11430000" y="6400800"/>
-            <a:ext cx="548640" cy="365760"/>
-          </a:xfrm>
-          <a:prstGeom prst="rect">
-            <a:avLst/>
-          </a:prstGeom>
-          <a:noFill/>
-        </p:spPr>
-        <p:txBody>
-          <a:bodyPr wrap="square">
-            <a:spAutoFit/>
-          </a:bodyPr>
-          <a:lstStyle/>
-          <a:p>
-            <a:pPr>
-              <a:spcAft>
-                <a:spcPts val="800"/>
-              </a:spcAft>
-            </a:pPr>
-            <a:r>
-              <a:rPr sz="1100" b="1" i="0">
-                <a:solidFill>
-                  <a:srgbClr val="94A3B8"/>
-                </a:solidFill>
-                <a:latin typeface="Segoe UI"/>
-              </a:rPr>
-              <a:t>3</a:t>
-            </a:r>
-          </a:p>
-        </p:txBody>
-      </p:sp>
+      </p:pic>
     </p:spTree>
   </p:cSld>
   <p:clrMapOvr>
@@ -4701,325 +3918,30 @@
         <p:nvPr/>
       </p:nvGrpSpPr>
       <p:grpSpPr/>
-      <p:sp>
-        <p:nvSpPr>
-          <p:cNvPr id="2" name="Rectangle 1"/>
-          <p:cNvSpPr/>
+      <p:pic>
+        <p:nvPicPr>
+          <p:cNvPr id="2" name="Picture 1" descr="s4.png"/>
+          <p:cNvPicPr>
+            <a:picLocks noChangeAspect="1"/>
+          </p:cNvPicPr>
           <p:nvPr/>
-        </p:nvSpPr>
+        </p:nvPicPr>
+        <p:blipFill>
+          <a:blip r:embed="rId2"/>
+          <a:stretch>
+            <a:fillRect/>
+          </a:stretch>
+        </p:blipFill>
         <p:spPr>
           <a:xfrm>
             <a:off x="0" y="0"/>
-            <a:ext cx="12191695" cy="164592"/>
+            <a:ext cx="12191695" cy="6858000"/>
           </a:xfrm>
           <a:prstGeom prst="rect">
             <a:avLst/>
           </a:prstGeom>
-          <a:solidFill>
-            <a:srgbClr val="C41230"/>
-          </a:solidFill>
-          <a:ln>
-            <a:noFill/>
-          </a:ln>
-          <a:effectLst/>
         </p:spPr>
-        <p:style>
-          <a:lnRef idx="1">
-            <a:schemeClr val="accent1"/>
-          </a:lnRef>
-          <a:fillRef idx="3">
-            <a:schemeClr val="accent1"/>
-          </a:fillRef>
-          <a:effectRef idx="2">
-            <a:schemeClr val="accent1"/>
-          </a:effectRef>
-          <a:fontRef idx="minor">
-            <a:schemeClr val="lt1"/>
-          </a:fontRef>
-        </p:style>
-        <p:txBody>
-          <a:bodyPr rtlCol="0" anchor="ctr"/>
-          <a:lstStyle/>
-          <a:p>
-            <a:pPr algn="ctr"/>
-          </a:p>
-        </p:txBody>
-      </p:sp>
-      <p:sp>
-        <p:nvSpPr>
-          <p:cNvPr id="3" name="TextBox 2"/>
-          <p:cNvSpPr txBox="1"/>
-          <p:nvPr/>
-        </p:nvSpPr>
-        <p:spPr>
-          <a:xfrm>
-            <a:off x="548640" y="384048"/>
-            <a:ext cx="11064240" cy="365760"/>
-          </a:xfrm>
-          <a:prstGeom prst="rect">
-            <a:avLst/>
-          </a:prstGeom>
-          <a:noFill/>
-        </p:spPr>
-        <p:txBody>
-          <a:bodyPr wrap="square">
-            <a:spAutoFit/>
-          </a:bodyPr>
-          <a:lstStyle/>
-          <a:p>
-            <a:pPr>
-              <a:spcAft>
-                <a:spcPts val="200"/>
-              </a:spcAft>
-            </a:pPr>
-            <a:r>
-              <a:rPr sz="1300" b="1" i="0">
-                <a:solidFill>
-                  <a:srgbClr val="C41230"/>
-                </a:solidFill>
-                <a:latin typeface="Segoe UI"/>
-              </a:rPr>
-              <a:t>PART 4 · QUICK CODE WALKTHROUGH</a:t>
-            </a:r>
-          </a:p>
-        </p:txBody>
-      </p:sp>
-      <p:sp>
-        <p:nvSpPr>
-          <p:cNvPr id="4" name="TextBox 3"/>
-          <p:cNvSpPr txBox="1"/>
-          <p:nvPr/>
-        </p:nvSpPr>
-        <p:spPr>
-          <a:xfrm>
-            <a:off x="548640" y="749808"/>
-            <a:ext cx="11064240" cy="914400"/>
-          </a:xfrm>
-          <a:prstGeom prst="rect">
-            <a:avLst/>
-          </a:prstGeom>
-          <a:noFill/>
-        </p:spPr>
-        <p:txBody>
-          <a:bodyPr wrap="square">
-            <a:spAutoFit/>
-          </a:bodyPr>
-          <a:lstStyle/>
-          <a:p>
-            <a:pPr>
-              <a:spcAft>
-                <a:spcPts val="0"/>
-              </a:spcAft>
-            </a:pPr>
-            <a:r>
-              <a:rPr sz="2900" b="1" i="0">
-                <a:solidFill>
-                  <a:srgbClr val="1E293B"/>
-                </a:solidFill>
-                <a:latin typeface="Segoe UI"/>
-              </a:rPr>
-              <a:t>Six files — each is one concept, end to end</a:t>
-            </a:r>
-          </a:p>
-        </p:txBody>
-      </p:sp>
-      <p:sp>
-        <p:nvSpPr>
-          <p:cNvPr id="5" name="TextBox 4"/>
-          <p:cNvSpPr txBox="1"/>
-          <p:nvPr/>
-        </p:nvSpPr>
-        <p:spPr>
-          <a:xfrm>
-            <a:off x="640080" y="1737360"/>
-            <a:ext cx="10881360" cy="4480560"/>
-          </a:xfrm>
-          <a:prstGeom prst="rect">
-            <a:avLst/>
-          </a:prstGeom>
-          <a:noFill/>
-        </p:spPr>
-        <p:txBody>
-          <a:bodyPr wrap="square">
-            <a:spAutoFit/>
-          </a:bodyPr>
-          <a:lstStyle/>
-          <a:p>
-            <a:pPr>
-              <a:spcAft>
-                <a:spcPts val="900"/>
-              </a:spcAft>
-            </a:pPr>
-            <a:r>
-              <a:rPr sz="1800" b="0" i="0">
-                <a:solidFill>
-                  <a:srgbClr val="1E293B"/>
-                </a:solidFill>
-                <a:latin typeface="Segoe UI"/>
-              </a:rPr>
-              <a:t>•  catalog/metrics.yaml — the certified definitions everything resolves to.   [governance / source of truth]</a:t>
-            </a:r>
-          </a:p>
-          <a:p>
-            <a:pPr>
-              <a:spcAft>
-                <a:spcPts val="900"/>
-              </a:spcAft>
-            </a:pPr>
-            <a:r>
-              <a:rPr sz="1800" b="0" i="0">
-                <a:solidFill>
-                  <a:srgbClr val="1E293B"/>
-                </a:solidFill>
-                <a:latin typeface="Segoe UI"/>
-              </a:rPr>
-              <a:t>•  skills/sql_skill.py · check_sql() — only read-only SELECTs over approved tables run.   [guardrails]</a:t>
-            </a:r>
-          </a:p>
-          <a:p>
-            <a:pPr>
-              <a:spcAft>
-                <a:spcPts val="900"/>
-              </a:spcAft>
-            </a:pPr>
-            <a:r>
-              <a:rPr sz="1800" b="0" i="0">
-                <a:solidFill>
-                  <a:srgbClr val="1E293B"/>
-                </a:solidFill>
-                <a:latin typeface="Segoe UI"/>
-              </a:rPr>
-              <a:t>•  skills/retrieval_skill.py · retrieve() — top-k vector lookup + a staleness/sync gate.   [RAG]</a:t>
-            </a:r>
-          </a:p>
-          <a:p>
-            <a:pPr>
-              <a:spcAft>
-                <a:spcPts val="900"/>
-              </a:spcAft>
-            </a:pPr>
-            <a:r>
-              <a:rPr sz="1800" b="0" i="0">
-                <a:solidFill>
-                  <a:srgbClr val="1E293B"/>
-                </a:solidFill>
-                <a:latin typeface="Segoe UI"/>
-              </a:rPr>
-              <a:t>•  workflows/graph.py · build_workflow() + classify_intent() — the LangGraph loop &amp; routing.   [orchestration]</a:t>
-            </a:r>
-          </a:p>
-          <a:p>
-            <a:pPr>
-              <a:spcAft>
-                <a:spcPts val="900"/>
-              </a:spcAft>
-            </a:pPr>
-            <a:r>
-              <a:rPr sz="1800" b="0" i="0">
-                <a:solidFill>
-                  <a:srgbClr val="1E293B"/>
-                </a:solidFill>
-                <a:latin typeface="Segoe UI"/>
-              </a:rPr>
-              <a:t>•  agents/team.py · dispatch() — 7 analysts in parallel; a failure is isolated.   [multi-agent]</a:t>
-            </a:r>
-          </a:p>
-          <a:p>
-            <a:pPr>
-              <a:spcAft>
-                <a:spcPts val="900"/>
-              </a:spcAft>
-            </a:pPr>
-            <a:r>
-              <a:rPr sz="1800" b="0" i="0">
-                <a:solidFill>
-                  <a:srgbClr val="1E293B"/>
-                </a:solidFill>
-                <a:latin typeface="Segoe UI"/>
-              </a:rPr>
-              <a:t>•  skills/tot_skill.py · score_branch() + ungoverned_branch() — the 0–14 rubric prunes the ungoverned 'maybe prices rose' idea automatically.   [ToT/beam + responsible AI]</a:t>
-            </a:r>
-          </a:p>
-        </p:txBody>
-      </p:sp>
-      <p:sp>
-        <p:nvSpPr>
-          <p:cNvPr id="6" name="TextBox 5"/>
-          <p:cNvSpPr txBox="1"/>
-          <p:nvPr/>
-        </p:nvSpPr>
-        <p:spPr>
-          <a:xfrm>
-            <a:off x="548640" y="6400800"/>
-            <a:ext cx="10607040" cy="365760"/>
-          </a:xfrm>
-          <a:prstGeom prst="rect">
-            <a:avLst/>
-          </a:prstGeom>
-          <a:noFill/>
-        </p:spPr>
-        <p:txBody>
-          <a:bodyPr wrap="square">
-            <a:spAutoFit/>
-          </a:bodyPr>
-          <a:lstStyle/>
-          <a:p>
-            <a:pPr>
-              <a:spcAft>
-                <a:spcPts val="800"/>
-              </a:spcAft>
-            </a:pPr>
-            <a:r>
-              <a:rPr sz="1000" b="0" i="0">
-                <a:solidFill>
-                  <a:srgbClr val="475569"/>
-                </a:solidFill>
-                <a:latin typeface="Segoe UI"/>
-              </a:rPr>
-              <a:t>Omnichannel Retail Analytics Assistant  ·  CMU Capstone  ·  8-min</a:t>
-            </a:r>
-          </a:p>
-        </p:txBody>
-      </p:sp>
-      <p:sp>
-        <p:nvSpPr>
-          <p:cNvPr id="7" name="TextBox 6"/>
-          <p:cNvSpPr txBox="1"/>
-          <p:nvPr/>
-        </p:nvSpPr>
-        <p:spPr>
-          <a:xfrm>
-            <a:off x="11430000" y="6400800"/>
-            <a:ext cx="548640" cy="365760"/>
-          </a:xfrm>
-          <a:prstGeom prst="rect">
-            <a:avLst/>
-          </a:prstGeom>
-          <a:noFill/>
-        </p:spPr>
-        <p:txBody>
-          <a:bodyPr wrap="square">
-            <a:spAutoFit/>
-          </a:bodyPr>
-          <a:lstStyle/>
-          <a:p>
-            <a:pPr>
-              <a:spcAft>
-                <a:spcPts val="800"/>
-              </a:spcAft>
-            </a:pPr>
-            <a:r>
-              <a:rPr sz="1100" b="1" i="0">
-                <a:solidFill>
-                  <a:srgbClr val="475569"/>
-                </a:solidFill>
-                <a:latin typeface="Segoe UI"/>
-              </a:rPr>
-              <a:t>4</a:t>
-            </a:r>
-          </a:p>
-        </p:txBody>
-      </p:sp>
+      </p:pic>
     </p:spTree>
   </p:cSld>
   <p:clrMapOvr>
@@ -5038,293 +3960,30 @@
         <p:nvPr/>
       </p:nvGrpSpPr>
       <p:grpSpPr/>
-      <p:sp>
-        <p:nvSpPr>
-          <p:cNvPr id="2" name="Rectangle 1"/>
-          <p:cNvSpPr/>
+      <p:pic>
+        <p:nvPicPr>
+          <p:cNvPr id="2" name="Picture 1" descr="s5.png"/>
+          <p:cNvPicPr>
+            <a:picLocks noChangeAspect="1"/>
+          </p:cNvPicPr>
           <p:nvPr/>
-        </p:nvSpPr>
+        </p:nvPicPr>
+        <p:blipFill>
+          <a:blip r:embed="rId2"/>
+          <a:stretch>
+            <a:fillRect/>
+          </a:stretch>
+        </p:blipFill>
         <p:spPr>
           <a:xfrm>
             <a:off x="0" y="0"/>
-            <a:ext cx="12191695" cy="164592"/>
+            <a:ext cx="12191695" cy="6858000"/>
           </a:xfrm>
           <a:prstGeom prst="rect">
             <a:avLst/>
           </a:prstGeom>
-          <a:solidFill>
-            <a:srgbClr val="C41230"/>
-          </a:solidFill>
-          <a:ln>
-            <a:noFill/>
-          </a:ln>
-          <a:effectLst/>
         </p:spPr>
-        <p:style>
-          <a:lnRef idx="1">
-            <a:schemeClr val="accent1"/>
-          </a:lnRef>
-          <a:fillRef idx="3">
-            <a:schemeClr val="accent1"/>
-          </a:fillRef>
-          <a:effectRef idx="2">
-            <a:schemeClr val="accent1"/>
-          </a:effectRef>
-          <a:fontRef idx="minor">
-            <a:schemeClr val="lt1"/>
-          </a:fontRef>
-        </p:style>
-        <p:txBody>
-          <a:bodyPr rtlCol="0" anchor="ctr"/>
-          <a:lstStyle/>
-          <a:p>
-            <a:pPr algn="ctr"/>
-          </a:p>
-        </p:txBody>
-      </p:sp>
-      <p:sp>
-        <p:nvSpPr>
-          <p:cNvPr id="3" name="TextBox 2"/>
-          <p:cNvSpPr txBox="1"/>
-          <p:nvPr/>
-        </p:nvSpPr>
-        <p:spPr>
-          <a:xfrm>
-            <a:off x="548640" y="384048"/>
-            <a:ext cx="11064240" cy="365760"/>
-          </a:xfrm>
-          <a:prstGeom prst="rect">
-            <a:avLst/>
-          </a:prstGeom>
-          <a:noFill/>
-        </p:spPr>
-        <p:txBody>
-          <a:bodyPr wrap="square">
-            <a:spAutoFit/>
-          </a:bodyPr>
-          <a:lstStyle/>
-          <a:p>
-            <a:pPr>
-              <a:spcAft>
-                <a:spcPts val="200"/>
-              </a:spcAft>
-            </a:pPr>
-            <a:r>
-              <a:rPr sz="1300" b="1" i="0">
-                <a:solidFill>
-                  <a:srgbClr val="C41230"/>
-                </a:solidFill>
-                <a:latin typeface="Segoe UI"/>
-              </a:rPr>
-              <a:t>CLOSE</a:t>
-            </a:r>
-          </a:p>
-        </p:txBody>
-      </p:sp>
-      <p:sp>
-        <p:nvSpPr>
-          <p:cNvPr id="4" name="TextBox 3"/>
-          <p:cNvSpPr txBox="1"/>
-          <p:nvPr/>
-        </p:nvSpPr>
-        <p:spPr>
-          <a:xfrm>
-            <a:off x="548640" y="749808"/>
-            <a:ext cx="11064240" cy="914400"/>
-          </a:xfrm>
-          <a:prstGeom prst="rect">
-            <a:avLst/>
-          </a:prstGeom>
-          <a:noFill/>
-        </p:spPr>
-        <p:txBody>
-          <a:bodyPr wrap="square">
-            <a:spAutoFit/>
-          </a:bodyPr>
-          <a:lstStyle/>
-          <a:p>
-            <a:pPr>
-              <a:spcAft>
-                <a:spcPts val="0"/>
-              </a:spcAft>
-            </a:pPr>
-            <a:r>
-              <a:rPr sz="2900" b="1" i="0">
-                <a:solidFill>
-                  <a:srgbClr val="1E293B"/>
-                </a:solidFill>
-                <a:latin typeface="Segoe UI"/>
-              </a:rPr>
-              <a:t>From a 2-day fire drill to a governed answer in seconds</a:t>
-            </a:r>
-          </a:p>
-        </p:txBody>
-      </p:sp>
-      <p:sp>
-        <p:nvSpPr>
-          <p:cNvPr id="5" name="TextBox 4"/>
-          <p:cNvSpPr txBox="1"/>
-          <p:nvPr/>
-        </p:nvSpPr>
-        <p:spPr>
-          <a:xfrm>
-            <a:off x="640080" y="1737360"/>
-            <a:ext cx="10881360" cy="4480560"/>
-          </a:xfrm>
-          <a:prstGeom prst="rect">
-            <a:avLst/>
-          </a:prstGeom>
-          <a:noFill/>
-        </p:spPr>
-        <p:txBody>
-          <a:bodyPr wrap="square">
-            <a:spAutoFit/>
-          </a:bodyPr>
-          <a:lstStyle/>
-          <a:p>
-            <a:pPr>
-              <a:spcAft>
-                <a:spcPts val="900"/>
-              </a:spcAft>
-            </a:pPr>
-            <a:r>
-              <a:rPr sz="1800" b="0" i="0">
-                <a:solidFill>
-                  <a:srgbClr val="1E293B"/>
-                </a:solidFill>
-                <a:latin typeface="Segoe UI"/>
-              </a:rPr>
-              <a:t>•  Fast AND trustworthy — the tension I opened with, resolved.</a:t>
-            </a:r>
-          </a:p>
-          <a:p>
-            <a:pPr>
-              <a:spcAft>
-                <a:spcPts val="900"/>
-              </a:spcAft>
-            </a:pPr>
-            <a:r>
-              <a:rPr sz="1800" b="1" i="0">
-                <a:solidFill>
-                  <a:srgbClr val="1E293B"/>
-                </a:solidFill>
-                <a:latin typeface="Segoe UI"/>
-              </a:rPr>
-              <a:t>•  The lesson: the hard part of agentic AI isn't generating answers — it's governing, evaluating, and observing them.</a:t>
-            </a:r>
-          </a:p>
-          <a:p>
-            <a:pPr>
-              <a:spcAft>
-                <a:spcPts val="900"/>
-              </a:spcAft>
-            </a:pPr>
-            <a:r>
-              <a:rPr sz="1800" b="0" i="0">
-                <a:solidFill>
-                  <a:srgbClr val="1E293B"/>
-                </a:solidFill>
-                <a:latin typeface="Segoe UI"/>
-              </a:rPr>
-              <a:t>•  Proven &amp; reproducible: seeded ground truth, 15 validation checks, 25 tests, 0 UI exceptions — and 100% free/local.</a:t>
-            </a:r>
-          </a:p>
-          <a:p>
-            <a:pPr>
-              <a:spcAft>
-                <a:spcPts val="900"/>
-              </a:spcAft>
-            </a:pPr>
-            <a:r>
-              <a:rPr sz="1800" b="0" i="0">
-                <a:solidFill>
-                  <a:srgbClr val="1E293B"/>
-                </a:solidFill>
-                <a:latin typeface="Segoe UI"/>
-              </a:rPr>
-              <a:t>•  Extends to production: swap synthetic data for real tables behind the same catalog. Thank you — questions?</a:t>
-            </a:r>
-          </a:p>
-        </p:txBody>
-      </p:sp>
-      <p:sp>
-        <p:nvSpPr>
-          <p:cNvPr id="6" name="TextBox 5"/>
-          <p:cNvSpPr txBox="1"/>
-          <p:nvPr/>
-        </p:nvSpPr>
-        <p:spPr>
-          <a:xfrm>
-            <a:off x="548640" y="6400800"/>
-            <a:ext cx="10607040" cy="365760"/>
-          </a:xfrm>
-          <a:prstGeom prst="rect">
-            <a:avLst/>
-          </a:prstGeom>
-          <a:noFill/>
-        </p:spPr>
-        <p:txBody>
-          <a:bodyPr wrap="square">
-            <a:spAutoFit/>
-          </a:bodyPr>
-          <a:lstStyle/>
-          <a:p>
-            <a:pPr>
-              <a:spcAft>
-                <a:spcPts val="800"/>
-              </a:spcAft>
-            </a:pPr>
-            <a:r>
-              <a:rPr sz="1000" b="0" i="0">
-                <a:solidFill>
-                  <a:srgbClr val="475569"/>
-                </a:solidFill>
-                <a:latin typeface="Segoe UI"/>
-              </a:rPr>
-              <a:t>Omnichannel Retail Analytics Assistant  ·  CMU Capstone  ·  8-min</a:t>
-            </a:r>
-          </a:p>
-        </p:txBody>
-      </p:sp>
-      <p:sp>
-        <p:nvSpPr>
-          <p:cNvPr id="7" name="TextBox 6"/>
-          <p:cNvSpPr txBox="1"/>
-          <p:nvPr/>
-        </p:nvSpPr>
-        <p:spPr>
-          <a:xfrm>
-            <a:off x="11430000" y="6400800"/>
-            <a:ext cx="548640" cy="365760"/>
-          </a:xfrm>
-          <a:prstGeom prst="rect">
-            <a:avLst/>
-          </a:prstGeom>
-          <a:noFill/>
-        </p:spPr>
-        <p:txBody>
-          <a:bodyPr wrap="square">
-            <a:spAutoFit/>
-          </a:bodyPr>
-          <a:lstStyle/>
-          <a:p>
-            <a:pPr>
-              <a:spcAft>
-                <a:spcPts val="800"/>
-              </a:spcAft>
-            </a:pPr>
-            <a:r>
-              <a:rPr sz="1100" b="1" i="0">
-                <a:solidFill>
-                  <a:srgbClr val="475569"/>
-                </a:solidFill>
-                <a:latin typeface="Segoe UI"/>
-              </a:rPr>
-              <a:t>5</a:t>
-            </a:r>
-          </a:p>
-        </p:txBody>
-      </p:sp>
+      </p:pic>
     </p:spTree>
   </p:cSld>
   <p:clrMapOvr>

</xml_diff>